<commit_message>
Refine deck: add one-liner descriptions to outcome pointers, remove CTA/partnership language
Co-authored-by: Aankitgupta <Aankitgupta@users.noreply.github.com>
</commit_message>
<xml_diff>
--- a/presentations/dental-intelligence-pitch.pptx
+++ b/presentations/dental-intelligence-pitch.pptx
@@ -1452,7 +1452,7 @@
                 <a:ea typeface="Calibri" pitchFamily="34" charset="-122"/>
                 <a:cs typeface="Calibri" pitchFamily="34" charset="-120"/>
               </a:rPr>
-              <a:t>Provider output varies widely across locations</a:t>
+              <a:t>Provider output swings widely from location to location</a:t>
             </a:r>
             <a:endParaRPr lang="en-US" sz="1050" dirty="0"/>
           </a:p>
@@ -1611,7 +1611,7 @@
                 <a:ea typeface="Calibri" pitchFamily="34" charset="-122"/>
                 <a:cs typeface="Calibri" pitchFamily="34" charset="-120"/>
               </a:rPr>
-              <a:t>Hidden gaps in hygiene utilization</a:t>
+              <a:t>Unused hygiene capacity and open chairs go unnoticed</a:t>
             </a:r>
             <a:endParaRPr lang="en-US" sz="1050" dirty="0"/>
           </a:p>
@@ -1770,7 +1770,7 @@
                 <a:ea typeface="Calibri" pitchFamily="34" charset="-122"/>
                 <a:cs typeface="Calibri" pitchFamily="34" charset="-120"/>
               </a:rPr>
-              <a:t>Hard to see which procedures drive revenue</a:t>
+              <a:t>Hard to see which procedures actually drive revenue</a:t>
             </a:r>
             <a:endParaRPr lang="en-US" sz="1050" dirty="0"/>
           </a:p>
@@ -1929,7 +1929,7 @@
                 <a:ea typeface="Calibri" pitchFamily="34" charset="-122"/>
                 <a:cs typeface="Calibri" pitchFamily="34" charset="-120"/>
               </a:rPr>
-              <a:t>Adjustments quietly erode collections</a:t>
+              <a:t>Adjustments and write-offs quietly erode collections</a:t>
             </a:r>
             <a:endParaRPr lang="en-US" sz="1050" dirty="0"/>
           </a:p>
@@ -2088,7 +2088,7 @@
                 <a:ea typeface="Calibri" pitchFamily="34" charset="-122"/>
                 <a:cs typeface="Calibri" pitchFamily="34" charset="-120"/>
               </a:rPr>
-              <a:t>No proactive view of retention</a:t>
+              <a:t>No early view of patients lapsing from preventive care</a:t>
             </a:r>
             <a:endParaRPr lang="en-US" sz="1050" dirty="0"/>
           </a:p>
@@ -2247,7 +2247,7 @@
                 <a:ea typeface="Calibri" pitchFamily="34" charset="-122"/>
                 <a:cs typeface="Calibri" pitchFamily="34" charset="-120"/>
               </a:rPr>
-              <a:t>Issues surface too late to act</a:t>
+              <a:t>Performance issues surface weeks too late to act on</a:t>
             </a:r>
             <a:endParaRPr lang="en-US" sz="1050" dirty="0"/>
           </a:p>
@@ -2419,7 +2419,7 @@
                 <a:ea typeface="Calibri" pitchFamily="34" charset="-122"/>
                 <a:cs typeface="Calibri" pitchFamily="34" charset="-120"/>
               </a:rPr>
-              <a:t>We unify clinical, operational, financial, and patient data into six integrated intelligence portfolios — turning isolated metrics into connected, organization-wide intelligence.</a:t>
+              <a:t>Six integrated portfolios unify clinical, operational, financial, and patient data — turning isolated metrics into connected, organization-wide intelligence.</a:t>
             </a:r>
             <a:endParaRPr lang="en-US" sz="1400" dirty="0"/>
           </a:p>
@@ -2585,7 +2585,7 @@
                 <a:ea typeface="Calibri" pitchFamily="34" charset="-122"/>
                 <a:cs typeface="Calibri" pitchFamily="34" charset="-120"/>
               </a:rPr>
-              <a:t>Real-time utilization, scheduling efficiency &amp; forecasting</a:t>
+              <a:t>Real-time hygiene utilization, scheduling efficiency, and forecasting</a:t>
             </a:r>
             <a:endParaRPr lang="en-US" sz="1150" dirty="0"/>
           </a:p>
@@ -2751,7 +2751,7 @@
                 <a:ea typeface="Calibri" pitchFamily="34" charset="-122"/>
                 <a:cs typeface="Calibri" pitchFamily="34" charset="-120"/>
               </a:rPr>
-              <a:t>Links patient flow, clinical hours &amp; true production drivers</a:t>
+              <a:t>Connects patient flow, clinical hours, and true production drivers</a:t>
             </a:r>
             <a:endParaRPr lang="en-US" sz="1150" dirty="0"/>
           </a:p>
@@ -2917,7 +2917,7 @@
                 <a:ea typeface="Calibri" pitchFamily="34" charset="-122"/>
                 <a:cs typeface="Calibri" pitchFamily="34" charset="-120"/>
               </a:rPr>
-              <a:t>Treatment mix &amp; clinical trends by provider and location</a:t>
+              <a:t>Treatment mix and procedure trends by provider and location</a:t>
             </a:r>
             <a:endParaRPr lang="en-US" sz="1150" dirty="0"/>
           </a:p>
@@ -3083,7 +3083,7 @@
                 <a:ea typeface="Calibri" pitchFamily="34" charset="-122"/>
                 <a:cs typeface="Calibri" pitchFamily="34" charset="-120"/>
               </a:rPr>
-              <a:t>Transparency into production &amp; collection adjustments</a:t>
+              <a:t>Transparency into production and collection adjustment behavior</a:t>
             </a:r>
             <a:endParaRPr lang="en-US" sz="1150" dirty="0"/>
           </a:p>
@@ -3249,7 +3249,7 @@
                 <a:ea typeface="Calibri" pitchFamily="34" charset="-122"/>
                 <a:cs typeface="Calibri" pitchFamily="34" charset="-120"/>
               </a:rPr>
-              <a:t>Preventive engagement &amp; long-term patient retention</a:t>
+              <a:t>Preventive engagement tracking and long-term patient retention</a:t>
             </a:r>
             <a:endParaRPr lang="en-US" sz="1150" dirty="0"/>
           </a:p>
@@ -3415,7 +3415,7 @@
                 <a:ea typeface="Calibri" pitchFamily="34" charset="-122"/>
                 <a:cs typeface="Calibri" pitchFamily="34" charset="-120"/>
               </a:rPr>
-              <a:t>Daily, weekly &amp; MTD visibility for proactive control</a:t>
+              <a:t>Daily, weekly, and month-to-date visibility for proactive control</a:t>
             </a:r>
             <a:endParaRPr lang="en-US" sz="1150" dirty="0"/>
           </a:p>
@@ -3506,7 +3506,7 @@
                 <a:ea typeface="Calibri" pitchFamily="34" charset="-122"/>
                 <a:cs typeface="Calibri" pitchFamily="34" charset="-120"/>
               </a:rPr>
-              <a:t>WHAT YOUR BUSINESS GAINS</a:t>
+              <a:t>BUSINESS IMPACT &amp; STRATEGIC VALUE</a:t>
             </a:r>
             <a:endParaRPr lang="en-US" sz="1300" dirty="0"/>
           </a:p>
@@ -3890,7 +3890,7 @@
                 <a:ea typeface="Calibri" pitchFamily="34" charset="-122"/>
                 <a:cs typeface="Calibri" pitchFamily="34" charset="-120"/>
               </a:rPr>
-              <a:t>Connected dashboards</a:t>
+              <a:t>Connected performance dashboards</a:t>
             </a:r>
             <a:endParaRPr lang="en-US" sz="1050" dirty="0"/>
           </a:p>
@@ -4019,12 +4019,12 @@
         </p:nvSpPr>
         <p:spPr>
           <a:xfrm>
-            <a:off x="640080" y="2907792"/>
-            <a:ext cx="2521458" cy="1828800"/>
+            <a:off x="640080" y="2852928"/>
+            <a:ext cx="2521458" cy="2212848"/>
           </a:xfrm>
           <a:prstGeom prst="roundRect">
             <a:avLst>
-              <a:gd name="adj" fmla="val 4000"/>
+              <a:gd name="adj" fmla="val 3306"/>
             </a:avLst>
           </a:prstGeom>
           <a:solidFill>
@@ -4053,8 +4053,8 @@
         </p:nvSpPr>
         <p:spPr>
           <a:xfrm>
-            <a:off x="896112" y="3145536"/>
-            <a:ext cx="512064" cy="512064"/>
+            <a:off x="914400" y="3127248"/>
+            <a:ext cx="530352" cy="530352"/>
           </a:xfrm>
           <a:prstGeom prst="ellipse">
             <a:avLst/>
@@ -4088,8 +4088,8 @@
         </p:blipFill>
         <p:spPr>
           <a:xfrm>
-            <a:off x="1019007" y="3268431"/>
-            <a:ext cx="266273" cy="266273"/>
+            <a:off x="1041684" y="3254532"/>
+            <a:ext cx="275783" cy="275783"/>
           </a:xfrm>
           <a:prstGeom prst="rect">
             <a:avLst/>
@@ -4104,8 +4104,8 @@
         </p:nvSpPr>
         <p:spPr>
           <a:xfrm>
-            <a:off x="1517904" y="3108960"/>
-            <a:ext cx="1515618" cy="548640"/>
+            <a:off x="1554480" y="3127248"/>
+            <a:ext cx="1442466" cy="530352"/>
           </a:xfrm>
           <a:prstGeom prst="rect">
             <a:avLst/>
@@ -4143,8 +4143,8 @@
         </p:nvSpPr>
         <p:spPr>
           <a:xfrm>
-            <a:off x="914400" y="3776472"/>
-            <a:ext cx="2018538" cy="868680"/>
+            <a:off x="914400" y="3822192"/>
+            <a:ext cx="1991106" cy="1097280"/>
           </a:xfrm>
           <a:prstGeom prst="rect">
             <a:avLst/>
@@ -4156,12 +4156,11 @@
           <a:bodyPr wrap="square" lIns="0" tIns="0" rIns="0" bIns="0" rtlCol="0" anchor="ctr"/>
           <a:lstStyle/>
           <a:p>
-            <a:pPr algn="l" marL="342900" indent="-342900">
-              <a:spcAft>
-                <a:spcPts val="500"/>
-              </a:spcAft>
-              <a:buSzPct val="100000"/>
-              <a:buChar char="•"/>
+            <a:pPr algn="l" indent="0" marL="0">
+              <a:lnSpc>
+                <a:spcPct val="106000"/>
+              </a:lnSpc>
+              <a:buNone/>
             </a:pPr>
             <a:r>
               <a:rPr lang="en-US" sz="1100" dirty="0">
@@ -4172,31 +4171,10 @@
                 <a:ea typeface="Calibri" pitchFamily="34" charset="-122"/>
                 <a:cs typeface="Calibri" pitchFamily="34" charset="-120"/>
               </a:rPr>
-              <a:t>Optimized chair utilization</a:t>
+              <a:t>Higher chair utilization, optimized schedules, and faster response to operational disruptions.</a:t>
             </a:r>
             <a:endParaRPr lang="en-US" sz="1100" dirty="0"/>
           </a:p>
-          <a:p>
-            <a:pPr algn="l" marL="342900" indent="-342900">
-              <a:spcAft>
-                <a:spcPts val="500"/>
-              </a:spcAft>
-              <a:buSzPct val="100000"/>
-              <a:buChar char="•"/>
-            </a:pPr>
-            <a:r>
-              <a:rPr lang="en-US" sz="1100" dirty="0">
-                <a:solidFill>
-                  <a:srgbClr val="5E777C"/>
-                </a:solidFill>
-                <a:latin typeface="Calibri" pitchFamily="34" charset="0"/>
-                <a:ea typeface="Calibri" pitchFamily="34" charset="-122"/>
-                <a:cs typeface="Calibri" pitchFamily="34" charset="-120"/>
-              </a:rPr>
-              <a:t>Faster disruption response</a:t>
-            </a:r>
-            <a:endParaRPr lang="en-US" sz="1100" dirty="0"/>
-          </a:p>
         </p:txBody>
       </p:sp>
       <p:sp>
@@ -4207,12 +4185,12 @@
         </p:nvSpPr>
         <p:spPr>
           <a:xfrm>
-            <a:off x="3435858" y="2907792"/>
-            <a:ext cx="2521458" cy="1828800"/>
+            <a:off x="3435858" y="2852928"/>
+            <a:ext cx="2521458" cy="2212848"/>
           </a:xfrm>
           <a:prstGeom prst="roundRect">
             <a:avLst>
-              <a:gd name="adj" fmla="val 4000"/>
+              <a:gd name="adj" fmla="val 3306"/>
             </a:avLst>
           </a:prstGeom>
           <a:solidFill>
@@ -4241,8 +4219,8 @@
         </p:nvSpPr>
         <p:spPr>
           <a:xfrm>
-            <a:off x="3691890" y="3145536"/>
-            <a:ext cx="512064" cy="512064"/>
+            <a:off x="3710178" y="3127248"/>
+            <a:ext cx="530352" cy="530352"/>
           </a:xfrm>
           <a:prstGeom prst="ellipse">
             <a:avLst/>
@@ -4276,8 +4254,8 @@
         </p:blipFill>
         <p:spPr>
           <a:xfrm>
-            <a:off x="3814785" y="3268431"/>
-            <a:ext cx="266273" cy="266273"/>
+            <a:off x="3837462" y="3254532"/>
+            <a:ext cx="275783" cy="275783"/>
           </a:xfrm>
           <a:prstGeom prst="rect">
             <a:avLst/>
@@ -4292,8 +4270,8 @@
         </p:nvSpPr>
         <p:spPr>
           <a:xfrm>
-            <a:off x="4313682" y="3108960"/>
-            <a:ext cx="1515618" cy="548640"/>
+            <a:off x="4350258" y="3127248"/>
+            <a:ext cx="1442466" cy="530352"/>
           </a:xfrm>
           <a:prstGeom prst="rect">
             <a:avLst/>
@@ -4331,8 +4309,8 @@
         </p:nvSpPr>
         <p:spPr>
           <a:xfrm>
-            <a:off x="3710178" y="3776472"/>
-            <a:ext cx="2018538" cy="868680"/>
+            <a:off x="3710178" y="3822192"/>
+            <a:ext cx="1991106" cy="1097280"/>
           </a:xfrm>
           <a:prstGeom prst="rect">
             <a:avLst/>
@@ -4344,12 +4322,11 @@
           <a:bodyPr wrap="square" lIns="0" tIns="0" rIns="0" bIns="0" rtlCol="0" anchor="ctr"/>
           <a:lstStyle/>
           <a:p>
-            <a:pPr algn="l" marL="342900" indent="-342900">
-              <a:spcAft>
-                <a:spcPts val="500"/>
-              </a:spcAft>
-              <a:buSzPct val="100000"/>
-              <a:buChar char="•"/>
+            <a:pPr algn="l" indent="0" marL="0">
+              <a:lnSpc>
+                <a:spcPct val="106000"/>
+              </a:lnSpc>
+              <a:buNone/>
             </a:pPr>
             <a:r>
               <a:rPr lang="en-US" sz="1100" dirty="0">
@@ -4360,31 +4337,10 @@
                 <a:ea typeface="Calibri" pitchFamily="34" charset="-122"/>
                 <a:cs typeface="Calibri" pitchFamily="34" charset="-120"/>
               </a:rPr>
-              <a:t>Standardized benchmarking</a:t>
+              <a:t>Standardized benchmarking that reduces provider variability and clarifies efficiency vs. workload.</a:t>
             </a:r>
             <a:endParaRPr lang="en-US" sz="1100" dirty="0"/>
           </a:p>
-          <a:p>
-            <a:pPr algn="l" marL="342900" indent="-342900">
-              <a:spcAft>
-                <a:spcPts val="500"/>
-              </a:spcAft>
-              <a:buSzPct val="100000"/>
-              <a:buChar char="•"/>
-            </a:pPr>
-            <a:r>
-              <a:rPr lang="en-US" sz="1100" dirty="0">
-                <a:solidFill>
-                  <a:srgbClr val="5E777C"/>
-                </a:solidFill>
-                <a:latin typeface="Calibri" pitchFamily="34" charset="0"/>
-                <a:ea typeface="Calibri" pitchFamily="34" charset="-122"/>
-                <a:cs typeface="Calibri" pitchFamily="34" charset="-120"/>
-              </a:rPr>
-              <a:t>Less performance variability</a:t>
-            </a:r>
-            <a:endParaRPr lang="en-US" sz="1100" dirty="0"/>
-          </a:p>
         </p:txBody>
       </p:sp>
       <p:sp>
@@ -4395,12 +4351,12 @@
         </p:nvSpPr>
         <p:spPr>
           <a:xfrm>
-            <a:off x="6231636" y="2907792"/>
-            <a:ext cx="2521458" cy="1828800"/>
+            <a:off x="6231636" y="2852928"/>
+            <a:ext cx="2521458" cy="2212848"/>
           </a:xfrm>
           <a:prstGeom prst="roundRect">
             <a:avLst>
-              <a:gd name="adj" fmla="val 4000"/>
+              <a:gd name="adj" fmla="val 3306"/>
             </a:avLst>
           </a:prstGeom>
           <a:solidFill>
@@ -4429,8 +4385,8 @@
         </p:nvSpPr>
         <p:spPr>
           <a:xfrm>
-            <a:off x="6487668" y="3145536"/>
-            <a:ext cx="512064" cy="512064"/>
+            <a:off x="6505956" y="3127248"/>
+            <a:ext cx="530352" cy="530352"/>
           </a:xfrm>
           <a:prstGeom prst="ellipse">
             <a:avLst/>
@@ -4464,8 +4420,8 @@
         </p:blipFill>
         <p:spPr>
           <a:xfrm>
-            <a:off x="6610563" y="3268431"/>
-            <a:ext cx="266273" cy="266273"/>
+            <a:off x="6633240" y="3254532"/>
+            <a:ext cx="275783" cy="275783"/>
           </a:xfrm>
           <a:prstGeom prst="rect">
             <a:avLst/>
@@ -4480,8 +4436,8 @@
         </p:nvSpPr>
         <p:spPr>
           <a:xfrm>
-            <a:off x="7109460" y="3108960"/>
-            <a:ext cx="1515618" cy="548640"/>
+            <a:off x="7146036" y="3127248"/>
+            <a:ext cx="1442466" cy="530352"/>
           </a:xfrm>
           <a:prstGeom prst="rect">
             <a:avLst/>
@@ -4519,8 +4475,8 @@
         </p:nvSpPr>
         <p:spPr>
           <a:xfrm>
-            <a:off x="6505956" y="3776472"/>
-            <a:ext cx="2018538" cy="868680"/>
+            <a:off x="6505956" y="3822192"/>
+            <a:ext cx="1991106" cy="1097280"/>
           </a:xfrm>
           <a:prstGeom prst="rect">
             <a:avLst/>
@@ -4532,12 +4488,11 @@
           <a:bodyPr wrap="square" lIns="0" tIns="0" rIns="0" bIns="0" rtlCol="0" anchor="ctr"/>
           <a:lstStyle/>
           <a:p>
-            <a:pPr algn="l" marL="342900" indent="-342900">
-              <a:spcAft>
-                <a:spcPts val="500"/>
-              </a:spcAft>
-              <a:buSzPct val="100000"/>
-              <a:buChar char="•"/>
+            <a:pPr algn="l" indent="0" marL="0">
+              <a:lnSpc>
+                <a:spcPct val="106000"/>
+              </a:lnSpc>
+              <a:buNone/>
             </a:pPr>
             <a:r>
               <a:rPr lang="en-US" sz="1100" dirty="0">
@@ -4548,31 +4503,10 @@
                 <a:ea typeface="Calibri" pitchFamily="34" charset="-122"/>
                 <a:cs typeface="Calibri" pitchFamily="34" charset="-120"/>
               </a:rPr>
-              <a:t>Control over adjustments</a:t>
+              <a:t>Tighter control of adjustment trends with full transparency into revenue-impacting activity.</a:t>
             </a:r>
             <a:endParaRPr lang="en-US" sz="1100" dirty="0"/>
           </a:p>
-          <a:p>
-            <a:pPr algn="l" marL="342900" indent="-342900">
-              <a:spcAft>
-                <a:spcPts val="500"/>
-              </a:spcAft>
-              <a:buSzPct val="100000"/>
-              <a:buChar char="•"/>
-            </a:pPr>
-            <a:r>
-              <a:rPr lang="en-US" sz="1100" dirty="0">
-                <a:solidFill>
-                  <a:srgbClr val="5E777C"/>
-                </a:solidFill>
-                <a:latin typeface="Calibri" pitchFamily="34" charset="0"/>
-                <a:ea typeface="Calibri" pitchFamily="34" charset="-122"/>
-                <a:cs typeface="Calibri" pitchFamily="34" charset="-120"/>
-              </a:rPr>
-              <a:t>Revenue transparency</a:t>
-            </a:r>
-            <a:endParaRPr lang="en-US" sz="1100" dirty="0"/>
-          </a:p>
         </p:txBody>
       </p:sp>
       <p:sp>
@@ -4583,12 +4517,12 @@
         </p:nvSpPr>
         <p:spPr>
           <a:xfrm>
-            <a:off x="9027414" y="2907792"/>
-            <a:ext cx="2521458" cy="1828800"/>
+            <a:off x="9027414" y="2852928"/>
+            <a:ext cx="2521458" cy="2212848"/>
           </a:xfrm>
           <a:prstGeom prst="roundRect">
             <a:avLst>
-              <a:gd name="adj" fmla="val 4000"/>
+              <a:gd name="adj" fmla="val 3306"/>
             </a:avLst>
           </a:prstGeom>
           <a:solidFill>
@@ -4617,8 +4551,8 @@
         </p:nvSpPr>
         <p:spPr>
           <a:xfrm>
-            <a:off x="9283446" y="3145536"/>
-            <a:ext cx="512064" cy="512064"/>
+            <a:off x="9301734" y="3127248"/>
+            <a:ext cx="530352" cy="530352"/>
           </a:xfrm>
           <a:prstGeom prst="ellipse">
             <a:avLst/>
@@ -4652,8 +4586,8 @@
         </p:blipFill>
         <p:spPr>
           <a:xfrm>
-            <a:off x="9406341" y="3268431"/>
-            <a:ext cx="266273" cy="266273"/>
+            <a:off x="9429018" y="3254532"/>
+            <a:ext cx="275783" cy="275783"/>
           </a:xfrm>
           <a:prstGeom prst="rect">
             <a:avLst/>
@@ -4668,8 +4602,8 @@
         </p:nvSpPr>
         <p:spPr>
           <a:xfrm>
-            <a:off x="9905238" y="3108960"/>
-            <a:ext cx="1515618" cy="548640"/>
+            <a:off x="9941814" y="3127248"/>
+            <a:ext cx="1442466" cy="530352"/>
           </a:xfrm>
           <a:prstGeom prst="rect">
             <a:avLst/>
@@ -4707,8 +4641,8 @@
         </p:nvSpPr>
         <p:spPr>
           <a:xfrm>
-            <a:off x="9301734" y="3776472"/>
-            <a:ext cx="2018538" cy="868680"/>
+            <a:off x="9301734" y="3822192"/>
+            <a:ext cx="1991106" cy="1097280"/>
           </a:xfrm>
           <a:prstGeom prst="rect">
             <a:avLst/>
@@ -4720,12 +4654,11 @@
           <a:bodyPr wrap="square" lIns="0" tIns="0" rIns="0" bIns="0" rtlCol="0" anchor="ctr"/>
           <a:lstStyle/>
           <a:p>
-            <a:pPr algn="l" marL="342900" indent="-342900">
-              <a:spcAft>
-                <a:spcPts val="500"/>
-              </a:spcAft>
-              <a:buSzPct val="100000"/>
-              <a:buChar char="•"/>
+            <a:pPr algn="l" indent="0" marL="0">
+              <a:lnSpc>
+                <a:spcPct val="106000"/>
+              </a:lnSpc>
+              <a:buNone/>
             </a:pPr>
             <a:r>
               <a:rPr lang="en-US" sz="1100" dirty="0">
@@ -4736,31 +4669,10 @@
                 <a:ea typeface="Calibri" pitchFamily="34" charset="-122"/>
                 <a:cs typeface="Calibri" pitchFamily="34" charset="-120"/>
               </a:rPr>
-              <a:t>Treatment-mix visibility</a:t>
+              <a:t>Visibility into treatment mix, with early signals of declining preventive engagement.</a:t>
             </a:r>
             <a:endParaRPr lang="en-US" sz="1100" dirty="0"/>
           </a:p>
-          <a:p>
-            <a:pPr algn="l" marL="342900" indent="-342900">
-              <a:spcAft>
-                <a:spcPts val="500"/>
-              </a:spcAft>
-              <a:buSzPct val="100000"/>
-              <a:buChar char="•"/>
-            </a:pPr>
-            <a:r>
-              <a:rPr lang="en-US" sz="1100" dirty="0">
-                <a:solidFill>
-                  <a:srgbClr val="5E777C"/>
-                </a:solidFill>
-                <a:latin typeface="Calibri" pitchFamily="34" charset="0"/>
-                <a:ea typeface="Calibri" pitchFamily="34" charset="-122"/>
-                <a:cs typeface="Calibri" pitchFamily="34" charset="-120"/>
-              </a:rPr>
-              <a:t>Early retention signals</a:t>
-            </a:r>
-            <a:endParaRPr lang="en-US" sz="1100" dirty="0"/>
-          </a:p>
         </p:txBody>
       </p:sp>
       <p:sp>
@@ -4771,12 +4683,12 @@
         </p:nvSpPr>
         <p:spPr>
           <a:xfrm>
-            <a:off x="640080" y="5074920"/>
-            <a:ext cx="10908792" cy="1371600"/>
+            <a:off x="640080" y="5321808"/>
+            <a:ext cx="10908792" cy="1115568"/>
           </a:xfrm>
           <a:prstGeom prst="roundRect">
             <a:avLst>
-              <a:gd name="adj" fmla="val 6667"/>
+              <a:gd name="adj" fmla="val 8197"/>
             </a:avLst>
           </a:prstGeom>
           <a:solidFill>
@@ -4800,8 +4712,8 @@
         </p:nvSpPr>
         <p:spPr>
           <a:xfrm>
-            <a:off x="1097280" y="5276088"/>
-            <a:ext cx="6400800" cy="274320"/>
+            <a:off x="640080" y="5486400"/>
+            <a:ext cx="10908792" cy="256032"/>
           </a:xfrm>
           <a:prstGeom prst="rect">
             <a:avLst/>
@@ -4813,7 +4725,7 @@
           <a:bodyPr wrap="square" lIns="0" tIns="0" rIns="0" bIns="0" rtlCol="0" anchor="ctr"/>
           <a:lstStyle/>
           <a:p>
-            <a:pPr algn="l" indent="0" marL="0">
+            <a:pPr algn="ctr" indent="0" marL="0">
               <a:buNone/>
             </a:pPr>
             <a:r>
@@ -4825,7 +4737,7 @@
                 <a:ea typeface="Calibri" pitchFamily="34" charset="-122"/>
                 <a:cs typeface="Calibri" pitchFamily="34" charset="-120"/>
               </a:rPr>
-              <a:t>PARTNER WITH US</a:t>
+              <a:t>THE OUTCOME</a:t>
             </a:r>
             <a:endParaRPr lang="en-US" sz="1200" dirty="0"/>
           </a:p>
@@ -4839,8 +4751,8 @@
         </p:nvSpPr>
         <p:spPr>
           <a:xfrm>
-            <a:off x="1097280" y="5577840"/>
-            <a:ext cx="7315200" cy="731520"/>
+            <a:off x="1371600" y="5779008"/>
+            <a:ext cx="9445752" cy="548640"/>
           </a:xfrm>
           <a:prstGeom prst="rect">
             <a:avLst/>
@@ -4852,14 +4764,14 @@
           <a:bodyPr wrap="square" lIns="0" tIns="0" rIns="0" bIns="0" rtlCol="0" anchor="ctr"/>
           <a:lstStyle/>
           <a:p>
-            <a:pPr algn="l" indent="0" marL="0">
+            <a:pPr algn="ctr" indent="0" marL="0">
               <a:lnSpc>
                 <a:spcPct val="100000"/>
               </a:lnSpc>
               <a:buNone/>
             </a:pPr>
             <a:r>
-              <a:rPr lang="en-US" sz="1800" b="1" dirty="0">
+              <a:rPr lang="en-US" sz="1700" b="1" dirty="0">
                 <a:solidFill>
                   <a:srgbClr val="FFFFFF"/>
                 </a:solidFill>
@@ -4867,70 +4779,9 @@
                 <a:ea typeface="Georgia" pitchFamily="34" charset="-122"/>
                 <a:cs typeface="Georgia" pitchFamily="34" charset="-120"/>
               </a:rPr>
-              <a:t>Turn your operational data into measurable, optimized, predictable performance.</a:t>
-            </a:r>
-            <a:endParaRPr lang="en-US" sz="1800" dirty="0"/>
-          </a:p>
-        </p:txBody>
-      </p:sp>
-      <p:sp>
-        <p:nvSpPr>
-          <p:cNvPr id="40" name="Shape 34"/>
-          <p:cNvSpPr/>
-          <p:nvPr/>
-        </p:nvSpPr>
-        <p:spPr>
-          <a:xfrm>
-            <a:off x="8302752" y="5495544"/>
-            <a:ext cx="2788920" cy="548640"/>
-          </a:xfrm>
-          <a:prstGeom prst="roundRect">
-            <a:avLst>
-              <a:gd name="adj" fmla="val 50000"/>
-            </a:avLst>
-          </a:prstGeom>
-          <a:solidFill>
-            <a:srgbClr val="2DD4BF"/>
-          </a:solidFill>
-          <a:ln/>
-        </p:spPr>
-      </p:sp>
-      <p:sp>
-        <p:nvSpPr>
-          <p:cNvPr id="41" name="Text 35"/>
-          <p:cNvSpPr/>
-          <p:nvPr/>
-        </p:nvSpPr>
-        <p:spPr>
-          <a:xfrm>
-            <a:off x="8302752" y="5495544"/>
-            <a:ext cx="2788920" cy="548640"/>
-          </a:xfrm>
-          <a:prstGeom prst="rect">
-            <a:avLst/>
-          </a:prstGeom>
-          <a:noFill/>
-          <a:ln/>
-        </p:spPr>
-        <p:txBody>
-          <a:bodyPr wrap="square" lIns="0" tIns="0" rIns="0" bIns="0" rtlCol="0" anchor="ctr"/>
-          <a:lstStyle/>
-          <a:p>
-            <a:pPr algn="ctr" indent="0" marL="0">
-              <a:buNone/>
-            </a:pPr>
-            <a:r>
-              <a:rPr lang="en-US" sz="1300" b="1" dirty="0">
-                <a:solidFill>
-                  <a:srgbClr val="0A2A33"/>
-                </a:solidFill>
-                <a:latin typeface="Calibri" pitchFamily="34" charset="0"/>
-                <a:ea typeface="Calibri" pitchFamily="34" charset="-122"/>
-                <a:cs typeface="Calibri" pitchFamily="34" charset="-120"/>
-              </a:rPr>
-              <a:t>Book a discovery session  →</a:t>
-            </a:r>
-            <a:endParaRPr lang="en-US" sz="1300" dirty="0"/>
+              <a:t>A scalable operational intelligence framework that makes dental operations measurable, optimized, and predictable.</a:t>
+            </a:r>
+            <a:endParaRPr lang="en-US" sz="1700" dirty="0"/>
           </a:p>
         </p:txBody>
       </p:sp>

</xml_diff>

<commit_message>
Rework deck with Lumenore/DSO messaging; Calibri-only + LAYOUT_WIDE to fix viewer distortion
Co-authored-by: Aankitgupta <Aankitgupta@users.noreply.github.com>
</commit_message>
<xml_diff>
--- a/presentations/dental-intelligence-pitch.pptx
+++ b/presentations/dental-intelligence-pitch.pptx
@@ -12,8 +12,8 @@
   <p:notesMasterIdLst>
     <p:notesMasterId r:id="rId5"/>
   </p:notesMasterIdLst>
-  <p:sldSz cx="12188952" cy="6858000"/>
-  <p:notesSz cx="6858000" cy="12188952"/>
+  <p:sldSz cx="12192000" cy="6858000"/>
+  <p:notesSz cx="6858000" cy="12192000"/>
   <p:defaultTextStyle>
     <a:lvl1pPr marL="0" algn="l" defTabSz="914400" rtl="0" eaLnBrk="1" latinLnBrk="0" hangingPunct="1">
       <a:defRPr sz="1800" kern="1200">
@@ -1061,7 +1061,7 @@
         </p:nvSpPr>
         <p:spPr>
           <a:xfrm>
-            <a:off x="9692640" y="-1737360"/>
+            <a:off x="9601200" y="-1737360"/>
             <a:ext cx="4206240" cy="4206240"/>
           </a:xfrm>
           <a:prstGeom prst="ellipse">
@@ -1083,8 +1083,8 @@
         </p:nvSpPr>
         <p:spPr>
           <a:xfrm>
-            <a:off x="10881360" y="457200"/>
-            <a:ext cx="2011680" cy="2011680"/>
+            <a:off x="10789920" y="502920"/>
+            <a:ext cx="1920240" cy="1920240"/>
           </a:xfrm>
           <a:prstGeom prst="ellipse">
             <a:avLst/>
@@ -1126,7 +1126,7 @@
         <p:spPr>
           <a:xfrm>
             <a:off x="640080" y="502920"/>
-            <a:ext cx="8229600" cy="292608"/>
+            <a:ext cx="10058400" cy="292608"/>
           </a:xfrm>
           <a:prstGeom prst="rect">
             <a:avLst/>
@@ -1150,7 +1150,7 @@
                 <a:ea typeface="Calibri" pitchFamily="34" charset="-122"/>
                 <a:cs typeface="Calibri" pitchFamily="34" charset="-120"/>
               </a:rPr>
-              <a:t>FOR MULTI-LOCATION DENTAL GROUPS</a:t>
+              <a:t>FOR MULTI-LOCATION DSOs</a:t>
             </a:r>
             <a:endParaRPr lang="en-US" sz="1300" dirty="0"/>
           </a:p>
@@ -1164,8 +1164,8 @@
         </p:nvSpPr>
         <p:spPr>
           <a:xfrm>
-            <a:off x="621792" y="868680"/>
-            <a:ext cx="8595360" cy="1325880"/>
+            <a:off x="621792" y="896112"/>
+            <a:ext cx="10515600" cy="1280160"/>
           </a:xfrm>
           <a:prstGeom prst="rect">
             <a:avLst/>
@@ -1179,42 +1179,42 @@
           <a:p>
             <a:pPr algn="l" indent="0" marL="0">
               <a:lnSpc>
-                <a:spcPct val="98000"/>
+                <a:spcPct val="100000"/>
               </a:lnSpc>
               <a:buNone/>
             </a:pPr>
             <a:r>
-              <a:rPr lang="en-US" sz="4000" b="1" dirty="0">
+              <a:rPr lang="en-US" sz="3800" b="1" dirty="0">
                 <a:solidFill>
                   <a:srgbClr val="FFFFFF"/>
                 </a:solidFill>
-                <a:latin typeface="Georgia" pitchFamily="34" charset="0"/>
-                <a:ea typeface="Georgia" pitchFamily="34" charset="-122"/>
-                <a:cs typeface="Georgia" pitchFamily="34" charset="-120"/>
+                <a:latin typeface="Calibri" pitchFamily="34" charset="0"/>
+                <a:ea typeface="Calibri" pitchFamily="34" charset="-122"/>
+                <a:cs typeface="Calibri" pitchFamily="34" charset="-120"/>
               </a:rPr>
-              <a:t>Drowning in data.</a:t>
-            </a:r>
-            <a:endParaRPr lang="en-US" sz="4000" dirty="0"/>
+              <a:t>It’s not a data problem.</a:t>
+            </a:r>
+            <a:endParaRPr lang="en-US" sz="3800" dirty="0"/>
           </a:p>
           <a:p>
             <a:pPr algn="l" indent="0" marL="0">
               <a:lnSpc>
-                <a:spcPct val="98000"/>
+                <a:spcPct val="100000"/>
               </a:lnSpc>
               <a:buNone/>
             </a:pPr>
             <a:r>
-              <a:rPr lang="en-US" sz="4000" b="1" dirty="0">
+              <a:rPr lang="en-US" sz="3800" b="1" dirty="0">
                 <a:solidFill>
                   <a:srgbClr val="FFFFFF"/>
                 </a:solidFill>
-                <a:latin typeface="Georgia" pitchFamily="34" charset="0"/>
-                <a:ea typeface="Georgia" pitchFamily="34" charset="-122"/>
-                <a:cs typeface="Georgia" pitchFamily="34" charset="-120"/>
+                <a:latin typeface="Calibri" pitchFamily="34" charset="0"/>
+                <a:ea typeface="Calibri" pitchFamily="34" charset="-122"/>
+                <a:cs typeface="Calibri" pitchFamily="34" charset="-120"/>
               </a:rPr>
-              <a:t>Starving for decisions.</a:t>
-            </a:r>
-            <a:endParaRPr lang="en-US" sz="4000" dirty="0"/>
+              <a:t>It’s a timing problem.</a:t>
+            </a:r>
+            <a:endParaRPr lang="en-US" sz="3800" dirty="0"/>
           </a:p>
         </p:txBody>
       </p:sp>
@@ -1226,8 +1226,8 @@
         </p:nvSpPr>
         <p:spPr>
           <a:xfrm>
-            <a:off x="640080" y="2331720"/>
-            <a:ext cx="8321040" cy="914400"/>
+            <a:off x="640080" y="2286000"/>
+            <a:ext cx="8869680" cy="914400"/>
           </a:xfrm>
           <a:prstGeom prst="rect">
             <a:avLst/>
@@ -1241,7 +1241,7 @@
           <a:p>
             <a:pPr algn="l" indent="0" marL="0">
               <a:lnSpc>
-                <a:spcPct val="105000"/>
+                <a:spcPct val="108000"/>
               </a:lnSpc>
               <a:buNone/>
             </a:pPr>
@@ -1254,7 +1254,7 @@
                 <a:ea typeface="Calibri" pitchFamily="34" charset="-122"/>
                 <a:cs typeface="Calibri" pitchFamily="34" charset="-120"/>
               </a:rPr>
-              <a:t>A growing dental organization had massive operational data across clinical delivery, provider productivity, patient engagement, and finance — but no unified view across locations. Decisions stayed reactive, and the real drivers of production and profitability stayed hidden.</a:t>
+              <a:t>Most DSOs don’t struggle with data — they struggle with timing. KPI reports arrive days, sometimes weeks, late. By the time leadership sees the numbers, the problem has already impacted revenue.</a:t>
             </a:r>
             <a:endParaRPr lang="en-US" sz="1450" dirty="0"/>
           </a:p>
@@ -1268,8 +1268,8 @@
         </p:nvSpPr>
         <p:spPr>
           <a:xfrm>
-            <a:off x="640080" y="3401568"/>
-            <a:ext cx="8229600" cy="292608"/>
+            <a:off x="640080" y="3419856"/>
+            <a:ext cx="10058400" cy="292608"/>
           </a:xfrm>
           <a:prstGeom prst="rect">
             <a:avLst/>
@@ -1293,7 +1293,7 @@
                 <a:ea typeface="Calibri" pitchFamily="34" charset="-122"/>
                 <a:cs typeface="Calibri" pitchFamily="34" charset="-120"/>
               </a:rPr>
-              <a:t>KEY CHALLENGES WE SEE EVERY DAY</a:t>
+              <a:t>BY THE TIME YOU SEE IT — WAS IT…</a:t>
             </a:r>
             <a:endParaRPr lang="en-US" sz="1300" dirty="0"/>
           </a:p>
@@ -1308,11 +1308,11 @@
         <p:spPr>
           <a:xfrm>
             <a:off x="640080" y="3767328"/>
-            <a:ext cx="3465576" cy="1298448"/>
+            <a:ext cx="2514600" cy="2286000"/>
           </a:xfrm>
           <a:prstGeom prst="roundRect">
             <a:avLst>
-              <a:gd name="adj" fmla="val 4930"/>
+              <a:gd name="adj" fmla="val 2800"/>
             </a:avLst>
           </a:prstGeom>
           <a:solidFill>
@@ -1334,8 +1334,8 @@
         </p:nvSpPr>
         <p:spPr>
           <a:xfrm>
-            <a:off x="877824" y="4014216"/>
-            <a:ext cx="457200" cy="457200"/>
+            <a:off x="914400" y="4078224"/>
+            <a:ext cx="566928" cy="566928"/>
           </a:xfrm>
           <a:prstGeom prst="ellipse">
             <a:avLst/>
@@ -1369,8 +1369,8 @@
         </p:blipFill>
         <p:spPr>
           <a:xfrm>
-            <a:off x="987552" y="4123944"/>
-            <a:ext cx="237744" cy="237744"/>
+            <a:off x="1050463" y="4214287"/>
+            <a:ext cx="294803" cy="294803"/>
           </a:xfrm>
           <a:prstGeom prst="rect">
             <a:avLst/>
@@ -1385,8 +1385,8 @@
         </p:nvSpPr>
         <p:spPr>
           <a:xfrm>
-            <a:off x="1481328" y="3986784"/>
-            <a:ext cx="2459736" cy="502920"/>
+            <a:off x="914400" y="4809744"/>
+            <a:ext cx="1965960" cy="548640"/>
           </a:xfrm>
           <a:prstGeom prst="rect">
             <a:avLst/>
@@ -1395,14 +1395,17 @@
           <a:ln/>
         </p:spPr>
         <p:txBody>
-          <a:bodyPr wrap="square" lIns="0" tIns="0" rIns="0" bIns="0" rtlCol="0" anchor="ctr"/>
+          <a:bodyPr wrap="square" lIns="0" tIns="0" rIns="0" bIns="0" rtlCol="0" anchor="t"/>
           <a:lstStyle/>
           <a:p>
             <a:pPr algn="l" indent="0" marL="0">
+              <a:lnSpc>
+                <a:spcPct val="98000"/>
+              </a:lnSpc>
               <a:buNone/>
             </a:pPr>
             <a:r>
-              <a:rPr lang="en-US" sz="1350" b="1" dirty="0">
+              <a:rPr lang="en-US" sz="1450" b="1" dirty="0">
                 <a:solidFill>
                   <a:srgbClr val="FFFFFF"/>
                 </a:solidFill>
@@ -1410,9 +1413,9 @@
                 <a:ea typeface="Calibri" pitchFamily="34" charset="-122"/>
                 <a:cs typeface="Calibri" pitchFamily="34" charset="-120"/>
               </a:rPr>
-              <a:t>Inconsistent productivity</a:t>
-            </a:r>
-            <a:endParaRPr lang="en-US" sz="1350" dirty="0"/>
+              <a:t>Declining case acceptance</a:t>
+            </a:r>
+            <a:endParaRPr lang="en-US" sz="1450" dirty="0"/>
           </a:p>
         </p:txBody>
       </p:sp>
@@ -1424,8 +1427,8 @@
         </p:nvSpPr>
         <p:spPr>
           <a:xfrm>
-            <a:off x="896112" y="4517136"/>
-            <a:ext cx="3008376" cy="457200"/>
+            <a:off x="914400" y="5358384"/>
+            <a:ext cx="1984248" cy="603504"/>
           </a:xfrm>
           <a:prstGeom prst="rect">
             <a:avLst/>
@@ -1434,17 +1437,17 @@
           <a:ln/>
         </p:spPr>
         <p:txBody>
-          <a:bodyPr wrap="square" lIns="0" tIns="0" rIns="0" bIns="0" rtlCol="0" anchor="ctr"/>
+          <a:bodyPr wrap="square" lIns="0" tIns="0" rIns="0" bIns="0" rtlCol="0" anchor="t"/>
           <a:lstStyle/>
           <a:p>
             <a:pPr algn="l" indent="0" marL="0">
               <a:lnSpc>
-                <a:spcPct val="100000"/>
+                <a:spcPct val="104000"/>
               </a:lnSpc>
               <a:buNone/>
             </a:pPr>
             <a:r>
-              <a:rPr lang="en-US" sz="1050" dirty="0">
+              <a:rPr lang="en-US" sz="1100" dirty="0">
                 <a:solidFill>
                   <a:srgbClr val="9FB6BA"/>
                 </a:solidFill>
@@ -1452,9 +1455,9 @@
                 <a:ea typeface="Calibri" pitchFamily="34" charset="-122"/>
                 <a:cs typeface="Calibri" pitchFamily="34" charset="-120"/>
               </a:rPr>
-              <a:t>Provider output swings widely from location to location</a:t>
-            </a:r>
-            <a:endParaRPr lang="en-US" sz="1050" dirty="0"/>
+              <a:t>Conversion slipping unnoticed across providers</a:t>
+            </a:r>
+            <a:endParaRPr lang="en-US" sz="1100" dirty="0"/>
           </a:p>
         </p:txBody>
       </p:sp>
@@ -1466,12 +1469,12 @@
         </p:nvSpPr>
         <p:spPr>
           <a:xfrm>
-            <a:off x="4361688" y="3767328"/>
-            <a:ext cx="3465576" cy="1298448"/>
+            <a:off x="3429000" y="3767328"/>
+            <a:ext cx="2514600" cy="2286000"/>
           </a:xfrm>
           <a:prstGeom prst="roundRect">
             <a:avLst>
-              <a:gd name="adj" fmla="val 4930"/>
+              <a:gd name="adj" fmla="val 2800"/>
             </a:avLst>
           </a:prstGeom>
           <a:solidFill>
@@ -1493,8 +1496,8 @@
         </p:nvSpPr>
         <p:spPr>
           <a:xfrm>
-            <a:off x="4599432" y="4014216"/>
-            <a:ext cx="457200" cy="457200"/>
+            <a:off x="3703320" y="4078224"/>
+            <a:ext cx="566928" cy="566928"/>
           </a:xfrm>
           <a:prstGeom prst="ellipse">
             <a:avLst/>
@@ -1528,8 +1531,8 @@
         </p:blipFill>
         <p:spPr>
           <a:xfrm>
-            <a:off x="4709160" y="4123944"/>
-            <a:ext cx="237744" cy="237744"/>
+            <a:off x="3839383" y="4214287"/>
+            <a:ext cx="294803" cy="294803"/>
           </a:xfrm>
           <a:prstGeom prst="rect">
             <a:avLst/>
@@ -1544,8 +1547,8 @@
         </p:nvSpPr>
         <p:spPr>
           <a:xfrm>
-            <a:off x="5202936" y="3986784"/>
-            <a:ext cx="2459736" cy="502920"/>
+            <a:off x="3703320" y="4809744"/>
+            <a:ext cx="1965960" cy="548640"/>
           </a:xfrm>
           <a:prstGeom prst="rect">
             <a:avLst/>
@@ -1554,14 +1557,17 @@
           <a:ln/>
         </p:spPr>
         <p:txBody>
-          <a:bodyPr wrap="square" lIns="0" tIns="0" rIns="0" bIns="0" rtlCol="0" anchor="ctr"/>
+          <a:bodyPr wrap="square" lIns="0" tIns="0" rIns="0" bIns="0" rtlCol="0" anchor="t"/>
           <a:lstStyle/>
           <a:p>
             <a:pPr algn="l" indent="0" marL="0">
+              <a:lnSpc>
+                <a:spcPct val="98000"/>
+              </a:lnSpc>
               <a:buNone/>
             </a:pPr>
             <a:r>
-              <a:rPr lang="en-US" sz="1350" b="1" dirty="0">
+              <a:rPr lang="en-US" sz="1450" b="1" dirty="0">
                 <a:solidFill>
                   <a:srgbClr val="FFFFFF"/>
                 </a:solidFill>
@@ -1569,9 +1575,9 @@
                 <a:ea typeface="Calibri" pitchFamily="34" charset="-122"/>
                 <a:cs typeface="Calibri" pitchFamily="34" charset="-120"/>
               </a:rPr>
-              <a:t>Scheduling &amp; hygiene gaps</a:t>
-            </a:r>
-            <a:endParaRPr lang="en-US" sz="1350" dirty="0"/>
+              <a:t>Scheduling inefficiencies</a:t>
+            </a:r>
+            <a:endParaRPr lang="en-US" sz="1450" dirty="0"/>
           </a:p>
         </p:txBody>
       </p:sp>
@@ -1583,8 +1589,8 @@
         </p:nvSpPr>
         <p:spPr>
           <a:xfrm>
-            <a:off x="4617720" y="4517136"/>
-            <a:ext cx="3008376" cy="457200"/>
+            <a:off x="3703320" y="5358384"/>
+            <a:ext cx="1984248" cy="603504"/>
           </a:xfrm>
           <a:prstGeom prst="rect">
             <a:avLst/>
@@ -1593,17 +1599,17 @@
           <a:ln/>
         </p:spPr>
         <p:txBody>
-          <a:bodyPr wrap="square" lIns="0" tIns="0" rIns="0" bIns="0" rtlCol="0" anchor="ctr"/>
+          <a:bodyPr wrap="square" lIns="0" tIns="0" rIns="0" bIns="0" rtlCol="0" anchor="t"/>
           <a:lstStyle/>
           <a:p>
             <a:pPr algn="l" indent="0" marL="0">
               <a:lnSpc>
-                <a:spcPct val="100000"/>
+                <a:spcPct val="104000"/>
               </a:lnSpc>
               <a:buNone/>
             </a:pPr>
             <a:r>
-              <a:rPr lang="en-US" sz="1050" dirty="0">
+              <a:rPr lang="en-US" sz="1100" dirty="0">
                 <a:solidFill>
                   <a:srgbClr val="9FB6BA"/>
                 </a:solidFill>
@@ -1611,9 +1617,9 @@
                 <a:ea typeface="Calibri" pitchFamily="34" charset="-122"/>
                 <a:cs typeface="Calibri" pitchFamily="34" charset="-120"/>
               </a:rPr>
-              <a:t>Unused hygiene capacity and open chairs go unnoticed</a:t>
-            </a:r>
-            <a:endParaRPr lang="en-US" sz="1050" dirty="0"/>
+              <a:t>Open chairs and hygiene gaps draining capacity</a:t>
+            </a:r>
+            <a:endParaRPr lang="en-US" sz="1100" dirty="0"/>
           </a:p>
         </p:txBody>
       </p:sp>
@@ -1625,12 +1631,12 @@
         </p:nvSpPr>
         <p:spPr>
           <a:xfrm>
-            <a:off x="8083296" y="3767328"/>
-            <a:ext cx="3465576" cy="1298448"/>
+            <a:off x="6217920" y="3767328"/>
+            <a:ext cx="2514600" cy="2286000"/>
           </a:xfrm>
           <a:prstGeom prst="roundRect">
             <a:avLst>
-              <a:gd name="adj" fmla="val 4930"/>
+              <a:gd name="adj" fmla="val 2800"/>
             </a:avLst>
           </a:prstGeom>
           <a:solidFill>
@@ -1652,8 +1658,8 @@
         </p:nvSpPr>
         <p:spPr>
           <a:xfrm>
-            <a:off x="8321040" y="4014216"/>
-            <a:ext cx="457200" cy="457200"/>
+            <a:off x="6492240" y="4078224"/>
+            <a:ext cx="566928" cy="566928"/>
           </a:xfrm>
           <a:prstGeom prst="ellipse">
             <a:avLst/>
@@ -1687,8 +1693,8 @@
         </p:blipFill>
         <p:spPr>
           <a:xfrm>
-            <a:off x="8430768" y="4123944"/>
-            <a:ext cx="237744" cy="237744"/>
+            <a:off x="6628303" y="4214287"/>
+            <a:ext cx="294803" cy="294803"/>
           </a:xfrm>
           <a:prstGeom prst="rect">
             <a:avLst/>
@@ -1703,8 +1709,8 @@
         </p:nvSpPr>
         <p:spPr>
           <a:xfrm>
-            <a:off x="8924544" y="3986784"/>
-            <a:ext cx="2459736" cy="502920"/>
+            <a:off x="6492240" y="4809744"/>
+            <a:ext cx="1965960" cy="548640"/>
           </a:xfrm>
           <a:prstGeom prst="rect">
             <a:avLst/>
@@ -1713,14 +1719,17 @@
           <a:ln/>
         </p:spPr>
         <p:txBody>
-          <a:bodyPr wrap="square" lIns="0" tIns="0" rIns="0" bIns="0" rtlCol="0" anchor="ctr"/>
+          <a:bodyPr wrap="square" lIns="0" tIns="0" rIns="0" bIns="0" rtlCol="0" anchor="t"/>
           <a:lstStyle/>
           <a:p>
             <a:pPr algn="l" indent="0" marL="0">
+              <a:lnSpc>
+                <a:spcPct val="98000"/>
+              </a:lnSpc>
               <a:buNone/>
             </a:pPr>
             <a:r>
-              <a:rPr lang="en-US" sz="1350" b="1" dirty="0">
+              <a:rPr lang="en-US" sz="1450" b="1" dirty="0">
                 <a:solidFill>
                   <a:srgbClr val="FFFFFF"/>
                 </a:solidFill>
@@ -1728,9 +1737,9 @@
                 <a:ea typeface="Calibri" pitchFamily="34" charset="-122"/>
                 <a:cs typeface="Calibri" pitchFamily="34" charset="-120"/>
               </a:rPr>
-              <a:t>Unclear production drivers</a:t>
-            </a:r>
-            <a:endParaRPr lang="en-US" sz="1350" dirty="0"/>
+              <a:t>Shifts in procedure mix</a:t>
+            </a:r>
+            <a:endParaRPr lang="en-US" sz="1450" dirty="0"/>
           </a:p>
         </p:txBody>
       </p:sp>
@@ -1742,8 +1751,8 @@
         </p:nvSpPr>
         <p:spPr>
           <a:xfrm>
-            <a:off x="8339328" y="4517136"/>
-            <a:ext cx="3008376" cy="457200"/>
+            <a:off x="6492240" y="5358384"/>
+            <a:ext cx="1984248" cy="603504"/>
           </a:xfrm>
           <a:prstGeom prst="rect">
             <a:avLst/>
@@ -1752,17 +1761,17 @@
           <a:ln/>
         </p:spPr>
         <p:txBody>
-          <a:bodyPr wrap="square" lIns="0" tIns="0" rIns="0" bIns="0" rtlCol="0" anchor="ctr"/>
+          <a:bodyPr wrap="square" lIns="0" tIns="0" rIns="0" bIns="0" rtlCol="0" anchor="t"/>
           <a:lstStyle/>
           <a:p>
             <a:pPr algn="l" indent="0" marL="0">
               <a:lnSpc>
-                <a:spcPct val="100000"/>
+                <a:spcPct val="104000"/>
               </a:lnSpc>
               <a:buNone/>
             </a:pPr>
             <a:r>
-              <a:rPr lang="en-US" sz="1050" dirty="0">
+              <a:rPr lang="en-US" sz="1100" dirty="0">
                 <a:solidFill>
                   <a:srgbClr val="9FB6BA"/>
                 </a:solidFill>
@@ -1770,9 +1779,9 @@
                 <a:ea typeface="Calibri" pitchFamily="34" charset="-122"/>
                 <a:cs typeface="Calibri" pitchFamily="34" charset="-120"/>
               </a:rPr>
-              <a:t>Hard to see which procedures actually drive revenue</a:t>
-            </a:r>
-            <a:endParaRPr lang="en-US" sz="1050" dirty="0"/>
+              <a:t>High-value production quietly trending down</a:t>
+            </a:r>
+            <a:endParaRPr lang="en-US" sz="1100" dirty="0"/>
           </a:p>
         </p:txBody>
       </p:sp>
@@ -1784,12 +1793,12 @@
         </p:nvSpPr>
         <p:spPr>
           <a:xfrm>
-            <a:off x="640080" y="5321808"/>
-            <a:ext cx="3465576" cy="1298448"/>
+            <a:off x="9006840" y="3767328"/>
+            <a:ext cx="2514600" cy="2286000"/>
           </a:xfrm>
           <a:prstGeom prst="roundRect">
             <a:avLst>
-              <a:gd name="adj" fmla="val 4930"/>
+              <a:gd name="adj" fmla="val 2800"/>
             </a:avLst>
           </a:prstGeom>
           <a:solidFill>
@@ -1811,8 +1820,8 @@
         </p:nvSpPr>
         <p:spPr>
           <a:xfrm>
-            <a:off x="877824" y="5568696"/>
-            <a:ext cx="457200" cy="457200"/>
+            <a:off x="9281160" y="4078224"/>
+            <a:ext cx="566928" cy="566928"/>
           </a:xfrm>
           <a:prstGeom prst="ellipse">
             <a:avLst/>
@@ -1846,8 +1855,8 @@
         </p:blipFill>
         <p:spPr>
           <a:xfrm>
-            <a:off x="987552" y="5678424"/>
-            <a:ext cx="237744" cy="237744"/>
+            <a:off x="9417223" y="4214287"/>
+            <a:ext cx="294803" cy="294803"/>
           </a:xfrm>
           <a:prstGeom prst="rect">
             <a:avLst/>
@@ -1862,8 +1871,8 @@
         </p:nvSpPr>
         <p:spPr>
           <a:xfrm>
-            <a:off x="1481328" y="5541264"/>
-            <a:ext cx="2459736" cy="502920"/>
+            <a:off x="9281160" y="4809744"/>
+            <a:ext cx="1965960" cy="548640"/>
           </a:xfrm>
           <a:prstGeom prst="rect">
             <a:avLst/>
@@ -1872,14 +1881,17 @@
           <a:ln/>
         </p:spPr>
         <p:txBody>
-          <a:bodyPr wrap="square" lIns="0" tIns="0" rIns="0" bIns="0" rtlCol="0" anchor="ctr"/>
+          <a:bodyPr wrap="square" lIns="0" tIns="0" rIns="0" bIns="0" rtlCol="0" anchor="t"/>
           <a:lstStyle/>
           <a:p>
             <a:pPr algn="l" indent="0" marL="0">
+              <a:lnSpc>
+                <a:spcPct val="98000"/>
+              </a:lnSpc>
               <a:buNone/>
             </a:pPr>
             <a:r>
-              <a:rPr lang="en-US" sz="1350" b="1" dirty="0">
+              <a:rPr lang="en-US" sz="1450" b="1" dirty="0">
                 <a:solidFill>
                   <a:srgbClr val="FFFFFF"/>
                 </a:solidFill>
@@ -1887,9 +1899,9 @@
                 <a:ea typeface="Calibri" pitchFamily="34" charset="-122"/>
                 <a:cs typeface="Calibri" pitchFamily="34" charset="-120"/>
               </a:rPr>
-              <a:t>Revenue leakage</a:t>
-            </a:r>
-            <a:endParaRPr lang="en-US" sz="1350" dirty="0"/>
+              <a:t>Early patient churn</a:t>
+            </a:r>
+            <a:endParaRPr lang="en-US" sz="1450" dirty="0"/>
           </a:p>
         </p:txBody>
       </p:sp>
@@ -1901,8 +1913,8 @@
         </p:nvSpPr>
         <p:spPr>
           <a:xfrm>
-            <a:off x="896112" y="6071616"/>
-            <a:ext cx="3008376" cy="457200"/>
+            <a:off x="9281160" y="5358384"/>
+            <a:ext cx="1984248" cy="603504"/>
           </a:xfrm>
           <a:prstGeom prst="rect">
             <a:avLst/>
@@ -1911,17 +1923,17 @@
           <a:ln/>
         </p:spPr>
         <p:txBody>
-          <a:bodyPr wrap="square" lIns="0" tIns="0" rIns="0" bIns="0" rtlCol="0" anchor="ctr"/>
+          <a:bodyPr wrap="square" lIns="0" tIns="0" rIns="0" bIns="0" rtlCol="0" anchor="t"/>
           <a:lstStyle/>
           <a:p>
             <a:pPr algn="l" indent="0" marL="0">
               <a:lnSpc>
-                <a:spcPct val="100000"/>
+                <a:spcPct val="104000"/>
               </a:lnSpc>
               <a:buNone/>
             </a:pPr>
             <a:r>
-              <a:rPr lang="en-US" sz="1050" dirty="0">
+              <a:rPr lang="en-US" sz="1100" dirty="0">
                 <a:solidFill>
                   <a:srgbClr val="9FB6BA"/>
                 </a:solidFill>
@@ -1929,327 +1941,9 @@
                 <a:ea typeface="Calibri" pitchFamily="34" charset="-122"/>
                 <a:cs typeface="Calibri" pitchFamily="34" charset="-120"/>
               </a:rPr>
-              <a:t>Adjustments and write-offs quietly erode collections</a:t>
-            </a:r>
-            <a:endParaRPr lang="en-US" sz="1050" dirty="0"/>
-          </a:p>
-        </p:txBody>
-      </p:sp>
-      <p:sp>
-        <p:nvSpPr>
-          <p:cNvPr id="29" name="Shape 23"/>
-          <p:cNvSpPr/>
-          <p:nvPr/>
-        </p:nvSpPr>
-        <p:spPr>
-          <a:xfrm>
-            <a:off x="4361688" y="5321808"/>
-            <a:ext cx="3465576" cy="1298448"/>
-          </a:xfrm>
-          <a:prstGeom prst="roundRect">
-            <a:avLst>
-              <a:gd name="adj" fmla="val 4930"/>
-            </a:avLst>
-          </a:prstGeom>
-          <a:solidFill>
-            <a:srgbClr val="123A44"/>
-          </a:solidFill>
-          <a:ln w="12700">
-            <a:solidFill>
-              <a:srgbClr val="1C4A55"/>
-            </a:solidFill>
-            <a:prstDash val="solid"/>
-          </a:ln>
-        </p:spPr>
-      </p:sp>
-      <p:sp>
-        <p:nvSpPr>
-          <p:cNvPr id="30" name="Shape 24"/>
-          <p:cNvSpPr/>
-          <p:nvPr/>
-        </p:nvSpPr>
-        <p:spPr>
-          <a:xfrm>
-            <a:off x="4599432" y="5568696"/>
-            <a:ext cx="457200" cy="457200"/>
-          </a:xfrm>
-          <a:prstGeom prst="ellipse">
-            <a:avLst/>
-          </a:prstGeom>
-          <a:solidFill>
-            <a:srgbClr val="0F8A8F"/>
-          </a:solidFill>
-          <a:ln/>
-          <a:effectLst>
-            <a:outerShdw sx="100000" sy="100000" kx="0" ky="0" algn="bl" rotWithShape="0" blurRad="101600" dist="38100" dir="8100000">
-              <a:srgbClr val="0A2A33">
-                <a:alpha val="16000"/>
-              </a:srgbClr>
-            </a:outerShdw>
-          </a:effectLst>
-        </p:spPr>
-      </p:sp>
-      <p:pic>
-        <p:nvPicPr>
-          <p:cNvPr id="31" name="Image 4" descr="preencoded.png">    </p:cNvPr>
-          <p:cNvPicPr>
-            <a:picLocks noChangeAspect="1"/>
-          </p:cNvPicPr>
-          <p:nvPr/>
-        </p:nvPicPr>
-        <p:blipFill>
-          <a:blip r:embed="rId5"/>
-          <a:stretch>
-            <a:fillRect/>
-          </a:stretch>
-        </p:blipFill>
-        <p:spPr>
-          <a:xfrm>
-            <a:off x="4709160" y="5678424"/>
-            <a:ext cx="237744" cy="237744"/>
-          </a:xfrm>
-          <a:prstGeom prst="rect">
-            <a:avLst/>
-          </a:prstGeom>
-        </p:spPr>
-      </p:pic>
-      <p:sp>
-        <p:nvSpPr>
-          <p:cNvPr id="32" name="Text 25"/>
-          <p:cNvSpPr/>
-          <p:nvPr/>
-        </p:nvSpPr>
-        <p:spPr>
-          <a:xfrm>
-            <a:off x="5202936" y="5541264"/>
-            <a:ext cx="2459736" cy="502920"/>
-          </a:xfrm>
-          <a:prstGeom prst="rect">
-            <a:avLst/>
-          </a:prstGeom>
-          <a:noFill/>
-          <a:ln/>
-        </p:spPr>
-        <p:txBody>
-          <a:bodyPr wrap="square" lIns="0" tIns="0" rIns="0" bIns="0" rtlCol="0" anchor="ctr"/>
-          <a:lstStyle/>
-          <a:p>
-            <a:pPr algn="l" indent="0" marL="0">
-              <a:buNone/>
-            </a:pPr>
-            <a:r>
-              <a:rPr lang="en-US" sz="1350" b="1" dirty="0">
-                <a:solidFill>
-                  <a:srgbClr val="FFFFFF"/>
-                </a:solidFill>
-                <a:latin typeface="Calibri" pitchFamily="34" charset="0"/>
-                <a:ea typeface="Calibri" pitchFamily="34" charset="-122"/>
-                <a:cs typeface="Calibri" pitchFamily="34" charset="-120"/>
-              </a:rPr>
-              <a:t>Passive patient engagement</a:t>
-            </a:r>
-            <a:endParaRPr lang="en-US" sz="1350" dirty="0"/>
-          </a:p>
-        </p:txBody>
-      </p:sp>
-      <p:sp>
-        <p:nvSpPr>
-          <p:cNvPr id="33" name="Text 26"/>
-          <p:cNvSpPr/>
-          <p:nvPr/>
-        </p:nvSpPr>
-        <p:spPr>
-          <a:xfrm>
-            <a:off x="4617720" y="6071616"/>
-            <a:ext cx="3008376" cy="457200"/>
-          </a:xfrm>
-          <a:prstGeom prst="rect">
-            <a:avLst/>
-          </a:prstGeom>
-          <a:noFill/>
-          <a:ln/>
-        </p:spPr>
-        <p:txBody>
-          <a:bodyPr wrap="square" lIns="0" tIns="0" rIns="0" bIns="0" rtlCol="0" anchor="ctr"/>
-          <a:lstStyle/>
-          <a:p>
-            <a:pPr algn="l" indent="0" marL="0">
-              <a:lnSpc>
-                <a:spcPct val="100000"/>
-              </a:lnSpc>
-              <a:buNone/>
-            </a:pPr>
-            <a:r>
-              <a:rPr lang="en-US" sz="1050" dirty="0">
-                <a:solidFill>
-                  <a:srgbClr val="9FB6BA"/>
-                </a:solidFill>
-                <a:latin typeface="Calibri" pitchFamily="34" charset="0"/>
-                <a:ea typeface="Calibri" pitchFamily="34" charset="-122"/>
-                <a:cs typeface="Calibri" pitchFamily="34" charset="-120"/>
-              </a:rPr>
-              <a:t>No early view of patients lapsing from preventive care</a:t>
-            </a:r>
-            <a:endParaRPr lang="en-US" sz="1050" dirty="0"/>
-          </a:p>
-        </p:txBody>
-      </p:sp>
-      <p:sp>
-        <p:nvSpPr>
-          <p:cNvPr id="34" name="Shape 27"/>
-          <p:cNvSpPr/>
-          <p:nvPr/>
-        </p:nvSpPr>
-        <p:spPr>
-          <a:xfrm>
-            <a:off x="8083296" y="5321808"/>
-            <a:ext cx="3465576" cy="1298448"/>
-          </a:xfrm>
-          <a:prstGeom prst="roundRect">
-            <a:avLst>
-              <a:gd name="adj" fmla="val 4930"/>
-            </a:avLst>
-          </a:prstGeom>
-          <a:solidFill>
-            <a:srgbClr val="123A44"/>
-          </a:solidFill>
-          <a:ln w="12700">
-            <a:solidFill>
-              <a:srgbClr val="1C4A55"/>
-            </a:solidFill>
-            <a:prstDash val="solid"/>
-          </a:ln>
-        </p:spPr>
-      </p:sp>
-      <p:sp>
-        <p:nvSpPr>
-          <p:cNvPr id="35" name="Shape 28"/>
-          <p:cNvSpPr/>
-          <p:nvPr/>
-        </p:nvSpPr>
-        <p:spPr>
-          <a:xfrm>
-            <a:off x="8321040" y="5568696"/>
-            <a:ext cx="457200" cy="457200"/>
-          </a:xfrm>
-          <a:prstGeom prst="ellipse">
-            <a:avLst/>
-          </a:prstGeom>
-          <a:solidFill>
-            <a:srgbClr val="0F8A8F"/>
-          </a:solidFill>
-          <a:ln/>
-          <a:effectLst>
-            <a:outerShdw sx="100000" sy="100000" kx="0" ky="0" algn="bl" rotWithShape="0" blurRad="101600" dist="38100" dir="8100000">
-              <a:srgbClr val="0A2A33">
-                <a:alpha val="16000"/>
-              </a:srgbClr>
-            </a:outerShdw>
-          </a:effectLst>
-        </p:spPr>
-      </p:sp>
-      <p:pic>
-        <p:nvPicPr>
-          <p:cNvPr id="36" name="Image 5" descr="preencoded.png">    </p:cNvPr>
-          <p:cNvPicPr>
-            <a:picLocks noChangeAspect="1"/>
-          </p:cNvPicPr>
-          <p:nvPr/>
-        </p:nvPicPr>
-        <p:blipFill>
-          <a:blip r:embed="rId6"/>
-          <a:stretch>
-            <a:fillRect/>
-          </a:stretch>
-        </p:blipFill>
-        <p:spPr>
-          <a:xfrm>
-            <a:off x="8430768" y="5678424"/>
-            <a:ext cx="237744" cy="237744"/>
-          </a:xfrm>
-          <a:prstGeom prst="rect">
-            <a:avLst/>
-          </a:prstGeom>
-        </p:spPr>
-      </p:pic>
-      <p:sp>
-        <p:nvSpPr>
-          <p:cNvPr id="37" name="Text 29"/>
-          <p:cNvSpPr/>
-          <p:nvPr/>
-        </p:nvSpPr>
-        <p:spPr>
-          <a:xfrm>
-            <a:off x="8924544" y="5541264"/>
-            <a:ext cx="2459736" cy="502920"/>
-          </a:xfrm>
-          <a:prstGeom prst="rect">
-            <a:avLst/>
-          </a:prstGeom>
-          <a:noFill/>
-          <a:ln/>
-        </p:spPr>
-        <p:txBody>
-          <a:bodyPr wrap="square" lIns="0" tIns="0" rIns="0" bIns="0" rtlCol="0" anchor="ctr"/>
-          <a:lstStyle/>
-          <a:p>
-            <a:pPr algn="l" indent="0" marL="0">
-              <a:buNone/>
-            </a:pPr>
-            <a:r>
-              <a:rPr lang="en-US" sz="1350" b="1" dirty="0">
-                <a:solidFill>
-                  <a:srgbClr val="FFFFFF"/>
-                </a:solidFill>
-                <a:latin typeface="Calibri" pitchFamily="34" charset="0"/>
-                <a:ea typeface="Calibri" pitchFamily="34" charset="-122"/>
-                <a:cs typeface="Calibri" pitchFamily="34" charset="-120"/>
-              </a:rPr>
-              <a:t>Reactive decisions</a:t>
-            </a:r>
-            <a:endParaRPr lang="en-US" sz="1350" dirty="0"/>
-          </a:p>
-        </p:txBody>
-      </p:sp>
-      <p:sp>
-        <p:nvSpPr>
-          <p:cNvPr id="38" name="Text 30"/>
-          <p:cNvSpPr/>
-          <p:nvPr/>
-        </p:nvSpPr>
-        <p:spPr>
-          <a:xfrm>
-            <a:off x="8339328" y="6071616"/>
-            <a:ext cx="3008376" cy="457200"/>
-          </a:xfrm>
-          <a:prstGeom prst="rect">
-            <a:avLst/>
-          </a:prstGeom>
-          <a:noFill/>
-          <a:ln/>
-        </p:spPr>
-        <p:txBody>
-          <a:bodyPr wrap="square" lIns="0" tIns="0" rIns="0" bIns="0" rtlCol="0" anchor="ctr"/>
-          <a:lstStyle/>
-          <a:p>
-            <a:pPr algn="l" indent="0" marL="0">
-              <a:lnSpc>
-                <a:spcPct val="100000"/>
-              </a:lnSpc>
-              <a:buNone/>
-            </a:pPr>
-            <a:r>
-              <a:rPr lang="en-US" sz="1050" dirty="0">
-                <a:solidFill>
-                  <a:srgbClr val="9FB6BA"/>
-                </a:solidFill>
-                <a:latin typeface="Calibri" pitchFamily="34" charset="0"/>
-                <a:ea typeface="Calibri" pitchFamily="34" charset="-122"/>
-                <a:cs typeface="Calibri" pitchFamily="34" charset="-120"/>
-              </a:rPr>
-              <a:t>Performance issues surface weeks too late to act on</a:t>
-            </a:r>
-            <a:endParaRPr lang="en-US" sz="1050" dirty="0"/>
+              <a:t>At-risk patients lapsing before anyone reacts</a:t>
+            </a:r>
+            <a:endParaRPr lang="en-US" sz="1100" dirty="0"/>
           </a:p>
         </p:txBody>
       </p:sp>
@@ -2314,7 +2008,7 @@
         <p:spPr>
           <a:xfrm>
             <a:off x="640080" y="457200"/>
-            <a:ext cx="8229600" cy="292608"/>
+            <a:ext cx="10058400" cy="292608"/>
           </a:xfrm>
           <a:prstGeom prst="rect">
             <a:avLst/>
@@ -2338,7 +2032,7 @@
                 <a:ea typeface="Calibri" pitchFamily="34" charset="-122"/>
                 <a:cs typeface="Calibri" pitchFamily="34" charset="-120"/>
               </a:rPr>
-              <a:t>THE SOLUTION</a:t>
+              <a:t>LUMENORE  ·  UNIFIED DENTAL BI</a:t>
             </a:r>
             <a:endParaRPr lang="en-US" sz="1300" dirty="0"/>
           </a:p>
@@ -2353,7 +2047,7 @@
         <p:spPr>
           <a:xfrm>
             <a:off x="621792" y="786384"/>
-            <a:ext cx="11155680" cy="640080"/>
+            <a:ext cx="11247120" cy="640080"/>
           </a:xfrm>
           <a:prstGeom prst="rect">
             <a:avLst/>
@@ -2373,11 +2067,11 @@
                 <a:solidFill>
                   <a:srgbClr val="0E323B"/>
                 </a:solidFill>
-                <a:latin typeface="Georgia" pitchFamily="34" charset="0"/>
-                <a:ea typeface="Georgia" pitchFamily="34" charset="-122"/>
-                <a:cs typeface="Georgia" pitchFamily="34" charset="-120"/>
+                <a:latin typeface="Calibri" pitchFamily="34" charset="0"/>
+                <a:ea typeface="Calibri" pitchFamily="34" charset="-122"/>
+                <a:cs typeface="Calibri" pitchFamily="34" charset="-120"/>
               </a:rPr>
-              <a:t>One connected dental performance intelligence ecosystem</a:t>
+              <a:t>Predict risk. Prevent churn. Power DSO growth.</a:t>
             </a:r>
             <a:endParaRPr lang="en-US" sz="3000" dirty="0"/>
           </a:p>
@@ -2392,7 +2086,7 @@
         <p:spPr>
           <a:xfrm>
             <a:off x="640080" y="1481328"/>
-            <a:ext cx="10607040" cy="548640"/>
+            <a:ext cx="10881360" cy="548640"/>
           </a:xfrm>
           <a:prstGeom prst="rect">
             <a:avLst/>
@@ -2406,7 +2100,7 @@
           <a:p>
             <a:pPr algn="l" indent="0" marL="0">
               <a:lnSpc>
-                <a:spcPct val="104000"/>
+                <a:spcPct val="105000"/>
               </a:lnSpc>
               <a:buNone/>
             </a:pPr>
@@ -2419,7 +2113,7 @@
                 <a:ea typeface="Calibri" pitchFamily="34" charset="-122"/>
                 <a:cs typeface="Calibri" pitchFamily="34" charset="-120"/>
               </a:rPr>
-              <a:t>Six integrated portfolios unify clinical, operational, financial, and patient data — turning isolated metrics into connected, organization-wide intelligence.</a:t>
+              <a:t>Lumenore unifies clinical, scheduling, and financial data into one BI layer — with real-time benchmarking, predictive analytics, and natural-language answers.</a:t>
             </a:r>
             <a:endParaRPr lang="en-US" sz="1400" dirty="0"/>
           </a:p>
@@ -2433,8 +2127,8 @@
         </p:nvSpPr>
         <p:spPr>
           <a:xfrm>
-            <a:off x="640080" y="2194560"/>
-            <a:ext cx="3429000" cy="1938528"/>
+            <a:off x="640080" y="2176272"/>
+            <a:ext cx="3419856" cy="1938528"/>
           </a:xfrm>
           <a:prstGeom prst="roundRect">
             <a:avLst>
@@ -2467,7 +2161,7 @@
         </p:nvSpPr>
         <p:spPr>
           <a:xfrm>
-            <a:off x="932688" y="2487168"/>
+            <a:off x="932688" y="2468880"/>
             <a:ext cx="658368" cy="658368"/>
           </a:xfrm>
           <a:prstGeom prst="ellipse">
@@ -2502,7 +2196,7 @@
         </p:blipFill>
         <p:spPr>
           <a:xfrm>
-            <a:off x="1090696" y="2645176"/>
+            <a:off x="1090696" y="2626888"/>
             <a:ext cx="342351" cy="342351"/>
           </a:xfrm>
           <a:prstGeom prst="rect">
@@ -2518,8 +2212,8 @@
         </p:nvSpPr>
         <p:spPr>
           <a:xfrm>
-            <a:off x="932688" y="3273552"/>
-            <a:ext cx="2880360" cy="365760"/>
+            <a:off x="932688" y="3236976"/>
+            <a:ext cx="2871216" cy="365760"/>
           </a:xfrm>
           <a:prstGeom prst="rect">
             <a:avLst/>
@@ -2543,7 +2237,7 @@
                 <a:ea typeface="Calibri" pitchFamily="34" charset="-122"/>
                 <a:cs typeface="Calibri" pitchFamily="34" charset="-120"/>
               </a:rPr>
-              <a:t>Hygiene Intelligence</a:t>
+              <a:t>Real-time benchmarking</a:t>
             </a:r>
             <a:endParaRPr lang="en-US" sz="1550" dirty="0"/>
           </a:p>
@@ -2557,8 +2251,8 @@
         </p:nvSpPr>
         <p:spPr>
           <a:xfrm>
-            <a:off x="932688" y="3611880"/>
-            <a:ext cx="2862072" cy="457200"/>
+            <a:off x="932688" y="3566160"/>
+            <a:ext cx="2852928" cy="457200"/>
           </a:xfrm>
           <a:prstGeom prst="rect">
             <a:avLst/>
@@ -2585,7 +2279,7 @@
                 <a:ea typeface="Calibri" pitchFamily="34" charset="-122"/>
                 <a:cs typeface="Calibri" pitchFamily="34" charset="-120"/>
               </a:rPr>
-              <a:t>Real-time hygiene utilization, scheduling efficiency, and forecasting</a:t>
+              <a:t>Compare dentists across locations as it happens</a:t>
             </a:r>
             <a:endParaRPr lang="en-US" sz="1150" dirty="0"/>
           </a:p>
@@ -2599,8 +2293,8 @@
         </p:nvSpPr>
         <p:spPr>
           <a:xfrm>
-            <a:off x="4379976" y="2194560"/>
-            <a:ext cx="3429000" cy="1938528"/>
+            <a:off x="4370832" y="2176272"/>
+            <a:ext cx="3419856" cy="1938528"/>
           </a:xfrm>
           <a:prstGeom prst="roundRect">
             <a:avLst>
@@ -2633,7 +2327,7 @@
         </p:nvSpPr>
         <p:spPr>
           <a:xfrm>
-            <a:off x="4672584" y="2487168"/>
+            <a:off x="4663440" y="2468880"/>
             <a:ext cx="658368" cy="658368"/>
           </a:xfrm>
           <a:prstGeom prst="ellipse">
@@ -2668,7 +2362,7 @@
         </p:blipFill>
         <p:spPr>
           <a:xfrm>
-            <a:off x="4830592" y="2645176"/>
+            <a:off x="4821448" y="2626888"/>
             <a:ext cx="342351" cy="342351"/>
           </a:xfrm>
           <a:prstGeom prst="rect">
@@ -2684,8 +2378,8 @@
         </p:nvSpPr>
         <p:spPr>
           <a:xfrm>
-            <a:off x="4672584" y="3273552"/>
-            <a:ext cx="2880360" cy="365760"/>
+            <a:off x="4663440" y="3236976"/>
+            <a:ext cx="2871216" cy="365760"/>
           </a:xfrm>
           <a:prstGeom prst="rect">
             <a:avLst/>
@@ -2709,7 +2403,7 @@
                 <a:ea typeface="Calibri" pitchFamily="34" charset="-122"/>
                 <a:cs typeface="Calibri" pitchFamily="34" charset="-120"/>
               </a:rPr>
-              <a:t>Dentist Productivity</a:t>
+              <a:t>Conversion &amp; engagement</a:t>
             </a:r>
             <a:endParaRPr lang="en-US" sz="1550" dirty="0"/>
           </a:p>
@@ -2723,8 +2417,8 @@
         </p:nvSpPr>
         <p:spPr>
           <a:xfrm>
-            <a:off x="4672584" y="3611880"/>
-            <a:ext cx="2862072" cy="457200"/>
+            <a:off x="4663440" y="3566160"/>
+            <a:ext cx="2852928" cy="457200"/>
           </a:xfrm>
           <a:prstGeom prst="rect">
             <a:avLst/>
@@ -2751,7 +2445,7 @@
                 <a:ea typeface="Calibri" pitchFamily="34" charset="-122"/>
                 <a:cs typeface="Calibri" pitchFamily="34" charset="-120"/>
               </a:rPr>
-              <a:t>Connects patient flow, clinical hours, and true production drivers</a:t>
+              <a:t>Detect declining case acceptance and engagement early</a:t>
             </a:r>
             <a:endParaRPr lang="en-US" sz="1150" dirty="0"/>
           </a:p>
@@ -2765,8 +2459,8 @@
         </p:nvSpPr>
         <p:spPr>
           <a:xfrm>
-            <a:off x="8119872" y="2194560"/>
-            <a:ext cx="3429000" cy="1938528"/>
+            <a:off x="8101584" y="2176272"/>
+            <a:ext cx="3419856" cy="1938528"/>
           </a:xfrm>
           <a:prstGeom prst="roundRect">
             <a:avLst>
@@ -2799,7 +2493,7 @@
         </p:nvSpPr>
         <p:spPr>
           <a:xfrm>
-            <a:off x="8412480" y="2487168"/>
+            <a:off x="8394192" y="2468880"/>
             <a:ext cx="658368" cy="658368"/>
           </a:xfrm>
           <a:prstGeom prst="ellipse">
@@ -2834,7 +2528,7 @@
         </p:blipFill>
         <p:spPr>
           <a:xfrm>
-            <a:off x="8570488" y="2645176"/>
+            <a:off x="8552200" y="2626888"/>
             <a:ext cx="342351" cy="342351"/>
           </a:xfrm>
           <a:prstGeom prst="rect">
@@ -2850,8 +2544,8 @@
         </p:nvSpPr>
         <p:spPr>
           <a:xfrm>
-            <a:off x="8412480" y="3273552"/>
-            <a:ext cx="2880360" cy="365760"/>
+            <a:off x="8394192" y="3236976"/>
+            <a:ext cx="2871216" cy="365760"/>
           </a:xfrm>
           <a:prstGeom prst="rect">
             <a:avLst/>
@@ -2875,7 +2569,7 @@
                 <a:ea typeface="Calibri" pitchFamily="34" charset="-122"/>
                 <a:cs typeface="Calibri" pitchFamily="34" charset="-120"/>
               </a:rPr>
-              <a:t>Procedure Intelligence</a:t>
+              <a:t>Early churn signals</a:t>
             </a:r>
             <a:endParaRPr lang="en-US" sz="1550" dirty="0"/>
           </a:p>
@@ -2889,8 +2583,8 @@
         </p:nvSpPr>
         <p:spPr>
           <a:xfrm>
-            <a:off x="8412480" y="3611880"/>
-            <a:ext cx="2862072" cy="457200"/>
+            <a:off x="8394192" y="3566160"/>
+            <a:ext cx="2852928" cy="457200"/>
           </a:xfrm>
           <a:prstGeom prst="rect">
             <a:avLst/>
@@ -2917,7 +2611,7 @@
                 <a:ea typeface="Calibri" pitchFamily="34" charset="-122"/>
                 <a:cs typeface="Calibri" pitchFamily="34" charset="-120"/>
               </a:rPr>
-              <a:t>Treatment mix and procedure trends by provider and location</a:t>
+              <a:t>Flag patients at risk of lapsing from care</a:t>
             </a:r>
             <a:endParaRPr lang="en-US" sz="1150" dirty="0"/>
           </a:p>
@@ -2931,8 +2625,8 @@
         </p:nvSpPr>
         <p:spPr>
           <a:xfrm>
-            <a:off x="640080" y="4443984"/>
-            <a:ext cx="3429000" cy="1938528"/>
+            <a:off x="640080" y="4425696"/>
+            <a:ext cx="3419856" cy="1938528"/>
           </a:xfrm>
           <a:prstGeom prst="roundRect">
             <a:avLst>
@@ -2965,7 +2659,7 @@
         </p:nvSpPr>
         <p:spPr>
           <a:xfrm>
-            <a:off x="932688" y="4736592"/>
+            <a:off x="932688" y="4718304"/>
             <a:ext cx="658368" cy="658368"/>
           </a:xfrm>
           <a:prstGeom prst="ellipse">
@@ -3000,7 +2694,7 @@
         </p:blipFill>
         <p:spPr>
           <a:xfrm>
-            <a:off x="1090696" y="4894600"/>
+            <a:off x="1090696" y="4876312"/>
             <a:ext cx="342351" cy="342351"/>
           </a:xfrm>
           <a:prstGeom prst="rect">
@@ -3016,8 +2710,8 @@
         </p:nvSpPr>
         <p:spPr>
           <a:xfrm>
-            <a:off x="932688" y="5522976"/>
-            <a:ext cx="2880360" cy="365760"/>
+            <a:off x="932688" y="5486400"/>
+            <a:ext cx="2871216" cy="365760"/>
           </a:xfrm>
           <a:prstGeom prst="rect">
             <a:avLst/>
@@ -3041,7 +2735,7 @@
                 <a:ea typeface="Calibri" pitchFamily="34" charset="-122"/>
                 <a:cs typeface="Calibri" pitchFamily="34" charset="-120"/>
               </a:rPr>
-              <a:t>Financial Adjustment</a:t>
+              <a:t>Revenue risk forecast</a:t>
             </a:r>
             <a:endParaRPr lang="en-US" sz="1550" dirty="0"/>
           </a:p>
@@ -3055,8 +2749,8 @@
         </p:nvSpPr>
         <p:spPr>
           <a:xfrm>
-            <a:off x="932688" y="5861304"/>
-            <a:ext cx="2862072" cy="457200"/>
+            <a:off x="932688" y="5815584"/>
+            <a:ext cx="2852928" cy="457200"/>
           </a:xfrm>
           <a:prstGeom prst="rect">
             <a:avLst/>
@@ -3083,7 +2777,7 @@
                 <a:ea typeface="Calibri" pitchFamily="34" charset="-122"/>
                 <a:cs typeface="Calibri" pitchFamily="34" charset="-120"/>
               </a:rPr>
-              <a:t>Transparency into production and collection adjustment behavior</a:t>
+              <a:t>See revenue exposure before month-end</a:t>
             </a:r>
             <a:endParaRPr lang="en-US" sz="1150" dirty="0"/>
           </a:p>
@@ -3097,8 +2791,8 @@
         </p:nvSpPr>
         <p:spPr>
           <a:xfrm>
-            <a:off x="4379976" y="4443984"/>
-            <a:ext cx="3429000" cy="1938528"/>
+            <a:off x="4370832" y="4425696"/>
+            <a:ext cx="3419856" cy="1938528"/>
           </a:xfrm>
           <a:prstGeom prst="roundRect">
             <a:avLst>
@@ -3131,7 +2825,7 @@
         </p:nvSpPr>
         <p:spPr>
           <a:xfrm>
-            <a:off x="4672584" y="4736592"/>
+            <a:off x="4663440" y="4718304"/>
             <a:ext cx="658368" cy="658368"/>
           </a:xfrm>
           <a:prstGeom prst="ellipse">
@@ -3166,7 +2860,7 @@
         </p:blipFill>
         <p:spPr>
           <a:xfrm>
-            <a:off x="4830592" y="4894600"/>
+            <a:off x="4821448" y="4876312"/>
             <a:ext cx="342351" cy="342351"/>
           </a:xfrm>
           <a:prstGeom prst="rect">
@@ -3182,8 +2876,8 @@
         </p:nvSpPr>
         <p:spPr>
           <a:xfrm>
-            <a:off x="4672584" y="5522976"/>
-            <a:ext cx="2880360" cy="365760"/>
+            <a:off x="4663440" y="5486400"/>
+            <a:ext cx="2871216" cy="365760"/>
           </a:xfrm>
           <a:prstGeom prst="rect">
             <a:avLst/>
@@ -3207,7 +2901,7 @@
                 <a:ea typeface="Calibri" pitchFamily="34" charset="-122"/>
                 <a:cs typeface="Calibri" pitchFamily="34" charset="-120"/>
               </a:rPr>
-              <a:t>Active Patient Intelligence</a:t>
+              <a:t>One unified BI layer</a:t>
             </a:r>
             <a:endParaRPr lang="en-US" sz="1550" dirty="0"/>
           </a:p>
@@ -3221,8 +2915,8 @@
         </p:nvSpPr>
         <p:spPr>
           <a:xfrm>
-            <a:off x="4672584" y="5861304"/>
-            <a:ext cx="2862072" cy="457200"/>
+            <a:off x="4663440" y="5815584"/>
+            <a:ext cx="2852928" cy="457200"/>
           </a:xfrm>
           <a:prstGeom prst="rect">
             <a:avLst/>
@@ -3249,7 +2943,7 @@
                 <a:ea typeface="Calibri" pitchFamily="34" charset="-122"/>
                 <a:cs typeface="Calibri" pitchFamily="34" charset="-120"/>
               </a:rPr>
-              <a:t>Preventive engagement tracking and long-term patient retention</a:t>
+              <a:t>Clinical, scheduling &amp; financial data in one place</a:t>
             </a:r>
             <a:endParaRPr lang="en-US" sz="1150" dirty="0"/>
           </a:p>
@@ -3263,8 +2957,8 @@
         </p:nvSpPr>
         <p:spPr>
           <a:xfrm>
-            <a:off x="8119872" y="4443984"/>
-            <a:ext cx="3429000" cy="1938528"/>
+            <a:off x="8101584" y="4425696"/>
+            <a:ext cx="3419856" cy="1938528"/>
           </a:xfrm>
           <a:prstGeom prst="roundRect">
             <a:avLst>
@@ -3297,7 +2991,7 @@
         </p:nvSpPr>
         <p:spPr>
           <a:xfrm>
-            <a:off x="8412480" y="4736592"/>
+            <a:off x="8394192" y="4718304"/>
             <a:ext cx="658368" cy="658368"/>
           </a:xfrm>
           <a:prstGeom prst="ellipse">
@@ -3332,7 +3026,7 @@
         </p:blipFill>
         <p:spPr>
           <a:xfrm>
-            <a:off x="8570488" y="4894600"/>
+            <a:off x="8552200" y="4876312"/>
             <a:ext cx="342351" cy="342351"/>
           </a:xfrm>
           <a:prstGeom prst="rect">
@@ -3348,8 +3042,8 @@
         </p:nvSpPr>
         <p:spPr>
           <a:xfrm>
-            <a:off x="8412480" y="5522976"/>
-            <a:ext cx="2880360" cy="365760"/>
+            <a:off x="8394192" y="5486400"/>
+            <a:ext cx="2871216" cy="365760"/>
           </a:xfrm>
           <a:prstGeom prst="rect">
             <a:avLst/>
@@ -3373,7 +3067,7 @@
                 <a:ea typeface="Calibri" pitchFamily="34" charset="-122"/>
                 <a:cs typeface="Calibri" pitchFamily="34" charset="-120"/>
               </a:rPr>
-              <a:t>Weekly Flash Monitoring</a:t>
+              <a:t>Ask in plain language</a:t>
             </a:r>
             <a:endParaRPr lang="en-US" sz="1550" dirty="0"/>
           </a:p>
@@ -3387,8 +3081,8 @@
         </p:nvSpPr>
         <p:spPr>
           <a:xfrm>
-            <a:off x="8412480" y="5861304"/>
-            <a:ext cx="2862072" cy="457200"/>
+            <a:off x="8394192" y="5815584"/>
+            <a:ext cx="2852928" cy="457200"/>
           </a:xfrm>
           <a:prstGeom prst="rect">
             <a:avLst/>
@@ -3407,7 +3101,7 @@
               <a:buNone/>
             </a:pPr>
             <a:r>
-              <a:rPr lang="en-US" sz="1150" dirty="0">
+              <a:rPr lang="en-US" sz="1150" i="1" dirty="0">
                 <a:solidFill>
                   <a:srgbClr val="5E777C"/>
                 </a:solidFill>
@@ -3415,7 +3109,7 @@
                 <a:ea typeface="Calibri" pitchFamily="34" charset="-122"/>
                 <a:cs typeface="Calibri" pitchFamily="34" charset="-120"/>
               </a:rPr>
-              <a:t>Daily, weekly, and month-to-date visibility for proactive control</a:t>
+              <a:t>“Why did Dr. A’s revenue drop last month?”</a:t>
             </a:r>
             <a:endParaRPr lang="en-US" sz="1150" dirty="0"/>
           </a:p>
@@ -3482,7 +3176,7 @@
         <p:spPr>
           <a:xfrm>
             <a:off x="640080" y="438912"/>
-            <a:ext cx="8229600" cy="292608"/>
+            <a:ext cx="10058400" cy="292608"/>
           </a:xfrm>
           <a:prstGeom prst="rect">
             <a:avLst/>
@@ -3506,7 +3200,7 @@
                 <a:ea typeface="Calibri" pitchFamily="34" charset="-122"/>
                 <a:cs typeface="Calibri" pitchFamily="34" charset="-120"/>
               </a:rPr>
-              <a:t>BUSINESS IMPACT &amp; STRATEGIC VALUE</a:t>
+              <a:t>THE IMPACT</a:t>
             </a:r>
             <a:endParaRPr lang="en-US" sz="1300" dirty="0"/>
           </a:p>
@@ -3521,7 +3215,7 @@
         <p:spPr>
           <a:xfrm>
             <a:off x="621792" y="758952"/>
-            <a:ext cx="11155680" cy="603504"/>
+            <a:ext cx="11247120" cy="603504"/>
           </a:xfrm>
           <a:prstGeom prst="rect">
             <a:avLst/>
@@ -3541,11 +3235,11 @@
                 <a:solidFill>
                   <a:srgbClr val="0E323B"/>
                 </a:solidFill>
-                <a:latin typeface="Georgia" pitchFamily="34" charset="0"/>
-                <a:ea typeface="Georgia" pitchFamily="34" charset="-122"/>
-                <a:cs typeface="Georgia" pitchFamily="34" charset="-120"/>
+                <a:latin typeface="Calibri" pitchFamily="34" charset="0"/>
+                <a:ea typeface="Calibri" pitchFamily="34" charset="-122"/>
+                <a:cs typeface="Calibri" pitchFamily="34" charset="-120"/>
               </a:rPr>
-              <a:t>From operational visibility to predictable, scalable growth</a:t>
+              <a:t>From static reports to predictive control</a:t>
             </a:r>
             <a:endParaRPr lang="en-US" sz="2800" dirty="0"/>
           </a:p>
@@ -3553,18 +3247,60 @@
       </p:sp>
       <p:sp>
         <p:nvSpPr>
-          <p:cNvPr id="5" name="Shape 3"/>
-          <p:cNvSpPr/>
-          <p:nvPr/>
-        </p:nvSpPr>
-        <p:spPr>
-          <a:xfrm>
-            <a:off x="640080" y="1481328"/>
-            <a:ext cx="2521458" cy="1170432"/>
+          <p:cNvPr id="5" name="Text 3"/>
+          <p:cNvSpPr/>
+          <p:nvPr/>
+        </p:nvSpPr>
+        <p:spPr>
+          <a:xfrm>
+            <a:off x="640080" y="1444752"/>
+            <a:ext cx="10881360" cy="548640"/>
+          </a:xfrm>
+          <a:prstGeom prst="rect">
+            <a:avLst/>
+          </a:prstGeom>
+          <a:noFill/>
+          <a:ln/>
+        </p:spPr>
+        <p:txBody>
+          <a:bodyPr wrap="square" lIns="0" tIns="0" rIns="0" bIns="0" rtlCol="0" anchor="ctr"/>
+          <a:lstStyle/>
+          <a:p>
+            <a:pPr algn="l" indent="0" marL="0">
+              <a:lnSpc>
+                <a:spcPct val="105000"/>
+              </a:lnSpc>
+              <a:buNone/>
+            </a:pPr>
+            <a:r>
+              <a:rPr lang="en-US" sz="1400" dirty="0">
+                <a:solidFill>
+                  <a:srgbClr val="5E777C"/>
+                </a:solidFill>
+                <a:latin typeface="Calibri" pitchFamily="34" charset="0"/>
+                <a:ea typeface="Calibri" pitchFamily="34" charset="-122"/>
+                <a:cs typeface="Calibri" pitchFamily="34" charset="-120"/>
+              </a:rPr>
+              <a:t>A multi-location dental network replaced static KPI reports with interactive dashboards and predictive analytics — and now sees risk before it spreads network-wide.</a:t>
+            </a:r>
+            <a:endParaRPr lang="en-US" sz="1400" dirty="0"/>
+          </a:p>
+        </p:txBody>
+      </p:sp>
+      <p:sp>
+        <p:nvSpPr>
+          <p:cNvPr id="6" name="Shape 4"/>
+          <p:cNvSpPr/>
+          <p:nvPr/>
+        </p:nvSpPr>
+        <p:spPr>
+          <a:xfrm>
+            <a:off x="640080" y="2286000"/>
+            <a:ext cx="2514600" cy="2286000"/>
           </a:xfrm>
           <a:prstGeom prst="roundRect">
             <a:avLst>
-              <a:gd name="adj" fmla="val 6250"/>
+              <a:gd name="adj" fmla="val 3200"/>
             </a:avLst>
           </a:prstGeom>
           <a:solidFill>
@@ -3587,14 +3323,65 @@
       </p:sp>
       <p:sp>
         <p:nvSpPr>
-          <p:cNvPr id="6" name="Text 4"/>
-          <p:cNvSpPr/>
-          <p:nvPr/>
-        </p:nvSpPr>
-        <p:spPr>
-          <a:xfrm>
-            <a:off x="731520" y="1591056"/>
-            <a:ext cx="2338578" cy="566928"/>
+          <p:cNvPr id="7" name="Shape 5"/>
+          <p:cNvSpPr/>
+          <p:nvPr/>
+        </p:nvSpPr>
+        <p:spPr>
+          <a:xfrm>
+            <a:off x="914400" y="2596896"/>
+            <a:ext cx="566928" cy="566928"/>
+          </a:xfrm>
+          <a:prstGeom prst="ellipse">
+            <a:avLst/>
+          </a:prstGeom>
+          <a:solidFill>
+            <a:srgbClr val="0B5C63"/>
+          </a:solidFill>
+          <a:ln/>
+          <a:effectLst>
+            <a:outerShdw sx="100000" sy="100000" kx="0" ky="0" algn="bl" rotWithShape="0" blurRad="101600" dist="38100" dir="8100000">
+              <a:srgbClr val="0A2A33">
+                <a:alpha val="16000"/>
+              </a:srgbClr>
+            </a:outerShdw>
+          </a:effectLst>
+        </p:spPr>
+      </p:sp>
+      <p:pic>
+        <p:nvPicPr>
+          <p:cNvPr id="8" name="Image 0" descr="preencoded.png">    </p:cNvPr>
+          <p:cNvPicPr>
+            <a:picLocks noChangeAspect="1"/>
+          </p:cNvPicPr>
+          <p:nvPr/>
+        </p:nvPicPr>
+        <p:blipFill>
+          <a:blip r:embed="rId1"/>
+          <a:stretch>
+            <a:fillRect/>
+          </a:stretch>
+        </p:blipFill>
+        <p:spPr>
+          <a:xfrm>
+            <a:off x="1050463" y="2732959"/>
+            <a:ext cx="294803" cy="294803"/>
+          </a:xfrm>
+          <a:prstGeom prst="rect">
+            <a:avLst/>
+          </a:prstGeom>
+        </p:spPr>
+      </p:pic>
+      <p:sp>
+        <p:nvSpPr>
+          <p:cNvPr id="9" name="Text 6"/>
+          <p:cNvSpPr/>
+          <p:nvPr/>
+        </p:nvSpPr>
+        <p:spPr>
+          <a:xfrm>
+            <a:off x="914400" y="3328416"/>
+            <a:ext cx="1984248" cy="548640"/>
           </a:xfrm>
           <a:prstGeom prst="rect">
             <a:avLst/>
@@ -3603,56 +3390,59 @@
           <a:ln/>
         </p:spPr>
         <p:txBody>
-          <a:bodyPr wrap="square" lIns="0" tIns="0" rIns="0" bIns="0" rtlCol="0" anchor="ctr"/>
-          <a:lstStyle/>
-          <a:p>
-            <a:pPr algn="ctr" indent="0" marL="0">
-              <a:buNone/>
-            </a:pPr>
-            <a:r>
-              <a:rPr lang="en-US" sz="3800" b="1" dirty="0">
-                <a:solidFill>
-                  <a:srgbClr val="0F8A8F"/>
-                </a:solidFill>
-                <a:latin typeface="Georgia" pitchFamily="34" charset="0"/>
-                <a:ea typeface="Georgia" pitchFamily="34" charset="-122"/>
-                <a:cs typeface="Georgia" pitchFamily="34" charset="-120"/>
-              </a:rPr>
-              <a:t>100%</a:t>
-            </a:r>
-            <a:endParaRPr lang="en-US" sz="3800" dirty="0"/>
-          </a:p>
-        </p:txBody>
-      </p:sp>
-      <p:sp>
-        <p:nvSpPr>
-          <p:cNvPr id="7" name="Text 5"/>
-          <p:cNvSpPr/>
-          <p:nvPr/>
-        </p:nvSpPr>
-        <p:spPr>
-          <a:xfrm>
-            <a:off x="786384" y="2194560"/>
-            <a:ext cx="2228850" cy="384048"/>
-          </a:xfrm>
-          <a:prstGeom prst="rect">
-            <a:avLst/>
-          </a:prstGeom>
-          <a:noFill/>
-          <a:ln/>
-        </p:spPr>
-        <p:txBody>
-          <a:bodyPr wrap="square" lIns="0" tIns="0" rIns="0" bIns="0" rtlCol="0" anchor="ctr"/>
-          <a:lstStyle/>
-          <a:p>
-            <a:pPr algn="ctr" indent="0" marL="0">
+          <a:bodyPr wrap="square" lIns="0" tIns="0" rIns="0" bIns="0" rtlCol="0" anchor="t"/>
+          <a:lstStyle/>
+          <a:p>
+            <a:pPr algn="l" indent="0" marL="0">
               <a:lnSpc>
                 <a:spcPct val="98000"/>
               </a:lnSpc>
               <a:buNone/>
             </a:pPr>
             <a:r>
-              <a:rPr lang="en-US" sz="1050" dirty="0">
+              <a:rPr lang="en-US" sz="1400" b="1" dirty="0">
+                <a:solidFill>
+                  <a:srgbClr val="0E323B"/>
+                </a:solidFill>
+                <a:latin typeface="Calibri" pitchFamily="34" charset="0"/>
+                <a:ea typeface="Calibri" pitchFamily="34" charset="-122"/>
+                <a:cs typeface="Calibri" pitchFamily="34" charset="-120"/>
+              </a:rPr>
+              <a:t>Provider-level risk, early</a:t>
+            </a:r>
+            <a:endParaRPr lang="en-US" sz="1400" dirty="0"/>
+          </a:p>
+        </p:txBody>
+      </p:sp>
+      <p:sp>
+        <p:nvSpPr>
+          <p:cNvPr id="10" name="Text 7"/>
+          <p:cNvSpPr/>
+          <p:nvPr/>
+        </p:nvSpPr>
+        <p:spPr>
+          <a:xfrm>
+            <a:off x="914400" y="3877056"/>
+            <a:ext cx="1984248" cy="603504"/>
+          </a:xfrm>
+          <a:prstGeom prst="rect">
+            <a:avLst/>
+          </a:prstGeom>
+          <a:noFill/>
+          <a:ln/>
+        </p:spPr>
+        <p:txBody>
+          <a:bodyPr wrap="square" lIns="0" tIns="0" rIns="0" bIns="0" rtlCol="0" anchor="t"/>
+          <a:lstStyle/>
+          <a:p>
+            <a:pPr algn="l" indent="0" marL="0">
+              <a:lnSpc>
+                <a:spcPct val="104000"/>
+              </a:lnSpc>
+              <a:buNone/>
+            </a:pPr>
+            <a:r>
+              <a:rPr lang="en-US" sz="1100" dirty="0">
                 <a:solidFill>
                   <a:srgbClr val="5E777C"/>
                 </a:solidFill>
@@ -3660,26 +3450,26 @@
                 <a:ea typeface="Calibri" pitchFamily="34" charset="-122"/>
                 <a:cs typeface="Calibri" pitchFamily="34" charset="-120"/>
               </a:rPr>
-              <a:t>Operational coverage, clinical to financial</a:t>
-            </a:r>
-            <a:endParaRPr lang="en-US" sz="1050" dirty="0"/>
-          </a:p>
-        </p:txBody>
-      </p:sp>
-      <p:sp>
-        <p:nvSpPr>
-          <p:cNvPr id="8" name="Shape 6"/>
-          <p:cNvSpPr/>
-          <p:nvPr/>
-        </p:nvSpPr>
-        <p:spPr>
-          <a:xfrm>
-            <a:off x="3435858" y="1481328"/>
-            <a:ext cx="2521458" cy="1170432"/>
+              <a:t>Leadership spots risky performance patterns by provider</a:t>
+            </a:r>
+            <a:endParaRPr lang="en-US" sz="1100" dirty="0"/>
+          </a:p>
+        </p:txBody>
+      </p:sp>
+      <p:sp>
+        <p:nvSpPr>
+          <p:cNvPr id="11" name="Shape 8"/>
+          <p:cNvSpPr/>
+          <p:nvPr/>
+        </p:nvSpPr>
+        <p:spPr>
+          <a:xfrm>
+            <a:off x="3429000" y="2286000"/>
+            <a:ext cx="2514600" cy="2286000"/>
           </a:xfrm>
           <a:prstGeom prst="roundRect">
             <a:avLst>
-              <a:gd name="adj" fmla="val 6250"/>
+              <a:gd name="adj" fmla="val 3200"/>
             </a:avLst>
           </a:prstGeom>
           <a:solidFill>
@@ -3702,14 +3492,65 @@
       </p:sp>
       <p:sp>
         <p:nvSpPr>
-          <p:cNvPr id="9" name="Text 7"/>
-          <p:cNvSpPr/>
-          <p:nvPr/>
-        </p:nvSpPr>
-        <p:spPr>
-          <a:xfrm>
-            <a:off x="3527298" y="1591056"/>
-            <a:ext cx="2338578" cy="566928"/>
+          <p:cNvPr id="12" name="Shape 9"/>
+          <p:cNvSpPr/>
+          <p:nvPr/>
+        </p:nvSpPr>
+        <p:spPr>
+          <a:xfrm>
+            <a:off x="3703320" y="2596896"/>
+            <a:ext cx="566928" cy="566928"/>
+          </a:xfrm>
+          <a:prstGeom prst="ellipse">
+            <a:avLst/>
+          </a:prstGeom>
+          <a:solidFill>
+            <a:srgbClr val="0B5C63"/>
+          </a:solidFill>
+          <a:ln/>
+          <a:effectLst>
+            <a:outerShdw sx="100000" sy="100000" kx="0" ky="0" algn="bl" rotWithShape="0" blurRad="101600" dist="38100" dir="8100000">
+              <a:srgbClr val="0A2A33">
+                <a:alpha val="16000"/>
+              </a:srgbClr>
+            </a:outerShdw>
+          </a:effectLst>
+        </p:spPr>
+      </p:sp>
+      <p:pic>
+        <p:nvPicPr>
+          <p:cNvPr id="13" name="Image 1" descr="preencoded.png">    </p:cNvPr>
+          <p:cNvPicPr>
+            <a:picLocks noChangeAspect="1"/>
+          </p:cNvPicPr>
+          <p:nvPr/>
+        </p:nvPicPr>
+        <p:blipFill>
+          <a:blip r:embed="rId2"/>
+          <a:stretch>
+            <a:fillRect/>
+          </a:stretch>
+        </p:blipFill>
+        <p:spPr>
+          <a:xfrm>
+            <a:off x="3839383" y="2732959"/>
+            <a:ext cx="294803" cy="294803"/>
+          </a:xfrm>
+          <a:prstGeom prst="rect">
+            <a:avLst/>
+          </a:prstGeom>
+        </p:spPr>
+      </p:pic>
+      <p:sp>
+        <p:nvSpPr>
+          <p:cNvPr id="14" name="Text 10"/>
+          <p:cNvSpPr/>
+          <p:nvPr/>
+        </p:nvSpPr>
+        <p:spPr>
+          <a:xfrm>
+            <a:off x="3703320" y="3328416"/>
+            <a:ext cx="1984248" cy="548640"/>
           </a:xfrm>
           <a:prstGeom prst="rect">
             <a:avLst/>
@@ -3718,56 +3559,59 @@
           <a:ln/>
         </p:spPr>
         <p:txBody>
-          <a:bodyPr wrap="square" lIns="0" tIns="0" rIns="0" bIns="0" rtlCol="0" anchor="ctr"/>
-          <a:lstStyle/>
-          <a:p>
-            <a:pPr algn="ctr" indent="0" marL="0">
-              <a:buNone/>
-            </a:pPr>
-            <a:r>
-              <a:rPr lang="en-US" sz="3800" b="1" dirty="0">
-                <a:solidFill>
-                  <a:srgbClr val="0F8A8F"/>
-                </a:solidFill>
-                <a:latin typeface="Georgia" pitchFamily="34" charset="0"/>
-                <a:ea typeface="Georgia" pitchFamily="34" charset="-122"/>
-                <a:cs typeface="Georgia" pitchFamily="34" charset="-120"/>
-              </a:rPr>
-              <a:t>6</a:t>
-            </a:r>
-            <a:endParaRPr lang="en-US" sz="3800" dirty="0"/>
-          </a:p>
-        </p:txBody>
-      </p:sp>
-      <p:sp>
-        <p:nvSpPr>
-          <p:cNvPr id="10" name="Text 8"/>
-          <p:cNvSpPr/>
-          <p:nvPr/>
-        </p:nvSpPr>
-        <p:spPr>
-          <a:xfrm>
-            <a:off x="3582162" y="2194560"/>
-            <a:ext cx="2228850" cy="384048"/>
-          </a:xfrm>
-          <a:prstGeom prst="rect">
-            <a:avLst/>
-          </a:prstGeom>
-          <a:noFill/>
-          <a:ln/>
-        </p:spPr>
-        <p:txBody>
-          <a:bodyPr wrap="square" lIns="0" tIns="0" rIns="0" bIns="0" rtlCol="0" anchor="ctr"/>
-          <a:lstStyle/>
-          <a:p>
-            <a:pPr algn="ctr" indent="0" marL="0">
+          <a:bodyPr wrap="square" lIns="0" tIns="0" rIns="0" bIns="0" rtlCol="0" anchor="t"/>
+          <a:lstStyle/>
+          <a:p>
+            <a:pPr algn="l" indent="0" marL="0">
               <a:lnSpc>
                 <a:spcPct val="98000"/>
               </a:lnSpc>
               <a:buNone/>
             </a:pPr>
             <a:r>
-              <a:rPr lang="en-US" sz="1050" dirty="0">
+              <a:rPr lang="en-US" sz="1400" b="1" dirty="0">
+                <a:solidFill>
+                  <a:srgbClr val="0E323B"/>
+                </a:solidFill>
+                <a:latin typeface="Calibri" pitchFamily="34" charset="0"/>
+                <a:ea typeface="Calibri" pitchFamily="34" charset="-122"/>
+                <a:cs typeface="Calibri" pitchFamily="34" charset="-120"/>
+              </a:rPr>
+              <a:t>Churn caught upstream</a:t>
+            </a:r>
+            <a:endParaRPr lang="en-US" sz="1400" dirty="0"/>
+          </a:p>
+        </p:txBody>
+      </p:sp>
+      <p:sp>
+        <p:nvSpPr>
+          <p:cNvPr id="15" name="Text 11"/>
+          <p:cNvSpPr/>
+          <p:nvPr/>
+        </p:nvSpPr>
+        <p:spPr>
+          <a:xfrm>
+            <a:off x="3703320" y="3877056"/>
+            <a:ext cx="1984248" cy="603504"/>
+          </a:xfrm>
+          <a:prstGeom prst="rect">
+            <a:avLst/>
+          </a:prstGeom>
+          <a:noFill/>
+          <a:ln/>
+        </p:spPr>
+        <p:txBody>
+          <a:bodyPr wrap="square" lIns="0" tIns="0" rIns="0" bIns="0" rtlCol="0" anchor="t"/>
+          <a:lstStyle/>
+          <a:p>
+            <a:pPr algn="l" indent="0" marL="0">
+              <a:lnSpc>
+                <a:spcPct val="104000"/>
+              </a:lnSpc>
+              <a:buNone/>
+            </a:pPr>
+            <a:r>
+              <a:rPr lang="en-US" sz="1100" dirty="0">
                 <a:solidFill>
                   <a:srgbClr val="5E777C"/>
                 </a:solidFill>
@@ -3775,26 +3619,26 @@
                 <a:ea typeface="Calibri" pitchFamily="34" charset="-122"/>
                 <a:cs typeface="Calibri" pitchFamily="34" charset="-120"/>
               </a:rPr>
-              <a:t>Integrated intelligence portfolios</a:t>
-            </a:r>
-            <a:endParaRPr lang="en-US" sz="1050" dirty="0"/>
-          </a:p>
-        </p:txBody>
-      </p:sp>
-      <p:sp>
-        <p:nvSpPr>
-          <p:cNvPr id="11" name="Shape 9"/>
-          <p:cNvSpPr/>
-          <p:nvPr/>
-        </p:nvSpPr>
-        <p:spPr>
-          <a:xfrm>
-            <a:off x="6231636" y="1481328"/>
-            <a:ext cx="2521458" cy="1170432"/>
+              <a:t>Engagement drops flagged before network-wide impact</a:t>
+            </a:r>
+            <a:endParaRPr lang="en-US" sz="1100" dirty="0"/>
+          </a:p>
+        </p:txBody>
+      </p:sp>
+      <p:sp>
+        <p:nvSpPr>
+          <p:cNvPr id="16" name="Shape 12"/>
+          <p:cNvSpPr/>
+          <p:nvPr/>
+        </p:nvSpPr>
+        <p:spPr>
+          <a:xfrm>
+            <a:off x="6217920" y="2286000"/>
+            <a:ext cx="2514600" cy="2286000"/>
           </a:xfrm>
           <a:prstGeom prst="roundRect">
             <a:avLst>
-              <a:gd name="adj" fmla="val 6250"/>
+              <a:gd name="adj" fmla="val 3200"/>
             </a:avLst>
           </a:prstGeom>
           <a:solidFill>
@@ -3817,14 +3661,65 @@
       </p:sp>
       <p:sp>
         <p:nvSpPr>
-          <p:cNvPr id="12" name="Text 10"/>
-          <p:cNvSpPr/>
-          <p:nvPr/>
-        </p:nvSpPr>
-        <p:spPr>
-          <a:xfrm>
-            <a:off x="6323076" y="1591056"/>
-            <a:ext cx="2338578" cy="566928"/>
+          <p:cNvPr id="17" name="Shape 13"/>
+          <p:cNvSpPr/>
+          <p:nvPr/>
+        </p:nvSpPr>
+        <p:spPr>
+          <a:xfrm>
+            <a:off x="6492240" y="2596896"/>
+            <a:ext cx="566928" cy="566928"/>
+          </a:xfrm>
+          <a:prstGeom prst="ellipse">
+            <a:avLst/>
+          </a:prstGeom>
+          <a:solidFill>
+            <a:srgbClr val="0B5C63"/>
+          </a:solidFill>
+          <a:ln/>
+          <a:effectLst>
+            <a:outerShdw sx="100000" sy="100000" kx="0" ky="0" algn="bl" rotWithShape="0" blurRad="101600" dist="38100" dir="8100000">
+              <a:srgbClr val="0A2A33">
+                <a:alpha val="16000"/>
+              </a:srgbClr>
+            </a:outerShdw>
+          </a:effectLst>
+        </p:spPr>
+      </p:sp>
+      <p:pic>
+        <p:nvPicPr>
+          <p:cNvPr id="18" name="Image 2" descr="preencoded.png">    </p:cNvPr>
+          <p:cNvPicPr>
+            <a:picLocks noChangeAspect="1"/>
+          </p:cNvPicPr>
+          <p:nvPr/>
+        </p:nvPicPr>
+        <p:blipFill>
+          <a:blip r:embed="rId3"/>
+          <a:stretch>
+            <a:fillRect/>
+          </a:stretch>
+        </p:blipFill>
+        <p:spPr>
+          <a:xfrm>
+            <a:off x="6628303" y="2732959"/>
+            <a:ext cx="294803" cy="294803"/>
+          </a:xfrm>
+          <a:prstGeom prst="rect">
+            <a:avLst/>
+          </a:prstGeom>
+        </p:spPr>
+      </p:pic>
+      <p:sp>
+        <p:nvSpPr>
+          <p:cNvPr id="19" name="Text 14"/>
+          <p:cNvSpPr/>
+          <p:nvPr/>
+        </p:nvSpPr>
+        <p:spPr>
+          <a:xfrm>
+            <a:off x="6492240" y="3328416"/>
+            <a:ext cx="1984248" cy="548640"/>
           </a:xfrm>
           <a:prstGeom prst="rect">
             <a:avLst/>
@@ -3833,56 +3728,59 @@
           <a:ln/>
         </p:spPr>
         <p:txBody>
-          <a:bodyPr wrap="square" lIns="0" tIns="0" rIns="0" bIns="0" rtlCol="0" anchor="ctr"/>
-          <a:lstStyle/>
-          <a:p>
-            <a:pPr algn="ctr" indent="0" marL="0">
-              <a:buNone/>
-            </a:pPr>
-            <a:r>
-              <a:rPr lang="en-US" sz="3800" b="1" dirty="0">
-                <a:solidFill>
-                  <a:srgbClr val="0F8A8F"/>
-                </a:solidFill>
-                <a:latin typeface="Georgia" pitchFamily="34" charset="0"/>
-                <a:ea typeface="Georgia" pitchFamily="34" charset="-122"/>
-                <a:cs typeface="Georgia" pitchFamily="34" charset="-120"/>
-              </a:rPr>
-              <a:t>15+</a:t>
-            </a:r>
-            <a:endParaRPr lang="en-US" sz="3800" dirty="0"/>
-          </a:p>
-        </p:txBody>
-      </p:sp>
-      <p:sp>
-        <p:nvSpPr>
-          <p:cNvPr id="13" name="Text 11"/>
-          <p:cNvSpPr/>
-          <p:nvPr/>
-        </p:nvSpPr>
-        <p:spPr>
-          <a:xfrm>
-            <a:off x="6377940" y="2194560"/>
-            <a:ext cx="2228850" cy="384048"/>
-          </a:xfrm>
-          <a:prstGeom prst="rect">
-            <a:avLst/>
-          </a:prstGeom>
-          <a:noFill/>
-          <a:ln/>
-        </p:spPr>
-        <p:txBody>
-          <a:bodyPr wrap="square" lIns="0" tIns="0" rIns="0" bIns="0" rtlCol="0" anchor="ctr"/>
-          <a:lstStyle/>
-          <a:p>
-            <a:pPr algn="ctr" indent="0" marL="0">
+          <a:bodyPr wrap="square" lIns="0" tIns="0" rIns="0" bIns="0" rtlCol="0" anchor="t"/>
+          <a:lstStyle/>
+          <a:p>
+            <a:pPr algn="l" indent="0" marL="0">
               <a:lnSpc>
                 <a:spcPct val="98000"/>
               </a:lnSpc>
               <a:buNone/>
             </a:pPr>
             <a:r>
-              <a:rPr lang="en-US" sz="1050" dirty="0">
+              <a:rPr lang="en-US" sz="1400" b="1" dirty="0">
+                <a:solidFill>
+                  <a:srgbClr val="0E323B"/>
+                </a:solidFill>
+                <a:latin typeface="Calibri" pitchFamily="34" charset="0"/>
+                <a:ea typeface="Calibri" pitchFamily="34" charset="-122"/>
+                <a:cs typeface="Calibri" pitchFamily="34" charset="-120"/>
+              </a:rPr>
+              <a:t>Real-time visibility</a:t>
+            </a:r>
+            <a:endParaRPr lang="en-US" sz="1400" dirty="0"/>
+          </a:p>
+        </p:txBody>
+      </p:sp>
+      <p:sp>
+        <p:nvSpPr>
+          <p:cNvPr id="20" name="Text 15"/>
+          <p:cNvSpPr/>
+          <p:nvPr/>
+        </p:nvSpPr>
+        <p:spPr>
+          <a:xfrm>
+            <a:off x="6492240" y="3877056"/>
+            <a:ext cx="1984248" cy="603504"/>
+          </a:xfrm>
+          <a:prstGeom prst="rect">
+            <a:avLst/>
+          </a:prstGeom>
+          <a:noFill/>
+          <a:ln/>
+        </p:spPr>
+        <p:txBody>
+          <a:bodyPr wrap="square" lIns="0" tIns="0" rIns="0" bIns="0" rtlCol="0" anchor="t"/>
+          <a:lstStyle/>
+          <a:p>
+            <a:pPr algn="l" indent="0" marL="0">
+              <a:lnSpc>
+                <a:spcPct val="104000"/>
+              </a:lnSpc>
+              <a:buNone/>
+            </a:pPr>
+            <a:r>
+              <a:rPr lang="en-US" sz="1100" dirty="0">
                 <a:solidFill>
                   <a:srgbClr val="5E777C"/>
                 </a:solidFill>
@@ -3890,26 +3788,26 @@
                 <a:ea typeface="Calibri" pitchFamily="34" charset="-122"/>
                 <a:cs typeface="Calibri" pitchFamily="34" charset="-120"/>
               </a:rPr>
-              <a:t>Connected performance dashboards</a:t>
-            </a:r>
-            <a:endParaRPr lang="en-US" sz="1050" dirty="0"/>
-          </a:p>
-        </p:txBody>
-      </p:sp>
-      <p:sp>
-        <p:nvSpPr>
-          <p:cNvPr id="14" name="Shape 12"/>
-          <p:cNvSpPr/>
-          <p:nvPr/>
-        </p:nvSpPr>
-        <p:spPr>
-          <a:xfrm>
-            <a:off x="9027414" y="1481328"/>
-            <a:ext cx="2521458" cy="1170432"/>
+              <a:t>Live dashboards replace days-late KPI reports</a:t>
+            </a:r>
+            <a:endParaRPr lang="en-US" sz="1100" dirty="0"/>
+          </a:p>
+        </p:txBody>
+      </p:sp>
+      <p:sp>
+        <p:nvSpPr>
+          <p:cNvPr id="21" name="Shape 16"/>
+          <p:cNvSpPr/>
+          <p:nvPr/>
+        </p:nvSpPr>
+        <p:spPr>
+          <a:xfrm>
+            <a:off x="9006840" y="2286000"/>
+            <a:ext cx="2514600" cy="2286000"/>
           </a:xfrm>
           <a:prstGeom prst="roundRect">
             <a:avLst>
-              <a:gd name="adj" fmla="val 6250"/>
+              <a:gd name="adj" fmla="val 3200"/>
             </a:avLst>
           </a:prstGeom>
           <a:solidFill>
@@ -3932,110 +3830,22 @@
       </p:sp>
       <p:sp>
         <p:nvSpPr>
-          <p:cNvPr id="15" name="Text 13"/>
-          <p:cNvSpPr/>
-          <p:nvPr/>
-        </p:nvSpPr>
-        <p:spPr>
-          <a:xfrm>
-            <a:off x="9118854" y="1591056"/>
-            <a:ext cx="2338578" cy="566928"/>
-          </a:xfrm>
-          <a:prstGeom prst="rect">
-            <a:avLst/>
-          </a:prstGeom>
-          <a:noFill/>
-          <a:ln/>
-        </p:spPr>
-        <p:txBody>
-          <a:bodyPr wrap="square" lIns="0" tIns="0" rIns="0" bIns="0" rtlCol="0" anchor="ctr"/>
-          <a:lstStyle/>
-          <a:p>
-            <a:pPr algn="ctr" indent="0" marL="0">
-              <a:buNone/>
-            </a:pPr>
-            <a:r>
-              <a:rPr lang="en-US" sz="3800" b="1" dirty="0">
-                <a:solidFill>
-                  <a:srgbClr val="0F8A8F"/>
-                </a:solidFill>
-                <a:latin typeface="Georgia" pitchFamily="34" charset="0"/>
-                <a:ea typeface="Georgia" pitchFamily="34" charset="-122"/>
-                <a:cs typeface="Georgia" pitchFamily="34" charset="-120"/>
-              </a:rPr>
-              <a:t>3</a:t>
-            </a:r>
-            <a:endParaRPr lang="en-US" sz="3800" dirty="0"/>
-          </a:p>
-        </p:txBody>
-      </p:sp>
-      <p:sp>
-        <p:nvSpPr>
-          <p:cNvPr id="16" name="Text 14"/>
-          <p:cNvSpPr/>
-          <p:nvPr/>
-        </p:nvSpPr>
-        <p:spPr>
-          <a:xfrm>
-            <a:off x="9173718" y="2194560"/>
-            <a:ext cx="2228850" cy="384048"/>
-          </a:xfrm>
-          <a:prstGeom prst="rect">
-            <a:avLst/>
-          </a:prstGeom>
-          <a:noFill/>
-          <a:ln/>
-        </p:spPr>
-        <p:txBody>
-          <a:bodyPr wrap="square" lIns="0" tIns="0" rIns="0" bIns="0" rtlCol="0" anchor="ctr"/>
-          <a:lstStyle/>
-          <a:p>
-            <a:pPr algn="ctr" indent="0" marL="0">
-              <a:lnSpc>
-                <a:spcPct val="98000"/>
-              </a:lnSpc>
-              <a:buNone/>
-            </a:pPr>
-            <a:r>
-              <a:rPr lang="en-US" sz="1050" dirty="0">
-                <a:solidFill>
-                  <a:srgbClr val="5E777C"/>
-                </a:solidFill>
-                <a:latin typeface="Calibri" pitchFamily="34" charset="0"/>
-                <a:ea typeface="Calibri" pitchFamily="34" charset="-122"/>
-                <a:cs typeface="Calibri" pitchFamily="34" charset="-120"/>
-              </a:rPr>
-              <a:t>Levels of decision intelligence</a:t>
-            </a:r>
-            <a:endParaRPr lang="en-US" sz="1050" dirty="0"/>
-          </a:p>
-        </p:txBody>
-      </p:sp>
-      <p:sp>
-        <p:nvSpPr>
-          <p:cNvPr id="17" name="Shape 15"/>
-          <p:cNvSpPr/>
-          <p:nvPr/>
-        </p:nvSpPr>
-        <p:spPr>
-          <a:xfrm>
-            <a:off x="640080" y="2852928"/>
-            <a:ext cx="2521458" cy="2212848"/>
-          </a:xfrm>
-          <a:prstGeom prst="roundRect">
-            <a:avLst>
-              <a:gd name="adj" fmla="val 3306"/>
-            </a:avLst>
-          </a:prstGeom>
-          <a:solidFill>
-            <a:srgbClr val="FFFFFF"/>
-          </a:solidFill>
-          <a:ln w="12700">
-            <a:solidFill>
-              <a:srgbClr val="DDEAEC"/>
-            </a:solidFill>
-            <a:prstDash val="solid"/>
-          </a:ln>
+          <p:cNvPr id="22" name="Shape 17"/>
+          <p:cNvSpPr/>
+          <p:nvPr/>
+        </p:nvSpPr>
+        <p:spPr>
+          <a:xfrm>
+            <a:off x="9281160" y="2596896"/>
+            <a:ext cx="566928" cy="566928"/>
+          </a:xfrm>
+          <a:prstGeom prst="ellipse">
+            <a:avLst/>
+          </a:prstGeom>
+          <a:solidFill>
+            <a:srgbClr val="0B5C63"/>
+          </a:solidFill>
+          <a:ln/>
           <a:effectLst>
             <a:outerShdw sx="100000" sy="100000" kx="0" ky="0" algn="bl" rotWithShape="0" blurRad="101600" dist="38100" dir="8100000">
               <a:srgbClr val="0A2A33">
@@ -4045,51 +3855,24 @@
           </a:effectLst>
         </p:spPr>
       </p:sp>
-      <p:sp>
-        <p:nvSpPr>
-          <p:cNvPr id="18" name="Shape 16"/>
-          <p:cNvSpPr/>
-          <p:nvPr/>
-        </p:nvSpPr>
-        <p:spPr>
-          <a:xfrm>
-            <a:off x="914400" y="3127248"/>
-            <a:ext cx="530352" cy="530352"/>
-          </a:xfrm>
-          <a:prstGeom prst="ellipse">
-            <a:avLst/>
-          </a:prstGeom>
-          <a:solidFill>
-            <a:srgbClr val="0B5C63"/>
-          </a:solidFill>
-          <a:ln/>
-          <a:effectLst>
-            <a:outerShdw sx="100000" sy="100000" kx="0" ky="0" algn="bl" rotWithShape="0" blurRad="101600" dist="38100" dir="8100000">
-              <a:srgbClr val="0A2A33">
-                <a:alpha val="16000"/>
-              </a:srgbClr>
-            </a:outerShdw>
-          </a:effectLst>
-        </p:spPr>
-      </p:sp>
       <p:pic>
         <p:nvPicPr>
-          <p:cNvPr id="19" name="Image 0" descr="preencoded.png">    </p:cNvPr>
+          <p:cNvPr id="23" name="Image 3" descr="preencoded.png">    </p:cNvPr>
           <p:cNvPicPr>
             <a:picLocks noChangeAspect="1"/>
           </p:cNvPicPr>
           <p:nvPr/>
         </p:nvPicPr>
         <p:blipFill>
-          <a:blip r:embed="rId1"/>
+          <a:blip r:embed="rId4"/>
           <a:stretch>
             <a:fillRect/>
           </a:stretch>
         </p:blipFill>
         <p:spPr>
           <a:xfrm>
-            <a:off x="1041684" y="3254532"/>
-            <a:ext cx="275783" cy="275783"/>
+            <a:off x="9417223" y="2732959"/>
+            <a:ext cx="294803" cy="294803"/>
           </a:xfrm>
           <a:prstGeom prst="rect">
             <a:avLst/>
@@ -4098,14 +3881,14 @@
       </p:pic>
       <p:sp>
         <p:nvSpPr>
-          <p:cNvPr id="20" name="Text 17"/>
-          <p:cNvSpPr/>
-          <p:nvPr/>
-        </p:nvSpPr>
-        <p:spPr>
-          <a:xfrm>
-            <a:off x="1554480" y="3127248"/>
-            <a:ext cx="1442466" cy="530352"/>
+          <p:cNvPr id="24" name="Text 18"/>
+          <p:cNvSpPr/>
+          <p:nvPr/>
+        </p:nvSpPr>
+        <p:spPr>
+          <a:xfrm>
+            <a:off x="9281160" y="3328416"/>
+            <a:ext cx="1984248" cy="548640"/>
           </a:xfrm>
           <a:prstGeom prst="rect">
             <a:avLst/>
@@ -4114,14 +3897,17 @@
           <a:ln/>
         </p:spPr>
         <p:txBody>
-          <a:bodyPr wrap="square" lIns="0" tIns="0" rIns="0" bIns="0" rtlCol="0" anchor="ctr"/>
+          <a:bodyPr wrap="square" lIns="0" tIns="0" rIns="0" bIns="0" rtlCol="0" anchor="t"/>
           <a:lstStyle/>
           <a:p>
             <a:pPr algn="l" indent="0" marL="0">
+              <a:lnSpc>
+                <a:spcPct val="98000"/>
+              </a:lnSpc>
               <a:buNone/>
             </a:pPr>
             <a:r>
-              <a:rPr lang="en-US" sz="1350" b="1" dirty="0">
+              <a:rPr lang="en-US" sz="1400" b="1" dirty="0">
                 <a:solidFill>
                   <a:srgbClr val="0E323B"/>
                 </a:solidFill>
@@ -4129,22 +3915,22 @@
                 <a:ea typeface="Calibri" pitchFamily="34" charset="-122"/>
                 <a:cs typeface="Calibri" pitchFamily="34" charset="-120"/>
               </a:rPr>
-              <a:t>Operational Efficiency</a:t>
-            </a:r>
-            <a:endParaRPr lang="en-US" sz="1350" dirty="0"/>
-          </a:p>
-        </p:txBody>
-      </p:sp>
-      <p:sp>
-        <p:nvSpPr>
-          <p:cNvPr id="21" name="Text 18"/>
-          <p:cNvSpPr/>
-          <p:nvPr/>
-        </p:nvSpPr>
-        <p:spPr>
-          <a:xfrm>
-            <a:off x="914400" y="3822192"/>
-            <a:ext cx="1991106" cy="1097280"/>
+              <a:t>Revenue protected</a:t>
+            </a:r>
+            <a:endParaRPr lang="en-US" sz="1400" dirty="0"/>
+          </a:p>
+        </p:txBody>
+      </p:sp>
+      <p:sp>
+        <p:nvSpPr>
+          <p:cNvPr id="25" name="Text 19"/>
+          <p:cNvSpPr/>
+          <p:nvPr/>
+        </p:nvSpPr>
+        <p:spPr>
+          <a:xfrm>
+            <a:off x="9281160" y="3877056"/>
+            <a:ext cx="1984248" cy="603504"/>
           </a:xfrm>
           <a:prstGeom prst="rect">
             <a:avLst/>
@@ -4153,12 +3939,12 @@
           <a:ln/>
         </p:spPr>
         <p:txBody>
-          <a:bodyPr wrap="square" lIns="0" tIns="0" rIns="0" bIns="0" rtlCol="0" anchor="ctr"/>
+          <a:bodyPr wrap="square" lIns="0" tIns="0" rIns="0" bIns="0" rtlCol="0" anchor="t"/>
           <a:lstStyle/>
           <a:p>
             <a:pPr algn="l" indent="0" marL="0">
               <a:lnSpc>
-                <a:spcPct val="106000"/>
+                <a:spcPct val="104000"/>
               </a:lnSpc>
               <a:buNone/>
             </a:pPr>
@@ -4171,7 +3957,7 @@
                 <a:ea typeface="Calibri" pitchFamily="34" charset="-122"/>
                 <a:cs typeface="Calibri" pitchFamily="34" charset="-120"/>
               </a:rPr>
-              <a:t>Higher chair utilization, optimized schedules, and faster response to operational disruptions.</a:t>
+              <a:t>Revenue risk forecast before the month-end close</a:t>
             </a:r>
             <a:endParaRPr lang="en-US" sz="1100" dirty="0"/>
           </a:p>
@@ -4179,29 +3965,24 @@
       </p:sp>
       <p:sp>
         <p:nvSpPr>
-          <p:cNvPr id="22" name="Shape 19"/>
-          <p:cNvSpPr/>
-          <p:nvPr/>
-        </p:nvSpPr>
-        <p:spPr>
-          <a:xfrm>
-            <a:off x="3435858" y="2852928"/>
-            <a:ext cx="2521458" cy="2212848"/>
+          <p:cNvPr id="26" name="Shape 20"/>
+          <p:cNvSpPr/>
+          <p:nvPr/>
+        </p:nvSpPr>
+        <p:spPr>
+          <a:xfrm>
+            <a:off x="640080" y="4983480"/>
+            <a:ext cx="10881360" cy="1298448"/>
           </a:xfrm>
           <a:prstGeom prst="roundRect">
             <a:avLst>
-              <a:gd name="adj" fmla="val 3306"/>
+              <a:gd name="adj" fmla="val 7042"/>
             </a:avLst>
           </a:prstGeom>
           <a:solidFill>
-            <a:srgbClr val="FFFFFF"/>
-          </a:solidFill>
-          <a:ln w="12700">
-            <a:solidFill>
-              <a:srgbClr val="DDEAEC"/>
-            </a:solidFill>
-            <a:prstDash val="solid"/>
-          </a:ln>
+            <a:srgbClr val="0A2A33"/>
+          </a:solidFill>
+          <a:ln/>
           <a:effectLst>
             <a:outerShdw sx="100000" sy="100000" kx="0" ky="0" algn="bl" rotWithShape="0" blurRad="101600" dist="38100" dir="8100000">
               <a:srgbClr val="0A2A33">
@@ -4213,507 +3994,14 @@
       </p:sp>
       <p:sp>
         <p:nvSpPr>
-          <p:cNvPr id="23" name="Shape 20"/>
-          <p:cNvSpPr/>
-          <p:nvPr/>
-        </p:nvSpPr>
-        <p:spPr>
-          <a:xfrm>
-            <a:off x="3710178" y="3127248"/>
-            <a:ext cx="530352" cy="530352"/>
-          </a:xfrm>
-          <a:prstGeom prst="ellipse">
-            <a:avLst/>
-          </a:prstGeom>
-          <a:solidFill>
-            <a:srgbClr val="0B5C63"/>
-          </a:solidFill>
-          <a:ln/>
-          <a:effectLst>
-            <a:outerShdw sx="100000" sy="100000" kx="0" ky="0" algn="bl" rotWithShape="0" blurRad="101600" dist="38100" dir="8100000">
-              <a:srgbClr val="0A2A33">
-                <a:alpha val="16000"/>
-              </a:srgbClr>
-            </a:outerShdw>
-          </a:effectLst>
-        </p:spPr>
-      </p:sp>
-      <p:pic>
-        <p:nvPicPr>
-          <p:cNvPr id="24" name="Image 1" descr="preencoded.png">    </p:cNvPr>
-          <p:cNvPicPr>
-            <a:picLocks noChangeAspect="1"/>
-          </p:cNvPicPr>
-          <p:nvPr/>
-        </p:nvPicPr>
-        <p:blipFill>
-          <a:blip r:embed="rId2"/>
-          <a:stretch>
-            <a:fillRect/>
-          </a:stretch>
-        </p:blipFill>
-        <p:spPr>
-          <a:xfrm>
-            <a:off x="3837462" y="3254532"/>
-            <a:ext cx="275783" cy="275783"/>
-          </a:xfrm>
-          <a:prstGeom prst="rect">
-            <a:avLst/>
-          </a:prstGeom>
-        </p:spPr>
-      </p:pic>
-      <p:sp>
-        <p:nvSpPr>
-          <p:cNvPr id="25" name="Text 21"/>
-          <p:cNvSpPr/>
-          <p:nvPr/>
-        </p:nvSpPr>
-        <p:spPr>
-          <a:xfrm>
-            <a:off x="4350258" y="3127248"/>
-            <a:ext cx="1442466" cy="530352"/>
-          </a:xfrm>
-          <a:prstGeom prst="rect">
-            <a:avLst/>
-          </a:prstGeom>
-          <a:noFill/>
-          <a:ln/>
-        </p:spPr>
-        <p:txBody>
-          <a:bodyPr wrap="square" lIns="0" tIns="0" rIns="0" bIns="0" rtlCol="0" anchor="ctr"/>
-          <a:lstStyle/>
-          <a:p>
-            <a:pPr algn="l" indent="0" marL="0">
-              <a:buNone/>
-            </a:pPr>
-            <a:r>
-              <a:rPr lang="en-US" sz="1350" b="1" dirty="0">
-                <a:solidFill>
-                  <a:srgbClr val="0E323B"/>
-                </a:solidFill>
-                <a:latin typeface="Calibri" pitchFamily="34" charset="0"/>
-                <a:ea typeface="Calibri" pitchFamily="34" charset="-122"/>
-                <a:cs typeface="Calibri" pitchFamily="34" charset="-120"/>
-              </a:rPr>
-              <a:t>Provider Performance</a:t>
-            </a:r>
-            <a:endParaRPr lang="en-US" sz="1350" dirty="0"/>
-          </a:p>
-        </p:txBody>
-      </p:sp>
-      <p:sp>
-        <p:nvSpPr>
-          <p:cNvPr id="26" name="Text 22"/>
-          <p:cNvSpPr/>
-          <p:nvPr/>
-        </p:nvSpPr>
-        <p:spPr>
-          <a:xfrm>
-            <a:off x="3710178" y="3822192"/>
-            <a:ext cx="1991106" cy="1097280"/>
-          </a:xfrm>
-          <a:prstGeom prst="rect">
-            <a:avLst/>
-          </a:prstGeom>
-          <a:noFill/>
-          <a:ln/>
-        </p:spPr>
-        <p:txBody>
-          <a:bodyPr wrap="square" lIns="0" tIns="0" rIns="0" bIns="0" rtlCol="0" anchor="ctr"/>
-          <a:lstStyle/>
-          <a:p>
-            <a:pPr algn="l" indent="0" marL="0">
-              <a:lnSpc>
-                <a:spcPct val="106000"/>
-              </a:lnSpc>
-              <a:buNone/>
-            </a:pPr>
-            <a:r>
-              <a:rPr lang="en-US" sz="1100" dirty="0">
-                <a:solidFill>
-                  <a:srgbClr val="5E777C"/>
-                </a:solidFill>
-                <a:latin typeface="Calibri" pitchFamily="34" charset="0"/>
-                <a:ea typeface="Calibri" pitchFamily="34" charset="-122"/>
-                <a:cs typeface="Calibri" pitchFamily="34" charset="-120"/>
-              </a:rPr>
-              <a:t>Standardized benchmarking that reduces provider variability and clarifies efficiency vs. workload.</a:t>
-            </a:r>
-            <a:endParaRPr lang="en-US" sz="1100" dirty="0"/>
-          </a:p>
-        </p:txBody>
-      </p:sp>
-      <p:sp>
-        <p:nvSpPr>
-          <p:cNvPr id="27" name="Shape 23"/>
-          <p:cNvSpPr/>
-          <p:nvPr/>
-        </p:nvSpPr>
-        <p:spPr>
-          <a:xfrm>
-            <a:off x="6231636" y="2852928"/>
-            <a:ext cx="2521458" cy="2212848"/>
-          </a:xfrm>
-          <a:prstGeom prst="roundRect">
-            <a:avLst>
-              <a:gd name="adj" fmla="val 3306"/>
-            </a:avLst>
-          </a:prstGeom>
-          <a:solidFill>
-            <a:srgbClr val="FFFFFF"/>
-          </a:solidFill>
-          <a:ln w="12700">
-            <a:solidFill>
-              <a:srgbClr val="DDEAEC"/>
-            </a:solidFill>
-            <a:prstDash val="solid"/>
-          </a:ln>
-          <a:effectLst>
-            <a:outerShdw sx="100000" sy="100000" kx="0" ky="0" algn="bl" rotWithShape="0" blurRad="101600" dist="38100" dir="8100000">
-              <a:srgbClr val="0A2A33">
-                <a:alpha val="16000"/>
-              </a:srgbClr>
-            </a:outerShdw>
-          </a:effectLst>
-        </p:spPr>
-      </p:sp>
-      <p:sp>
-        <p:nvSpPr>
-          <p:cNvPr id="28" name="Shape 24"/>
-          <p:cNvSpPr/>
-          <p:nvPr/>
-        </p:nvSpPr>
-        <p:spPr>
-          <a:xfrm>
-            <a:off x="6505956" y="3127248"/>
-            <a:ext cx="530352" cy="530352"/>
-          </a:xfrm>
-          <a:prstGeom prst="ellipse">
-            <a:avLst/>
-          </a:prstGeom>
-          <a:solidFill>
-            <a:srgbClr val="0B5C63"/>
-          </a:solidFill>
-          <a:ln/>
-          <a:effectLst>
-            <a:outerShdw sx="100000" sy="100000" kx="0" ky="0" algn="bl" rotWithShape="0" blurRad="101600" dist="38100" dir="8100000">
-              <a:srgbClr val="0A2A33">
-                <a:alpha val="16000"/>
-              </a:srgbClr>
-            </a:outerShdw>
-          </a:effectLst>
-        </p:spPr>
-      </p:sp>
-      <p:pic>
-        <p:nvPicPr>
-          <p:cNvPr id="29" name="Image 2" descr="preencoded.png">    </p:cNvPr>
-          <p:cNvPicPr>
-            <a:picLocks noChangeAspect="1"/>
-          </p:cNvPicPr>
-          <p:nvPr/>
-        </p:nvPicPr>
-        <p:blipFill>
-          <a:blip r:embed="rId3"/>
-          <a:stretch>
-            <a:fillRect/>
-          </a:stretch>
-        </p:blipFill>
-        <p:spPr>
-          <a:xfrm>
-            <a:off x="6633240" y="3254532"/>
-            <a:ext cx="275783" cy="275783"/>
-          </a:xfrm>
-          <a:prstGeom prst="rect">
-            <a:avLst/>
-          </a:prstGeom>
-        </p:spPr>
-      </p:pic>
-      <p:sp>
-        <p:nvSpPr>
-          <p:cNvPr id="30" name="Text 25"/>
-          <p:cNvSpPr/>
-          <p:nvPr/>
-        </p:nvSpPr>
-        <p:spPr>
-          <a:xfrm>
-            <a:off x="7146036" y="3127248"/>
-            <a:ext cx="1442466" cy="530352"/>
-          </a:xfrm>
-          <a:prstGeom prst="rect">
-            <a:avLst/>
-          </a:prstGeom>
-          <a:noFill/>
-          <a:ln/>
-        </p:spPr>
-        <p:txBody>
-          <a:bodyPr wrap="square" lIns="0" tIns="0" rIns="0" bIns="0" rtlCol="0" anchor="ctr"/>
-          <a:lstStyle/>
-          <a:p>
-            <a:pPr algn="l" indent="0" marL="0">
-              <a:buNone/>
-            </a:pPr>
-            <a:r>
-              <a:rPr lang="en-US" sz="1350" b="1" dirty="0">
-                <a:solidFill>
-                  <a:srgbClr val="0E323B"/>
-                </a:solidFill>
-                <a:latin typeface="Calibri" pitchFamily="34" charset="0"/>
-                <a:ea typeface="Calibri" pitchFamily="34" charset="-122"/>
-                <a:cs typeface="Calibri" pitchFamily="34" charset="-120"/>
-              </a:rPr>
-              <a:t>Financial Integrity</a:t>
-            </a:r>
-            <a:endParaRPr lang="en-US" sz="1350" dirty="0"/>
-          </a:p>
-        </p:txBody>
-      </p:sp>
-      <p:sp>
-        <p:nvSpPr>
-          <p:cNvPr id="31" name="Text 26"/>
-          <p:cNvSpPr/>
-          <p:nvPr/>
-        </p:nvSpPr>
-        <p:spPr>
-          <a:xfrm>
-            <a:off x="6505956" y="3822192"/>
-            <a:ext cx="1991106" cy="1097280"/>
-          </a:xfrm>
-          <a:prstGeom prst="rect">
-            <a:avLst/>
-          </a:prstGeom>
-          <a:noFill/>
-          <a:ln/>
-        </p:spPr>
-        <p:txBody>
-          <a:bodyPr wrap="square" lIns="0" tIns="0" rIns="0" bIns="0" rtlCol="0" anchor="ctr"/>
-          <a:lstStyle/>
-          <a:p>
-            <a:pPr algn="l" indent="0" marL="0">
-              <a:lnSpc>
-                <a:spcPct val="106000"/>
-              </a:lnSpc>
-              <a:buNone/>
-            </a:pPr>
-            <a:r>
-              <a:rPr lang="en-US" sz="1100" dirty="0">
-                <a:solidFill>
-                  <a:srgbClr val="5E777C"/>
-                </a:solidFill>
-                <a:latin typeface="Calibri" pitchFamily="34" charset="0"/>
-                <a:ea typeface="Calibri" pitchFamily="34" charset="-122"/>
-                <a:cs typeface="Calibri" pitchFamily="34" charset="-120"/>
-              </a:rPr>
-              <a:t>Tighter control of adjustment trends with full transparency into revenue-impacting activity.</a:t>
-            </a:r>
-            <a:endParaRPr lang="en-US" sz="1100" dirty="0"/>
-          </a:p>
-        </p:txBody>
-      </p:sp>
-      <p:sp>
-        <p:nvSpPr>
-          <p:cNvPr id="32" name="Shape 27"/>
-          <p:cNvSpPr/>
-          <p:nvPr/>
-        </p:nvSpPr>
-        <p:spPr>
-          <a:xfrm>
-            <a:off x="9027414" y="2852928"/>
-            <a:ext cx="2521458" cy="2212848"/>
-          </a:xfrm>
-          <a:prstGeom prst="roundRect">
-            <a:avLst>
-              <a:gd name="adj" fmla="val 3306"/>
-            </a:avLst>
-          </a:prstGeom>
-          <a:solidFill>
-            <a:srgbClr val="FFFFFF"/>
-          </a:solidFill>
-          <a:ln w="12700">
-            <a:solidFill>
-              <a:srgbClr val="DDEAEC"/>
-            </a:solidFill>
-            <a:prstDash val="solid"/>
-          </a:ln>
-          <a:effectLst>
-            <a:outerShdw sx="100000" sy="100000" kx="0" ky="0" algn="bl" rotWithShape="0" blurRad="101600" dist="38100" dir="8100000">
-              <a:srgbClr val="0A2A33">
-                <a:alpha val="16000"/>
-              </a:srgbClr>
-            </a:outerShdw>
-          </a:effectLst>
-        </p:spPr>
-      </p:sp>
-      <p:sp>
-        <p:nvSpPr>
-          <p:cNvPr id="33" name="Shape 28"/>
-          <p:cNvSpPr/>
-          <p:nvPr/>
-        </p:nvSpPr>
-        <p:spPr>
-          <a:xfrm>
-            <a:off x="9301734" y="3127248"/>
-            <a:ext cx="530352" cy="530352"/>
-          </a:xfrm>
-          <a:prstGeom prst="ellipse">
-            <a:avLst/>
-          </a:prstGeom>
-          <a:solidFill>
-            <a:srgbClr val="0B5C63"/>
-          </a:solidFill>
-          <a:ln/>
-          <a:effectLst>
-            <a:outerShdw sx="100000" sy="100000" kx="0" ky="0" algn="bl" rotWithShape="0" blurRad="101600" dist="38100" dir="8100000">
-              <a:srgbClr val="0A2A33">
-                <a:alpha val="16000"/>
-              </a:srgbClr>
-            </a:outerShdw>
-          </a:effectLst>
-        </p:spPr>
-      </p:sp>
-      <p:pic>
-        <p:nvPicPr>
-          <p:cNvPr id="34" name="Image 3" descr="preencoded.png">    </p:cNvPr>
-          <p:cNvPicPr>
-            <a:picLocks noChangeAspect="1"/>
-          </p:cNvPicPr>
-          <p:nvPr/>
-        </p:nvPicPr>
-        <p:blipFill>
-          <a:blip r:embed="rId4"/>
-          <a:stretch>
-            <a:fillRect/>
-          </a:stretch>
-        </p:blipFill>
-        <p:spPr>
-          <a:xfrm>
-            <a:off x="9429018" y="3254532"/>
-            <a:ext cx="275783" cy="275783"/>
-          </a:xfrm>
-          <a:prstGeom prst="rect">
-            <a:avLst/>
-          </a:prstGeom>
-        </p:spPr>
-      </p:pic>
-      <p:sp>
-        <p:nvSpPr>
-          <p:cNvPr id="35" name="Text 29"/>
-          <p:cNvSpPr/>
-          <p:nvPr/>
-        </p:nvSpPr>
-        <p:spPr>
-          <a:xfrm>
-            <a:off x="9941814" y="3127248"/>
-            <a:ext cx="1442466" cy="530352"/>
-          </a:xfrm>
-          <a:prstGeom prst="rect">
-            <a:avLst/>
-          </a:prstGeom>
-          <a:noFill/>
-          <a:ln/>
-        </p:spPr>
-        <p:txBody>
-          <a:bodyPr wrap="square" lIns="0" tIns="0" rIns="0" bIns="0" rtlCol="0" anchor="ctr"/>
-          <a:lstStyle/>
-          <a:p>
-            <a:pPr algn="l" indent="0" marL="0">
-              <a:buNone/>
-            </a:pPr>
-            <a:r>
-              <a:rPr lang="en-US" sz="1350" b="1" dirty="0">
-                <a:solidFill>
-                  <a:srgbClr val="0E323B"/>
-                </a:solidFill>
-                <a:latin typeface="Calibri" pitchFamily="34" charset="0"/>
-                <a:ea typeface="Calibri" pitchFamily="34" charset="-122"/>
-                <a:cs typeface="Calibri" pitchFamily="34" charset="-120"/>
-              </a:rPr>
-              <a:t>Clinical &amp; Patient</a:t>
-            </a:r>
-            <a:endParaRPr lang="en-US" sz="1350" dirty="0"/>
-          </a:p>
-        </p:txBody>
-      </p:sp>
-      <p:sp>
-        <p:nvSpPr>
-          <p:cNvPr id="36" name="Text 30"/>
-          <p:cNvSpPr/>
-          <p:nvPr/>
-        </p:nvSpPr>
-        <p:spPr>
-          <a:xfrm>
-            <a:off x="9301734" y="3822192"/>
-            <a:ext cx="1991106" cy="1097280"/>
-          </a:xfrm>
-          <a:prstGeom prst="rect">
-            <a:avLst/>
-          </a:prstGeom>
-          <a:noFill/>
-          <a:ln/>
-        </p:spPr>
-        <p:txBody>
-          <a:bodyPr wrap="square" lIns="0" tIns="0" rIns="0" bIns="0" rtlCol="0" anchor="ctr"/>
-          <a:lstStyle/>
-          <a:p>
-            <a:pPr algn="l" indent="0" marL="0">
-              <a:lnSpc>
-                <a:spcPct val="106000"/>
-              </a:lnSpc>
-              <a:buNone/>
-            </a:pPr>
-            <a:r>
-              <a:rPr lang="en-US" sz="1100" dirty="0">
-                <a:solidFill>
-                  <a:srgbClr val="5E777C"/>
-                </a:solidFill>
-                <a:latin typeface="Calibri" pitchFamily="34" charset="0"/>
-                <a:ea typeface="Calibri" pitchFamily="34" charset="-122"/>
-                <a:cs typeface="Calibri" pitchFamily="34" charset="-120"/>
-              </a:rPr>
-              <a:t>Visibility into treatment mix, with early signals of declining preventive engagement.</a:t>
-            </a:r>
-            <a:endParaRPr lang="en-US" sz="1100" dirty="0"/>
-          </a:p>
-        </p:txBody>
-      </p:sp>
-      <p:sp>
-        <p:nvSpPr>
-          <p:cNvPr id="37" name="Shape 31"/>
-          <p:cNvSpPr/>
-          <p:nvPr/>
-        </p:nvSpPr>
-        <p:spPr>
-          <a:xfrm>
-            <a:off x="640080" y="5321808"/>
-            <a:ext cx="10908792" cy="1115568"/>
-          </a:xfrm>
-          <a:prstGeom prst="roundRect">
-            <a:avLst>
-              <a:gd name="adj" fmla="val 8197"/>
-            </a:avLst>
-          </a:prstGeom>
-          <a:solidFill>
-            <a:srgbClr val="0A2A33"/>
-          </a:solidFill>
-          <a:ln/>
-          <a:effectLst>
-            <a:outerShdw sx="100000" sy="100000" kx="0" ky="0" algn="bl" rotWithShape="0" blurRad="101600" dist="38100" dir="8100000">
-              <a:srgbClr val="0A2A33">
-                <a:alpha val="16000"/>
-              </a:srgbClr>
-            </a:outerShdw>
-          </a:effectLst>
-        </p:spPr>
-      </p:sp>
-      <p:sp>
-        <p:nvSpPr>
-          <p:cNvPr id="38" name="Text 32"/>
-          <p:cNvSpPr/>
-          <p:nvPr/>
-        </p:nvSpPr>
-        <p:spPr>
-          <a:xfrm>
-            <a:off x="640080" y="5486400"/>
-            <a:ext cx="10908792" cy="256032"/>
+          <p:cNvPr id="27" name="Text 21"/>
+          <p:cNvSpPr/>
+          <p:nvPr/>
+        </p:nvSpPr>
+        <p:spPr>
+          <a:xfrm>
+            <a:off x="640080" y="5184648"/>
+            <a:ext cx="10881360" cy="256032"/>
           </a:xfrm>
           <a:prstGeom prst="rect">
             <a:avLst/>
@@ -4737,7 +4025,7 @@
                 <a:ea typeface="Calibri" pitchFamily="34" charset="-122"/>
                 <a:cs typeface="Calibri" pitchFamily="34" charset="-120"/>
               </a:rPr>
-              <a:t>THE OUTCOME</a:t>
+              <a:t>WITH LUMENORE</a:t>
             </a:r>
             <a:endParaRPr lang="en-US" sz="1200" dirty="0"/>
           </a:p>
@@ -4745,14 +4033,14 @@
       </p:sp>
       <p:sp>
         <p:nvSpPr>
-          <p:cNvPr id="39" name="Text 33"/>
-          <p:cNvSpPr/>
-          <p:nvPr/>
-        </p:nvSpPr>
-        <p:spPr>
-          <a:xfrm>
-            <a:off x="1371600" y="5779008"/>
-            <a:ext cx="9445752" cy="548640"/>
+          <p:cNvPr id="28" name="Text 22"/>
+          <p:cNvSpPr/>
+          <p:nvPr/>
+        </p:nvSpPr>
+        <p:spPr>
+          <a:xfrm>
+            <a:off x="1188720" y="5495544"/>
+            <a:ext cx="9784080" cy="548640"/>
           </a:xfrm>
           <a:prstGeom prst="rect">
             <a:avLst/>
@@ -4765,23 +4053,20 @@
           <a:lstStyle/>
           <a:p>
             <a:pPr algn="ctr" indent="0" marL="0">
-              <a:lnSpc>
-                <a:spcPct val="100000"/>
-              </a:lnSpc>
               <a:buNone/>
             </a:pPr>
             <a:r>
-              <a:rPr lang="en-US" sz="1700" b="1" dirty="0">
+              <a:rPr lang="en-US" sz="2200" b="1" dirty="0">
                 <a:solidFill>
                   <a:srgbClr val="FFFFFF"/>
                 </a:solidFill>
-                <a:latin typeface="Georgia" pitchFamily="34" charset="0"/>
-                <a:ea typeface="Georgia" pitchFamily="34" charset="-122"/>
-                <a:cs typeface="Georgia" pitchFamily="34" charset="-120"/>
+                <a:latin typeface="Calibri" pitchFamily="34" charset="0"/>
+                <a:ea typeface="Calibri" pitchFamily="34" charset="-122"/>
+                <a:cs typeface="Calibri" pitchFamily="34" charset="-120"/>
               </a:rPr>
-              <a:t>A scalable operational intelligence framework that makes dental operations measurable, optimized, and predictable.</a:t>
-            </a:r>
-            <a:endParaRPr lang="en-US" sz="1700" dirty="0"/>
+              <a:t>Predict Risk.  Prevent Churn.  Power DSO Growth.</a:t>
+            </a:r>
+            <a:endParaRPr lang="en-US" sz="2200" dirty="0"/>
           </a:p>
         </p:txBody>
       </p:sp>

</xml_diff>

<commit_message>
Add 2 slides: Enterprise Data Integration framework and KPI coverage by source (Denticon/Paylocity/Sage Intacct)
Co-authored-by: Aankitgupta <Aankitgupta@users.noreply.github.com>
</commit_message>
<xml_diff>
--- a/presentations/dental-intelligence-pitch.pptx
+++ b/presentations/dental-intelligence-pitch.pptx
@@ -8,9 +8,11 @@
     <p:sldId id="256" r:id="rId2"/>
     <p:sldId id="257" r:id="rId3"/>
     <p:sldId id="258" r:id="rId4"/>
+    <p:sldId id="259" r:id="rId5"/>
+    <p:sldId id="260" r:id="rId6"/>
   </p:sldIdLst>
   <p:notesMasterIdLst>
-    <p:notesMasterId r:id="rId5"/>
+    <p:notesMasterId r:id="rId7"/>
   </p:notesMasterIdLst>
   <p:sldSz cx="12192000" cy="6858000"/>
   <p:notesSz cx="6858000" cy="12192000"/>
@@ -722,6 +724,182 @@
 </p:notes>
 </file>
 
+<file path=ppt/notesSlides/notesSlide4.xml><?xml version="1.0" encoding="utf-8"?>
+<p:notes xmlns:a="http://schemas.openxmlformats.org/drawingml/2006/main" xmlns:r="http://schemas.openxmlformats.org/officeDocument/2006/relationships" xmlns:p="http://schemas.openxmlformats.org/presentationml/2006/main">
+  <p:cSld>
+    <p:spTree>
+      <p:nvGrpSpPr>
+        <p:cNvPr id="1" name=""/>
+        <p:cNvGrpSpPr/>
+        <p:nvPr/>
+      </p:nvGrpSpPr>
+      <p:grpSpPr>
+        <a:xfrm>
+          <a:off x="0" y="0"/>
+          <a:ext cx="0" cy="0"/>
+          <a:chOff x="0" y="0"/>
+          <a:chExt cx="0" cy="0"/>
+        </a:xfrm>
+      </p:grpSpPr>
+      <p:sp>
+        <p:nvSpPr>
+          <p:cNvPr id="2" name="Slide Image Placeholder 1"/>
+          <p:cNvSpPr>
+            <a:spLocks noGrp="1" noRot="1" noChangeAspect="1"/>
+          </p:cNvSpPr>
+          <p:nvPr>
+            <p:ph type="sldImg"/>
+          </p:nvPr>
+        </p:nvSpPr>
+        <p:spPr/>
+      </p:sp>
+      <p:sp>
+        <p:nvSpPr>
+          <p:cNvPr id="3" name="Notes Placeholder 2"/>
+          <p:cNvSpPr>
+            <a:spLocks noGrp="1"/>
+          </p:cNvSpPr>
+          <p:nvPr>
+            <p:ph type="body" idx="1"/>
+          </p:nvPr>
+        </p:nvSpPr>
+        <p:spPr/>
+        <p:txBody>
+          <a:bodyPr/>
+          <a:lstStyle/>
+          <a:p>
+            <a:r>
+              <a:rPr lang="en-US" dirty="0"/>
+              <a:t/>
+            </a:r>
+            <a:endParaRPr lang="en-US" dirty="0"/>
+          </a:p>
+        </p:txBody>
+      </p:sp>
+      <p:sp>
+        <p:nvSpPr>
+          <p:cNvPr id="4" name="Slide Number Placeholder 3"/>
+          <p:cNvSpPr>
+            <a:spLocks noGrp="1"/>
+          </p:cNvSpPr>
+          <p:nvPr>
+            <p:ph type="sldNum" sz="quarter" idx="10"/>
+          </p:nvPr>
+        </p:nvSpPr>
+        <p:spPr/>
+        <p:txBody>
+          <a:bodyPr/>
+          <a:lstStyle/>
+          <a:p>
+            <a:fld id="{F7021451-1387-4CA6-816F-3879F97B5CBC}" type="slidenum">
+              <a:rPr lang="en-US"/>
+              <a:t>4</a:t>
+            </a:fld>
+            <a:endParaRPr lang="en-US"/>
+          </a:p>
+        </p:txBody>
+      </p:sp>
+    </p:spTree>
+    <p:extLst>
+      <p:ext uri="{BB962C8B-B14F-4D97-AF65-F5344CB8AC3E}">
+        <p14:creationId xmlns:p14="http://schemas.microsoft.com/office/powerpoint/2010/main" val="1024086991"/>
+      </p:ext>
+    </p:extLst>
+  </p:cSld>
+  <p:clrMapOvr>
+    <a:masterClrMapping/>
+  </p:clrMapOvr>
+</p:notes>
+</file>
+
+<file path=ppt/notesSlides/notesSlide5.xml><?xml version="1.0" encoding="utf-8"?>
+<p:notes xmlns:a="http://schemas.openxmlformats.org/drawingml/2006/main" xmlns:r="http://schemas.openxmlformats.org/officeDocument/2006/relationships" xmlns:p="http://schemas.openxmlformats.org/presentationml/2006/main">
+  <p:cSld>
+    <p:spTree>
+      <p:nvGrpSpPr>
+        <p:cNvPr id="1" name=""/>
+        <p:cNvGrpSpPr/>
+        <p:nvPr/>
+      </p:nvGrpSpPr>
+      <p:grpSpPr>
+        <a:xfrm>
+          <a:off x="0" y="0"/>
+          <a:ext cx="0" cy="0"/>
+          <a:chOff x="0" y="0"/>
+          <a:chExt cx="0" cy="0"/>
+        </a:xfrm>
+      </p:grpSpPr>
+      <p:sp>
+        <p:nvSpPr>
+          <p:cNvPr id="2" name="Slide Image Placeholder 1"/>
+          <p:cNvSpPr>
+            <a:spLocks noGrp="1" noRot="1" noChangeAspect="1"/>
+          </p:cNvSpPr>
+          <p:nvPr>
+            <p:ph type="sldImg"/>
+          </p:nvPr>
+        </p:nvSpPr>
+        <p:spPr/>
+      </p:sp>
+      <p:sp>
+        <p:nvSpPr>
+          <p:cNvPr id="3" name="Notes Placeholder 2"/>
+          <p:cNvSpPr>
+            <a:spLocks noGrp="1"/>
+          </p:cNvSpPr>
+          <p:nvPr>
+            <p:ph type="body" idx="1"/>
+          </p:nvPr>
+        </p:nvSpPr>
+        <p:spPr/>
+        <p:txBody>
+          <a:bodyPr/>
+          <a:lstStyle/>
+          <a:p>
+            <a:r>
+              <a:rPr lang="en-US" dirty="0"/>
+              <a:t/>
+            </a:r>
+            <a:endParaRPr lang="en-US" dirty="0"/>
+          </a:p>
+        </p:txBody>
+      </p:sp>
+      <p:sp>
+        <p:nvSpPr>
+          <p:cNvPr id="4" name="Slide Number Placeholder 3"/>
+          <p:cNvSpPr>
+            <a:spLocks noGrp="1"/>
+          </p:cNvSpPr>
+          <p:nvPr>
+            <p:ph type="sldNum" sz="quarter" idx="10"/>
+          </p:nvPr>
+        </p:nvSpPr>
+        <p:spPr/>
+        <p:txBody>
+          <a:bodyPr/>
+          <a:lstStyle/>
+          <a:p>
+            <a:fld id="{F7021451-1387-4CA6-816F-3879F97B5CBC}" type="slidenum">
+              <a:rPr lang="en-US"/>
+              <a:t>5</a:t>
+            </a:fld>
+            <a:endParaRPr lang="en-US"/>
+          </a:p>
+        </p:txBody>
+      </p:sp>
+    </p:spTree>
+    <p:extLst>
+      <p:ext uri="{BB962C8B-B14F-4D97-AF65-F5344CB8AC3E}">
+        <p14:creationId xmlns:p14="http://schemas.microsoft.com/office/powerpoint/2010/main" val="1024086991"/>
+      </p:ext>
+    </p:extLst>
+  </p:cSld>
+  <p:clrMapOvr>
+    <a:masterClrMapping/>
+  </p:clrMapOvr>
+</p:notes>
+</file>
+
 <file path=ppt/slideLayouts/slideLayout1.xml><?xml version="1.0" encoding="utf-8"?>
 <p:sldLayout xmlns:a="http://schemas.openxmlformats.org/drawingml/2006/main" xmlns:r="http://schemas.openxmlformats.org/officeDocument/2006/relationships" xmlns:p="http://schemas.openxmlformats.org/presentationml/2006/main" preserve="1">
   <p:cSld name="DEFAULT">
@@ -3126,6 +3304,1956 @@
 <file path=ppt/slides/slide3.xml><?xml version="1.0" encoding="utf-8"?>
 <p:sld xmlns:a="http://schemas.openxmlformats.org/drawingml/2006/main" xmlns:r="http://schemas.openxmlformats.org/officeDocument/2006/relationships" xmlns:p="http://schemas.openxmlformats.org/presentationml/2006/main">
   <p:cSld name="Slide 3">
+    <p:bg>
+      <p:bgPr>
+        <a:solidFill>
+          <a:srgbClr val="0A2A33"/>
+        </a:solidFill>
+      </p:bgPr>
+    </p:bg>
+    <p:spTree>
+      <p:nvGrpSpPr>
+        <p:cNvPr id="1" name=""/>
+        <p:cNvGrpSpPr/>
+        <p:nvPr/>
+      </p:nvGrpSpPr>
+      <p:grpSpPr>
+        <a:xfrm>
+          <a:off x="0" y="0"/>
+          <a:ext cx="0" cy="0"/>
+          <a:chOff x="0" y="0"/>
+          <a:chExt cx="0" cy="0"/>
+        </a:xfrm>
+      </p:grpSpPr>
+      <p:sp>
+        <p:nvSpPr>
+          <p:cNvPr id="2" name="Shape 0"/>
+          <p:cNvSpPr/>
+          <p:nvPr/>
+        </p:nvSpPr>
+        <p:spPr>
+          <a:xfrm>
+            <a:off x="9784080" y="-1828800"/>
+            <a:ext cx="4206240" cy="4206240"/>
+          </a:xfrm>
+          <a:prstGeom prst="ellipse">
+            <a:avLst/>
+          </a:prstGeom>
+          <a:solidFill>
+            <a:srgbClr val="0F8A8F">
+              <a:alpha val="18000"/>
+            </a:srgbClr>
+          </a:solidFill>
+          <a:ln/>
+        </p:spPr>
+      </p:sp>
+      <p:sp>
+        <p:nvSpPr>
+          <p:cNvPr id="3" name="Shape 1"/>
+          <p:cNvSpPr/>
+          <p:nvPr/>
+        </p:nvSpPr>
+        <p:spPr>
+          <a:xfrm>
+            <a:off x="0" y="0"/>
+            <a:ext cx="146304" cy="6858000"/>
+          </a:xfrm>
+          <a:prstGeom prst="rect">
+            <a:avLst/>
+          </a:prstGeom>
+          <a:solidFill>
+            <a:srgbClr val="2DD4BF"/>
+          </a:solidFill>
+          <a:ln/>
+        </p:spPr>
+      </p:sp>
+      <p:sp>
+        <p:nvSpPr>
+          <p:cNvPr id="4" name="Text 2"/>
+          <p:cNvSpPr/>
+          <p:nvPr/>
+        </p:nvSpPr>
+        <p:spPr>
+          <a:xfrm>
+            <a:off x="640080" y="457200"/>
+            <a:ext cx="10058400" cy="292608"/>
+          </a:xfrm>
+          <a:prstGeom prst="rect">
+            <a:avLst/>
+          </a:prstGeom>
+          <a:noFill/>
+          <a:ln/>
+        </p:spPr>
+        <p:txBody>
+          <a:bodyPr wrap="square" lIns="0" tIns="0" rIns="0" bIns="0" rtlCol="0" anchor="ctr"/>
+          <a:lstStyle/>
+          <a:p>
+            <a:pPr algn="l" indent="0" marL="0">
+              <a:buNone/>
+            </a:pPr>
+            <a:r>
+              <a:rPr lang="en-US" sz="1300" b="1" spc="300" kern="0" dirty="0">
+                <a:solidFill>
+                  <a:srgbClr val="2DD4BF"/>
+                </a:solidFill>
+                <a:latin typeface="Calibri" pitchFamily="34" charset="0"/>
+                <a:ea typeface="Calibri" pitchFamily="34" charset="-122"/>
+                <a:cs typeface="Calibri" pitchFamily="34" charset="-120"/>
+              </a:rPr>
+              <a:t>ENTERPRISE DATA INTEGRATION &amp; INTELLIGENCE FRAMEWORK</a:t>
+            </a:r>
+            <a:endParaRPr lang="en-US" sz="1300" dirty="0"/>
+          </a:p>
+        </p:txBody>
+      </p:sp>
+      <p:sp>
+        <p:nvSpPr>
+          <p:cNvPr id="5" name="Text 3"/>
+          <p:cNvSpPr/>
+          <p:nvPr/>
+        </p:nvSpPr>
+        <p:spPr>
+          <a:xfrm>
+            <a:off x="621792" y="786384"/>
+            <a:ext cx="10972800" cy="640080"/>
+          </a:xfrm>
+          <a:prstGeom prst="rect">
+            <a:avLst/>
+          </a:prstGeom>
+          <a:noFill/>
+          <a:ln/>
+        </p:spPr>
+        <p:txBody>
+          <a:bodyPr wrap="square" lIns="0" tIns="0" rIns="0" bIns="0" rtlCol="0" anchor="ctr"/>
+          <a:lstStyle/>
+          <a:p>
+            <a:pPr algn="l" indent="0" marL="0">
+              <a:buNone/>
+            </a:pPr>
+            <a:r>
+              <a:rPr lang="en-US" sz="2900" b="1" dirty="0">
+                <a:solidFill>
+                  <a:srgbClr val="FFFFFF"/>
+                </a:solidFill>
+                <a:latin typeface="Calibri" pitchFamily="34" charset="0"/>
+                <a:ea typeface="Calibri" pitchFamily="34" charset="-122"/>
+                <a:cs typeface="Calibri" pitchFamily="34" charset="-120"/>
+              </a:rPr>
+              <a:t>Powering dental intelligence through unified data integration</a:t>
+            </a:r>
+            <a:endParaRPr lang="en-US" sz="2900" dirty="0"/>
+          </a:p>
+        </p:txBody>
+      </p:sp>
+      <p:sp>
+        <p:nvSpPr>
+          <p:cNvPr id="6" name="Text 4"/>
+          <p:cNvSpPr/>
+          <p:nvPr/>
+        </p:nvSpPr>
+        <p:spPr>
+          <a:xfrm>
+            <a:off x="640080" y="1517904"/>
+            <a:ext cx="10607040" cy="640080"/>
+          </a:xfrm>
+          <a:prstGeom prst="rect">
+            <a:avLst/>
+          </a:prstGeom>
+          <a:noFill/>
+          <a:ln/>
+        </p:spPr>
+        <p:txBody>
+          <a:bodyPr wrap="square" lIns="0" tIns="0" rIns="0" bIns="0" rtlCol="0" anchor="ctr"/>
+          <a:lstStyle/>
+          <a:p>
+            <a:pPr algn="l" indent="0" marL="0">
+              <a:lnSpc>
+                <a:spcPct val="106000"/>
+              </a:lnSpc>
+              <a:buNone/>
+            </a:pPr>
+            <a:r>
+              <a:rPr lang="en-US" sz="1400" dirty="0">
+                <a:solidFill>
+                  <a:srgbClr val="C7D7DA"/>
+                </a:solidFill>
+                <a:latin typeface="Calibri" pitchFamily="34" charset="0"/>
+                <a:ea typeface="Calibri" pitchFamily="34" charset="-122"/>
+                <a:cs typeface="Calibri" pitchFamily="34" charset="-120"/>
+              </a:rPr>
+              <a:t>Clinical, workforce, and financial systems integrated into one centralized intelligence ecosystem — a single source of truth across operations, providers, patients, workforce, and finance.</a:t>
+            </a:r>
+            <a:endParaRPr lang="en-US" sz="1400" dirty="0"/>
+          </a:p>
+        </p:txBody>
+      </p:sp>
+      <p:sp>
+        <p:nvSpPr>
+          <p:cNvPr id="7" name="Shape 5"/>
+          <p:cNvSpPr/>
+          <p:nvPr/>
+        </p:nvSpPr>
+        <p:spPr>
+          <a:xfrm>
+            <a:off x="640080" y="2395728"/>
+            <a:ext cx="3383280" cy="3063240"/>
+          </a:xfrm>
+          <a:prstGeom prst="roundRect">
+            <a:avLst>
+              <a:gd name="adj" fmla="val 2388"/>
+            </a:avLst>
+          </a:prstGeom>
+          <a:solidFill>
+            <a:srgbClr val="123A44"/>
+          </a:solidFill>
+          <a:ln w="12700">
+            <a:solidFill>
+              <a:srgbClr val="1C4A55"/>
+            </a:solidFill>
+            <a:prstDash val="solid"/>
+          </a:ln>
+        </p:spPr>
+      </p:sp>
+      <p:sp>
+        <p:nvSpPr>
+          <p:cNvPr id="8" name="Shape 6"/>
+          <p:cNvSpPr/>
+          <p:nvPr/>
+        </p:nvSpPr>
+        <p:spPr>
+          <a:xfrm>
+            <a:off x="1024128" y="2779776"/>
+            <a:ext cx="749808" cy="749808"/>
+          </a:xfrm>
+          <a:prstGeom prst="ellipse">
+            <a:avLst/>
+          </a:prstGeom>
+          <a:solidFill>
+            <a:srgbClr val="0F8A8F"/>
+          </a:solidFill>
+          <a:ln/>
+          <a:effectLst>
+            <a:outerShdw sx="100000" sy="100000" kx="0" ky="0" algn="bl" rotWithShape="0" blurRad="101600" dist="38100" dir="8100000">
+              <a:srgbClr val="0A2A33">
+                <a:alpha val="16000"/>
+              </a:srgbClr>
+            </a:outerShdw>
+          </a:effectLst>
+        </p:spPr>
+      </p:sp>
+      <p:pic>
+        <p:nvPicPr>
+          <p:cNvPr id="9" name="Image 0" descr="preencoded.png">    </p:cNvPr>
+          <p:cNvPicPr>
+            <a:picLocks noChangeAspect="1"/>
+          </p:cNvPicPr>
+          <p:nvPr/>
+        </p:nvPicPr>
+        <p:blipFill>
+          <a:blip r:embed="rId1"/>
+          <a:stretch>
+            <a:fillRect/>
+          </a:stretch>
+        </p:blipFill>
+        <p:spPr>
+          <a:xfrm>
+            <a:off x="1204082" y="2959730"/>
+            <a:ext cx="389900" cy="389900"/>
+          </a:xfrm>
+          <a:prstGeom prst="rect">
+            <a:avLst/>
+          </a:prstGeom>
+        </p:spPr>
+      </p:pic>
+      <p:sp>
+        <p:nvSpPr>
+          <p:cNvPr id="10" name="Text 7"/>
+          <p:cNvSpPr/>
+          <p:nvPr/>
+        </p:nvSpPr>
+        <p:spPr>
+          <a:xfrm>
+            <a:off x="1024128" y="3694176"/>
+            <a:ext cx="2651760" cy="457200"/>
+          </a:xfrm>
+          <a:prstGeom prst="rect">
+            <a:avLst/>
+          </a:prstGeom>
+          <a:noFill/>
+          <a:ln/>
+        </p:spPr>
+        <p:txBody>
+          <a:bodyPr wrap="square" lIns="0" tIns="0" rIns="0" bIns="0" rtlCol="0" anchor="ctr"/>
+          <a:lstStyle/>
+          <a:p>
+            <a:pPr algn="l" indent="0" marL="0">
+              <a:buNone/>
+            </a:pPr>
+            <a:r>
+              <a:rPr lang="en-US" sz="2000" b="1" dirty="0">
+                <a:solidFill>
+                  <a:srgbClr val="FFFFFF"/>
+                </a:solidFill>
+                <a:latin typeface="Calibri" pitchFamily="34" charset="0"/>
+                <a:ea typeface="Calibri" pitchFamily="34" charset="-122"/>
+                <a:cs typeface="Calibri" pitchFamily="34" charset="-120"/>
+              </a:rPr>
+              <a:t>Denticon</a:t>
+            </a:r>
+            <a:endParaRPr lang="en-US" sz="2000" dirty="0"/>
+          </a:p>
+        </p:txBody>
+      </p:sp>
+      <p:sp>
+        <p:nvSpPr>
+          <p:cNvPr id="11" name="Text 8"/>
+          <p:cNvSpPr/>
+          <p:nvPr/>
+        </p:nvSpPr>
+        <p:spPr>
+          <a:xfrm>
+            <a:off x="1024128" y="4169664"/>
+            <a:ext cx="2651760" cy="274320"/>
+          </a:xfrm>
+          <a:prstGeom prst="rect">
+            <a:avLst/>
+          </a:prstGeom>
+          <a:noFill/>
+          <a:ln/>
+        </p:spPr>
+        <p:txBody>
+          <a:bodyPr wrap="square" lIns="0" tIns="0" rIns="0" bIns="0" rtlCol="0" anchor="ctr"/>
+          <a:lstStyle/>
+          <a:p>
+            <a:pPr algn="l" indent="0" marL="0">
+              <a:buNone/>
+            </a:pPr>
+            <a:r>
+              <a:rPr lang="en-US" sz="1100" b="1" spc="100" kern="0" dirty="0">
+                <a:solidFill>
+                  <a:srgbClr val="2DD4BF"/>
+                </a:solidFill>
+                <a:latin typeface="Calibri" pitchFamily="34" charset="0"/>
+                <a:ea typeface="Calibri" pitchFamily="34" charset="-122"/>
+                <a:cs typeface="Calibri" pitchFamily="34" charset="-120"/>
+              </a:rPr>
+              <a:t>CLINICAL &amp; PRACTICE MANAGEMENT</a:t>
+            </a:r>
+            <a:endParaRPr lang="en-US" sz="1100" dirty="0"/>
+          </a:p>
+        </p:txBody>
+      </p:sp>
+      <p:sp>
+        <p:nvSpPr>
+          <p:cNvPr id="12" name="Text 9"/>
+          <p:cNvSpPr/>
+          <p:nvPr/>
+        </p:nvSpPr>
+        <p:spPr>
+          <a:xfrm>
+            <a:off x="1024128" y="4535424"/>
+            <a:ext cx="2633472" cy="822960"/>
+          </a:xfrm>
+          <a:prstGeom prst="rect">
+            <a:avLst/>
+          </a:prstGeom>
+          <a:noFill/>
+          <a:ln/>
+        </p:spPr>
+        <p:txBody>
+          <a:bodyPr wrap="square" lIns="0" tIns="0" rIns="0" bIns="0" rtlCol="0" anchor="t"/>
+          <a:lstStyle/>
+          <a:p>
+            <a:pPr algn="l" indent="0" marL="0">
+              <a:lnSpc>
+                <a:spcPct val="106000"/>
+              </a:lnSpc>
+              <a:buNone/>
+            </a:pPr>
+            <a:r>
+              <a:rPr lang="en-US" sz="1200" dirty="0">
+                <a:solidFill>
+                  <a:srgbClr val="9FB6BA"/>
+                </a:solidFill>
+                <a:latin typeface="Calibri" pitchFamily="34" charset="0"/>
+                <a:ea typeface="Calibri" pitchFamily="34" charset="-122"/>
+                <a:cs typeface="Calibri" pitchFamily="34" charset="-120"/>
+              </a:rPr>
+              <a:t>Patient activity, provider productivity, scheduling, procedures, and production performance across every location.</a:t>
+            </a:r>
+            <a:endParaRPr lang="en-US" sz="1200" dirty="0"/>
+          </a:p>
+        </p:txBody>
+      </p:sp>
+      <p:sp>
+        <p:nvSpPr>
+          <p:cNvPr id="13" name="Shape 10"/>
+          <p:cNvSpPr/>
+          <p:nvPr/>
+        </p:nvSpPr>
+        <p:spPr>
+          <a:xfrm>
+            <a:off x="4389120" y="2395728"/>
+            <a:ext cx="3383280" cy="3063240"/>
+          </a:xfrm>
+          <a:prstGeom prst="roundRect">
+            <a:avLst>
+              <a:gd name="adj" fmla="val 2388"/>
+            </a:avLst>
+          </a:prstGeom>
+          <a:solidFill>
+            <a:srgbClr val="123A44"/>
+          </a:solidFill>
+          <a:ln w="12700">
+            <a:solidFill>
+              <a:srgbClr val="1C4A55"/>
+            </a:solidFill>
+            <a:prstDash val="solid"/>
+          </a:ln>
+        </p:spPr>
+      </p:sp>
+      <p:sp>
+        <p:nvSpPr>
+          <p:cNvPr id="14" name="Shape 11"/>
+          <p:cNvSpPr/>
+          <p:nvPr/>
+        </p:nvSpPr>
+        <p:spPr>
+          <a:xfrm>
+            <a:off x="4773168" y="2779776"/>
+            <a:ext cx="749808" cy="749808"/>
+          </a:xfrm>
+          <a:prstGeom prst="ellipse">
+            <a:avLst/>
+          </a:prstGeom>
+          <a:solidFill>
+            <a:srgbClr val="0F8A8F"/>
+          </a:solidFill>
+          <a:ln/>
+          <a:effectLst>
+            <a:outerShdw sx="100000" sy="100000" kx="0" ky="0" algn="bl" rotWithShape="0" blurRad="101600" dist="38100" dir="8100000">
+              <a:srgbClr val="0A2A33">
+                <a:alpha val="16000"/>
+              </a:srgbClr>
+            </a:outerShdw>
+          </a:effectLst>
+        </p:spPr>
+      </p:sp>
+      <p:pic>
+        <p:nvPicPr>
+          <p:cNvPr id="15" name="Image 1" descr="preencoded.png">    </p:cNvPr>
+          <p:cNvPicPr>
+            <a:picLocks noChangeAspect="1"/>
+          </p:cNvPicPr>
+          <p:nvPr/>
+        </p:nvPicPr>
+        <p:blipFill>
+          <a:blip r:embed="rId2"/>
+          <a:stretch>
+            <a:fillRect/>
+          </a:stretch>
+        </p:blipFill>
+        <p:spPr>
+          <a:xfrm>
+            <a:off x="4953122" y="2959730"/>
+            <a:ext cx="389900" cy="389900"/>
+          </a:xfrm>
+          <a:prstGeom prst="rect">
+            <a:avLst/>
+          </a:prstGeom>
+        </p:spPr>
+      </p:pic>
+      <p:sp>
+        <p:nvSpPr>
+          <p:cNvPr id="16" name="Text 12"/>
+          <p:cNvSpPr/>
+          <p:nvPr/>
+        </p:nvSpPr>
+        <p:spPr>
+          <a:xfrm>
+            <a:off x="4773168" y="3694176"/>
+            <a:ext cx="2651760" cy="457200"/>
+          </a:xfrm>
+          <a:prstGeom prst="rect">
+            <a:avLst/>
+          </a:prstGeom>
+          <a:noFill/>
+          <a:ln/>
+        </p:spPr>
+        <p:txBody>
+          <a:bodyPr wrap="square" lIns="0" tIns="0" rIns="0" bIns="0" rtlCol="0" anchor="ctr"/>
+          <a:lstStyle/>
+          <a:p>
+            <a:pPr algn="l" indent="0" marL="0">
+              <a:buNone/>
+            </a:pPr>
+            <a:r>
+              <a:rPr lang="en-US" sz="2000" b="1" dirty="0">
+                <a:solidFill>
+                  <a:srgbClr val="FFFFFF"/>
+                </a:solidFill>
+                <a:latin typeface="Calibri" pitchFamily="34" charset="0"/>
+                <a:ea typeface="Calibri" pitchFamily="34" charset="-122"/>
+                <a:cs typeface="Calibri" pitchFamily="34" charset="-120"/>
+              </a:rPr>
+              <a:t>Paylocity</a:t>
+            </a:r>
+            <a:endParaRPr lang="en-US" sz="2000" dirty="0"/>
+          </a:p>
+        </p:txBody>
+      </p:sp>
+      <p:sp>
+        <p:nvSpPr>
+          <p:cNvPr id="17" name="Text 13"/>
+          <p:cNvSpPr/>
+          <p:nvPr/>
+        </p:nvSpPr>
+        <p:spPr>
+          <a:xfrm>
+            <a:off x="4773168" y="4169664"/>
+            <a:ext cx="2651760" cy="274320"/>
+          </a:xfrm>
+          <a:prstGeom prst="rect">
+            <a:avLst/>
+          </a:prstGeom>
+          <a:noFill/>
+          <a:ln/>
+        </p:spPr>
+        <p:txBody>
+          <a:bodyPr wrap="square" lIns="0" tIns="0" rIns="0" bIns="0" rtlCol="0" anchor="ctr"/>
+          <a:lstStyle/>
+          <a:p>
+            <a:pPr algn="l" indent="0" marL="0">
+              <a:buNone/>
+            </a:pPr>
+            <a:r>
+              <a:rPr lang="en-US" sz="1100" b="1" spc="100" kern="0" dirty="0">
+                <a:solidFill>
+                  <a:srgbClr val="2DD4BF"/>
+                </a:solidFill>
+                <a:latin typeface="Calibri" pitchFamily="34" charset="0"/>
+                <a:ea typeface="Calibri" pitchFamily="34" charset="-122"/>
+                <a:cs typeface="Calibri" pitchFamily="34" charset="-120"/>
+              </a:rPr>
+              <a:t>WORKFORCE &amp; LABOR</a:t>
+            </a:r>
+            <a:endParaRPr lang="en-US" sz="1100" dirty="0"/>
+          </a:p>
+        </p:txBody>
+      </p:sp>
+      <p:sp>
+        <p:nvSpPr>
+          <p:cNvPr id="18" name="Text 14"/>
+          <p:cNvSpPr/>
+          <p:nvPr/>
+        </p:nvSpPr>
+        <p:spPr>
+          <a:xfrm>
+            <a:off x="4773168" y="4535424"/>
+            <a:ext cx="2633472" cy="822960"/>
+          </a:xfrm>
+          <a:prstGeom prst="rect">
+            <a:avLst/>
+          </a:prstGeom>
+          <a:noFill/>
+          <a:ln/>
+        </p:spPr>
+        <p:txBody>
+          <a:bodyPr wrap="square" lIns="0" tIns="0" rIns="0" bIns="0" rtlCol="0" anchor="t"/>
+          <a:lstStyle/>
+          <a:p>
+            <a:pPr algn="l" indent="0" marL="0">
+              <a:lnSpc>
+                <a:spcPct val="106000"/>
+              </a:lnSpc>
+              <a:buNone/>
+            </a:pPr>
+            <a:r>
+              <a:rPr lang="en-US" sz="1200" dirty="0">
+                <a:solidFill>
+                  <a:srgbClr val="9FB6BA"/>
+                </a:solidFill>
+                <a:latin typeface="Calibri" pitchFamily="34" charset="0"/>
+                <a:ea typeface="Calibri" pitchFamily="34" charset="-122"/>
+                <a:cs typeface="Calibri" pitchFamily="34" charset="-120"/>
+              </a:rPr>
+              <a:t>Employee scheduling, payroll, attendance, and staffing utilization unified into the operational view.</a:t>
+            </a:r>
+            <a:endParaRPr lang="en-US" sz="1200" dirty="0"/>
+          </a:p>
+        </p:txBody>
+      </p:sp>
+      <p:sp>
+        <p:nvSpPr>
+          <p:cNvPr id="19" name="Shape 15"/>
+          <p:cNvSpPr/>
+          <p:nvPr/>
+        </p:nvSpPr>
+        <p:spPr>
+          <a:xfrm>
+            <a:off x="8138160" y="2395728"/>
+            <a:ext cx="3383280" cy="3063240"/>
+          </a:xfrm>
+          <a:prstGeom prst="roundRect">
+            <a:avLst>
+              <a:gd name="adj" fmla="val 2388"/>
+            </a:avLst>
+          </a:prstGeom>
+          <a:solidFill>
+            <a:srgbClr val="123A44"/>
+          </a:solidFill>
+          <a:ln w="12700">
+            <a:solidFill>
+              <a:srgbClr val="1C4A55"/>
+            </a:solidFill>
+            <a:prstDash val="solid"/>
+          </a:ln>
+        </p:spPr>
+      </p:sp>
+      <p:sp>
+        <p:nvSpPr>
+          <p:cNvPr id="20" name="Shape 16"/>
+          <p:cNvSpPr/>
+          <p:nvPr/>
+        </p:nvSpPr>
+        <p:spPr>
+          <a:xfrm>
+            <a:off x="8522208" y="2779776"/>
+            <a:ext cx="749808" cy="749808"/>
+          </a:xfrm>
+          <a:prstGeom prst="ellipse">
+            <a:avLst/>
+          </a:prstGeom>
+          <a:solidFill>
+            <a:srgbClr val="0F8A8F"/>
+          </a:solidFill>
+          <a:ln/>
+          <a:effectLst>
+            <a:outerShdw sx="100000" sy="100000" kx="0" ky="0" algn="bl" rotWithShape="0" blurRad="101600" dist="38100" dir="8100000">
+              <a:srgbClr val="0A2A33">
+                <a:alpha val="16000"/>
+              </a:srgbClr>
+            </a:outerShdw>
+          </a:effectLst>
+        </p:spPr>
+      </p:sp>
+      <p:pic>
+        <p:nvPicPr>
+          <p:cNvPr id="21" name="Image 2" descr="preencoded.png">    </p:cNvPr>
+          <p:cNvPicPr>
+            <a:picLocks noChangeAspect="1"/>
+          </p:cNvPicPr>
+          <p:nvPr/>
+        </p:nvPicPr>
+        <p:blipFill>
+          <a:blip r:embed="rId3"/>
+          <a:stretch>
+            <a:fillRect/>
+          </a:stretch>
+        </p:blipFill>
+        <p:spPr>
+          <a:xfrm>
+            <a:off x="8702162" y="2959730"/>
+            <a:ext cx="389900" cy="389900"/>
+          </a:xfrm>
+          <a:prstGeom prst="rect">
+            <a:avLst/>
+          </a:prstGeom>
+        </p:spPr>
+      </p:pic>
+      <p:sp>
+        <p:nvSpPr>
+          <p:cNvPr id="22" name="Text 17"/>
+          <p:cNvSpPr/>
+          <p:nvPr/>
+        </p:nvSpPr>
+        <p:spPr>
+          <a:xfrm>
+            <a:off x="8522208" y="3694176"/>
+            <a:ext cx="2651760" cy="457200"/>
+          </a:xfrm>
+          <a:prstGeom prst="rect">
+            <a:avLst/>
+          </a:prstGeom>
+          <a:noFill/>
+          <a:ln/>
+        </p:spPr>
+        <p:txBody>
+          <a:bodyPr wrap="square" lIns="0" tIns="0" rIns="0" bIns="0" rtlCol="0" anchor="ctr"/>
+          <a:lstStyle/>
+          <a:p>
+            <a:pPr algn="l" indent="0" marL="0">
+              <a:buNone/>
+            </a:pPr>
+            <a:r>
+              <a:rPr lang="en-US" sz="2000" b="1" dirty="0">
+                <a:solidFill>
+                  <a:srgbClr val="FFFFFF"/>
+                </a:solidFill>
+                <a:latin typeface="Calibri" pitchFamily="34" charset="0"/>
+                <a:ea typeface="Calibri" pitchFamily="34" charset="-122"/>
+                <a:cs typeface="Calibri" pitchFamily="34" charset="-120"/>
+              </a:rPr>
+              <a:t>Sage Intacct</a:t>
+            </a:r>
+            <a:endParaRPr lang="en-US" sz="2000" dirty="0"/>
+          </a:p>
+        </p:txBody>
+      </p:sp>
+      <p:sp>
+        <p:nvSpPr>
+          <p:cNvPr id="23" name="Text 18"/>
+          <p:cNvSpPr/>
+          <p:nvPr/>
+        </p:nvSpPr>
+        <p:spPr>
+          <a:xfrm>
+            <a:off x="8522208" y="4169664"/>
+            <a:ext cx="2651760" cy="274320"/>
+          </a:xfrm>
+          <a:prstGeom prst="rect">
+            <a:avLst/>
+          </a:prstGeom>
+          <a:noFill/>
+          <a:ln/>
+        </p:spPr>
+        <p:txBody>
+          <a:bodyPr wrap="square" lIns="0" tIns="0" rIns="0" bIns="0" rtlCol="0" anchor="ctr"/>
+          <a:lstStyle/>
+          <a:p>
+            <a:pPr algn="l" indent="0" marL="0">
+              <a:buNone/>
+            </a:pPr>
+            <a:r>
+              <a:rPr lang="en-US" sz="1100" b="1" spc="100" kern="0" dirty="0">
+                <a:solidFill>
+                  <a:srgbClr val="2DD4BF"/>
+                </a:solidFill>
+                <a:latin typeface="Calibri" pitchFamily="34" charset="0"/>
+                <a:ea typeface="Calibri" pitchFamily="34" charset="-122"/>
+                <a:cs typeface="Calibri" pitchFamily="34" charset="-120"/>
+              </a:rPr>
+              <a:t>FINANCIAL &amp; ACCOUNTING</a:t>
+            </a:r>
+            <a:endParaRPr lang="en-US" sz="1100" dirty="0"/>
+          </a:p>
+        </p:txBody>
+      </p:sp>
+      <p:sp>
+        <p:nvSpPr>
+          <p:cNvPr id="24" name="Text 19"/>
+          <p:cNvSpPr/>
+          <p:nvPr/>
+        </p:nvSpPr>
+        <p:spPr>
+          <a:xfrm>
+            <a:off x="8522208" y="4535424"/>
+            <a:ext cx="2633472" cy="822960"/>
+          </a:xfrm>
+          <a:prstGeom prst="rect">
+            <a:avLst/>
+          </a:prstGeom>
+          <a:noFill/>
+          <a:ln/>
+        </p:spPr>
+        <p:txBody>
+          <a:bodyPr wrap="square" lIns="0" tIns="0" rIns="0" bIns="0" rtlCol="0" anchor="t"/>
+          <a:lstStyle/>
+          <a:p>
+            <a:pPr algn="l" indent="0" marL="0">
+              <a:lnSpc>
+                <a:spcPct val="106000"/>
+              </a:lnSpc>
+              <a:buNone/>
+            </a:pPr>
+            <a:r>
+              <a:rPr lang="en-US" sz="1200" dirty="0">
+                <a:solidFill>
+                  <a:srgbClr val="9FB6BA"/>
+                </a:solidFill>
+                <a:latin typeface="Calibri" pitchFamily="34" charset="0"/>
+                <a:ea typeface="Calibri" pitchFamily="34" charset="-122"/>
+                <a:cs typeface="Calibri" pitchFamily="34" charset="-120"/>
+              </a:rPr>
+              <a:t>Operational profitability, expense structure, and EBITDA performance across the organization.</a:t>
+            </a:r>
+            <a:endParaRPr lang="en-US" sz="1200" dirty="0"/>
+          </a:p>
+        </p:txBody>
+      </p:sp>
+      <p:sp>
+        <p:nvSpPr>
+          <p:cNvPr id="25" name="Text 20"/>
+          <p:cNvSpPr/>
+          <p:nvPr/>
+        </p:nvSpPr>
+        <p:spPr>
+          <a:xfrm>
+            <a:off x="640080" y="5870448"/>
+            <a:ext cx="10881360" cy="365760"/>
+          </a:xfrm>
+          <a:prstGeom prst="rect">
+            <a:avLst/>
+          </a:prstGeom>
+          <a:noFill/>
+          <a:ln/>
+        </p:spPr>
+        <p:txBody>
+          <a:bodyPr wrap="square" lIns="0" tIns="0" rIns="0" bIns="0" rtlCol="0" anchor="ctr"/>
+          <a:lstStyle/>
+          <a:p>
+            <a:pPr algn="ctr" indent="0" marL="0">
+              <a:buNone/>
+            </a:pPr>
+            <a:r>
+              <a:rPr lang="en-US" sz="1350" b="1" dirty="0">
+                <a:solidFill>
+                  <a:srgbClr val="2DD4BF"/>
+                </a:solidFill>
+                <a:latin typeface="Calibri" pitchFamily="34" charset="0"/>
+                <a:ea typeface="Calibri" pitchFamily="34" charset="-122"/>
+                <a:cs typeface="Calibri" pitchFamily="34" charset="-120"/>
+              </a:rPr>
+              <a:t>Denticon  +  Paylocity  +  Sage Intacct  →  one centralized intelligence ecosystem</a:t>
+            </a:r>
+            <a:endParaRPr lang="en-US" sz="1350" dirty="0"/>
+          </a:p>
+        </p:txBody>
+      </p:sp>
+    </p:spTree>
+  </p:cSld>
+  <p:clrMapOvr>
+    <a:masterClrMapping/>
+  </p:clrMapOvr>
+</p:sld>
+</file>
+
+<file path=ppt/slides/slide4.xml><?xml version="1.0" encoding="utf-8"?>
+<p:sld xmlns:a="http://schemas.openxmlformats.org/drawingml/2006/main" xmlns:r="http://schemas.openxmlformats.org/officeDocument/2006/relationships" xmlns:p="http://schemas.openxmlformats.org/presentationml/2006/main">
+  <p:cSld name="Slide 4">
+    <p:bg>
+      <p:bgPr>
+        <a:solidFill>
+          <a:srgbClr val="F2F8F9"/>
+        </a:solidFill>
+      </p:bgPr>
+    </p:bg>
+    <p:spTree>
+      <p:nvGrpSpPr>
+        <p:cNvPr id="1" name=""/>
+        <p:cNvGrpSpPr/>
+        <p:nvPr/>
+      </p:nvGrpSpPr>
+      <p:grpSpPr>
+        <a:xfrm>
+          <a:off x="0" y="0"/>
+          <a:ext cx="0" cy="0"/>
+          <a:chOff x="0" y="0"/>
+          <a:chExt cx="0" cy="0"/>
+        </a:xfrm>
+      </p:grpSpPr>
+      <p:sp>
+        <p:nvSpPr>
+          <p:cNvPr id="2" name="Shape 0"/>
+          <p:cNvSpPr/>
+          <p:nvPr/>
+        </p:nvSpPr>
+        <p:spPr>
+          <a:xfrm>
+            <a:off x="0" y="0"/>
+            <a:ext cx="146304" cy="6858000"/>
+          </a:xfrm>
+          <a:prstGeom prst="rect">
+            <a:avLst/>
+          </a:prstGeom>
+          <a:solidFill>
+            <a:srgbClr val="0F8A8F"/>
+          </a:solidFill>
+          <a:ln/>
+        </p:spPr>
+      </p:sp>
+      <p:sp>
+        <p:nvSpPr>
+          <p:cNvPr id="3" name="Text 1"/>
+          <p:cNvSpPr/>
+          <p:nvPr/>
+        </p:nvSpPr>
+        <p:spPr>
+          <a:xfrm>
+            <a:off x="640080" y="457200"/>
+            <a:ext cx="10058400" cy="292608"/>
+          </a:xfrm>
+          <a:prstGeom prst="rect">
+            <a:avLst/>
+          </a:prstGeom>
+          <a:noFill/>
+          <a:ln/>
+        </p:spPr>
+        <p:txBody>
+          <a:bodyPr wrap="square" lIns="0" tIns="0" rIns="0" bIns="0" rtlCol="0" anchor="ctr"/>
+          <a:lstStyle/>
+          <a:p>
+            <a:pPr algn="l" indent="0" marL="0">
+              <a:buNone/>
+            </a:pPr>
+            <a:r>
+              <a:rPr lang="en-US" sz="1300" b="1" spc="300" kern="0" dirty="0">
+                <a:solidFill>
+                  <a:srgbClr val="0F8A8F"/>
+                </a:solidFill>
+                <a:latin typeface="Calibri" pitchFamily="34" charset="0"/>
+                <a:ea typeface="Calibri" pitchFamily="34" charset="-122"/>
+                <a:cs typeface="Calibri" pitchFamily="34" charset="-120"/>
+              </a:rPr>
+              <a:t>KEY KPIs &amp; INTELLIGENCE AREAS</a:t>
+            </a:r>
+            <a:endParaRPr lang="en-US" sz="1300" dirty="0"/>
+          </a:p>
+        </p:txBody>
+      </p:sp>
+      <p:sp>
+        <p:nvSpPr>
+          <p:cNvPr id="4" name="Text 2"/>
+          <p:cNvSpPr/>
+          <p:nvPr/>
+        </p:nvSpPr>
+        <p:spPr>
+          <a:xfrm>
+            <a:off x="621792" y="786384"/>
+            <a:ext cx="11247120" cy="603504"/>
+          </a:xfrm>
+          <a:prstGeom prst="rect">
+            <a:avLst/>
+          </a:prstGeom>
+          <a:noFill/>
+          <a:ln/>
+        </p:spPr>
+        <p:txBody>
+          <a:bodyPr wrap="square" lIns="0" tIns="0" rIns="0" bIns="0" rtlCol="0" anchor="ctr"/>
+          <a:lstStyle/>
+          <a:p>
+            <a:pPr algn="l" indent="0" marL="0">
+              <a:buNone/>
+            </a:pPr>
+            <a:r>
+              <a:rPr lang="en-US" sz="2800" b="1" dirty="0">
+                <a:solidFill>
+                  <a:srgbClr val="0E323B"/>
+                </a:solidFill>
+                <a:latin typeface="Calibri" pitchFamily="34" charset="0"/>
+                <a:ea typeface="Calibri" pitchFamily="34" charset="-122"/>
+                <a:cs typeface="Calibri" pitchFamily="34" charset="-120"/>
+              </a:rPr>
+              <a:t>Connected metrics across every operational dimension</a:t>
+            </a:r>
+            <a:endParaRPr lang="en-US" sz="2800" dirty="0"/>
+          </a:p>
+        </p:txBody>
+      </p:sp>
+      <p:sp>
+        <p:nvSpPr>
+          <p:cNvPr id="5" name="Text 3"/>
+          <p:cNvSpPr/>
+          <p:nvPr/>
+        </p:nvSpPr>
+        <p:spPr>
+          <a:xfrm>
+            <a:off x="640080" y="1481328"/>
+            <a:ext cx="10881360" cy="457200"/>
+          </a:xfrm>
+          <a:prstGeom prst="rect">
+            <a:avLst/>
+          </a:prstGeom>
+          <a:noFill/>
+          <a:ln/>
+        </p:spPr>
+        <p:txBody>
+          <a:bodyPr wrap="square" lIns="0" tIns="0" rIns="0" bIns="0" rtlCol="0" anchor="ctr"/>
+          <a:lstStyle/>
+          <a:p>
+            <a:pPr algn="l" indent="0" marL="0">
+              <a:lnSpc>
+                <a:spcPct val="104000"/>
+              </a:lnSpc>
+              <a:buNone/>
+            </a:pPr>
+            <a:r>
+              <a:rPr lang="en-US" sz="1400" dirty="0">
+                <a:solidFill>
+                  <a:srgbClr val="5E777C"/>
+                </a:solidFill>
+                <a:latin typeface="Calibri" pitchFamily="34" charset="0"/>
+                <a:ea typeface="Calibri" pitchFamily="34" charset="-122"/>
+                <a:cs typeface="Calibri" pitchFamily="34" charset="-120"/>
+              </a:rPr>
+              <a:t>From clinical production to labor cost to EBITDA — every KPI measured and connected in one intelligence layer.</a:t>
+            </a:r>
+            <a:endParaRPr lang="en-US" sz="1400" dirty="0"/>
+          </a:p>
+        </p:txBody>
+      </p:sp>
+      <p:sp>
+        <p:nvSpPr>
+          <p:cNvPr id="6" name="Shape 4"/>
+          <p:cNvSpPr/>
+          <p:nvPr/>
+        </p:nvSpPr>
+        <p:spPr>
+          <a:xfrm>
+            <a:off x="640080" y="2103120"/>
+            <a:ext cx="3383280" cy="4114800"/>
+          </a:xfrm>
+          <a:prstGeom prst="roundRect">
+            <a:avLst>
+              <a:gd name="adj" fmla="val 2162"/>
+            </a:avLst>
+          </a:prstGeom>
+          <a:solidFill>
+            <a:srgbClr val="FFFFFF"/>
+          </a:solidFill>
+          <a:ln w="12700">
+            <a:solidFill>
+              <a:srgbClr val="DDEAEC"/>
+            </a:solidFill>
+            <a:prstDash val="solid"/>
+          </a:ln>
+          <a:effectLst>
+            <a:outerShdw sx="100000" sy="100000" kx="0" ky="0" algn="bl" rotWithShape="0" blurRad="101600" dist="38100" dir="8100000">
+              <a:srgbClr val="0A2A33">
+                <a:alpha val="16000"/>
+              </a:srgbClr>
+            </a:outerShdw>
+          </a:effectLst>
+        </p:spPr>
+      </p:sp>
+      <p:sp>
+        <p:nvSpPr>
+          <p:cNvPr id="7" name="Shape 5"/>
+          <p:cNvSpPr/>
+          <p:nvPr/>
+        </p:nvSpPr>
+        <p:spPr>
+          <a:xfrm>
+            <a:off x="950976" y="2414016"/>
+            <a:ext cx="566928" cy="566928"/>
+          </a:xfrm>
+          <a:prstGeom prst="ellipse">
+            <a:avLst/>
+          </a:prstGeom>
+          <a:solidFill>
+            <a:srgbClr val="0F8A8F"/>
+          </a:solidFill>
+          <a:ln/>
+          <a:effectLst>
+            <a:outerShdw sx="100000" sy="100000" kx="0" ky="0" algn="bl" rotWithShape="0" blurRad="101600" dist="38100" dir="8100000">
+              <a:srgbClr val="0A2A33">
+                <a:alpha val="16000"/>
+              </a:srgbClr>
+            </a:outerShdw>
+          </a:effectLst>
+        </p:spPr>
+      </p:sp>
+      <p:pic>
+        <p:nvPicPr>
+          <p:cNvPr id="8" name="Image 0" descr="preencoded.png">    </p:cNvPr>
+          <p:cNvPicPr>
+            <a:picLocks noChangeAspect="1"/>
+          </p:cNvPicPr>
+          <p:nvPr/>
+        </p:nvPicPr>
+        <p:blipFill>
+          <a:blip r:embed="rId1"/>
+          <a:stretch>
+            <a:fillRect/>
+          </a:stretch>
+        </p:blipFill>
+        <p:spPr>
+          <a:xfrm>
+            <a:off x="1087039" y="2550079"/>
+            <a:ext cx="294803" cy="294803"/>
+          </a:xfrm>
+          <a:prstGeom prst="rect">
+            <a:avLst/>
+          </a:prstGeom>
+        </p:spPr>
+      </p:pic>
+      <p:sp>
+        <p:nvSpPr>
+          <p:cNvPr id="9" name="Text 6"/>
+          <p:cNvSpPr/>
+          <p:nvPr/>
+        </p:nvSpPr>
+        <p:spPr>
+          <a:xfrm>
+            <a:off x="1645920" y="2432304"/>
+            <a:ext cx="2194560" cy="347472"/>
+          </a:xfrm>
+          <a:prstGeom prst="rect">
+            <a:avLst/>
+          </a:prstGeom>
+          <a:noFill/>
+          <a:ln/>
+        </p:spPr>
+        <p:txBody>
+          <a:bodyPr wrap="square" lIns="0" tIns="0" rIns="0" bIns="0" rtlCol="0" anchor="ctr"/>
+          <a:lstStyle/>
+          <a:p>
+            <a:pPr algn="l" indent="0" marL="0">
+              <a:buNone/>
+            </a:pPr>
+            <a:r>
+              <a:rPr lang="en-US" sz="1700" b="1" dirty="0">
+                <a:solidFill>
+                  <a:srgbClr val="0E323B"/>
+                </a:solidFill>
+                <a:latin typeface="Calibri" pitchFamily="34" charset="0"/>
+                <a:ea typeface="Calibri" pitchFamily="34" charset="-122"/>
+                <a:cs typeface="Calibri" pitchFamily="34" charset="-120"/>
+              </a:rPr>
+              <a:t>Denticon</a:t>
+            </a:r>
+            <a:endParaRPr lang="en-US" sz="1700" dirty="0"/>
+          </a:p>
+        </p:txBody>
+      </p:sp>
+      <p:sp>
+        <p:nvSpPr>
+          <p:cNvPr id="10" name="Text 7"/>
+          <p:cNvSpPr/>
+          <p:nvPr/>
+        </p:nvSpPr>
+        <p:spPr>
+          <a:xfrm>
+            <a:off x="1645920" y="2798064"/>
+            <a:ext cx="2194560" cy="274320"/>
+          </a:xfrm>
+          <a:prstGeom prst="rect">
+            <a:avLst/>
+          </a:prstGeom>
+          <a:noFill/>
+          <a:ln/>
+        </p:spPr>
+        <p:txBody>
+          <a:bodyPr wrap="square" lIns="0" tIns="0" rIns="0" bIns="0" rtlCol="0" anchor="ctr"/>
+          <a:lstStyle/>
+          <a:p>
+            <a:pPr algn="l" indent="0" marL="0">
+              <a:buNone/>
+            </a:pPr>
+            <a:r>
+              <a:rPr lang="en-US" sz="950" b="1" spc="100" kern="0" dirty="0">
+                <a:solidFill>
+                  <a:srgbClr val="0F8A8F"/>
+                </a:solidFill>
+                <a:latin typeface="Calibri" pitchFamily="34" charset="0"/>
+                <a:ea typeface="Calibri" pitchFamily="34" charset="-122"/>
+                <a:cs typeface="Calibri" pitchFamily="34" charset="-120"/>
+              </a:rPr>
+              <a:t>CLINICAL &amp; PRACTICE MANAGEMENT</a:t>
+            </a:r>
+            <a:endParaRPr lang="en-US" sz="950" dirty="0"/>
+          </a:p>
+        </p:txBody>
+      </p:sp>
+      <p:sp>
+        <p:nvSpPr>
+          <p:cNvPr id="11" name="Shape 8"/>
+          <p:cNvSpPr/>
+          <p:nvPr/>
+        </p:nvSpPr>
+        <p:spPr>
+          <a:xfrm>
+            <a:off x="950976" y="3200400"/>
+            <a:ext cx="2761488" cy="10973"/>
+          </a:xfrm>
+          <a:prstGeom prst="rect">
+            <a:avLst/>
+          </a:prstGeom>
+          <a:solidFill>
+            <a:srgbClr val="DDEAEC"/>
+          </a:solidFill>
+          <a:ln/>
+        </p:spPr>
+      </p:sp>
+      <p:sp>
+        <p:nvSpPr>
+          <p:cNvPr id="12" name="Text 9"/>
+          <p:cNvSpPr/>
+          <p:nvPr/>
+        </p:nvSpPr>
+        <p:spPr>
+          <a:xfrm>
+            <a:off x="1005840" y="3364992"/>
+            <a:ext cx="2706624" cy="2651760"/>
+          </a:xfrm>
+          <a:prstGeom prst="rect">
+            <a:avLst/>
+          </a:prstGeom>
+          <a:noFill/>
+          <a:ln/>
+        </p:spPr>
+        <p:txBody>
+          <a:bodyPr wrap="square" lIns="0" tIns="0" rIns="0" bIns="0" rtlCol="0" anchor="t"/>
+          <a:lstStyle/>
+          <a:p>
+            <a:pPr algn="l" marL="177800" indent="-177800">
+              <a:spcAft>
+                <a:spcPts val="800"/>
+              </a:spcAft>
+              <a:buSzPct val="100000"/>
+              <a:buChar char="•"/>
+            </a:pPr>
+            <a:r>
+              <a:rPr lang="en-US" sz="1250" dirty="0">
+                <a:solidFill>
+                  <a:srgbClr val="0E323B"/>
+                </a:solidFill>
+                <a:latin typeface="Calibri" pitchFamily="34" charset="0"/>
+                <a:ea typeface="Calibri" pitchFamily="34" charset="-122"/>
+                <a:cs typeface="Calibri" pitchFamily="34" charset="-120"/>
+              </a:rPr>
+              <a:t>Gross &amp; Net Production</a:t>
+            </a:r>
+            <a:endParaRPr lang="en-US" sz="1250" dirty="0"/>
+          </a:p>
+          <a:p>
+            <a:pPr algn="l" marL="177800" indent="-177800">
+              <a:spcAft>
+                <a:spcPts val="800"/>
+              </a:spcAft>
+              <a:buSzPct val="100000"/>
+              <a:buChar char="•"/>
+            </a:pPr>
+            <a:r>
+              <a:rPr lang="en-US" sz="1250" dirty="0">
+                <a:solidFill>
+                  <a:srgbClr val="0E323B"/>
+                </a:solidFill>
+                <a:latin typeface="Calibri" pitchFamily="34" charset="0"/>
+                <a:ea typeface="Calibri" pitchFamily="34" charset="-122"/>
+                <a:cs typeface="Calibri" pitchFamily="34" charset="-120"/>
+              </a:rPr>
+              <a:t>Hygiene Utilization</a:t>
+            </a:r>
+            <a:endParaRPr lang="en-US" sz="1250" dirty="0"/>
+          </a:p>
+          <a:p>
+            <a:pPr algn="l" marL="177800" indent="-177800">
+              <a:spcAft>
+                <a:spcPts val="800"/>
+              </a:spcAft>
+              <a:buSzPct val="100000"/>
+              <a:buChar char="•"/>
+            </a:pPr>
+            <a:r>
+              <a:rPr lang="en-US" sz="1250" dirty="0">
+                <a:solidFill>
+                  <a:srgbClr val="0E323B"/>
+                </a:solidFill>
+                <a:latin typeface="Calibri" pitchFamily="34" charset="0"/>
+                <a:ea typeface="Calibri" pitchFamily="34" charset="-122"/>
+                <a:cs typeface="Calibri" pitchFamily="34" charset="-120"/>
+              </a:rPr>
+              <a:t>Provider Productivity</a:t>
+            </a:r>
+            <a:endParaRPr lang="en-US" sz="1250" dirty="0"/>
+          </a:p>
+          <a:p>
+            <a:pPr algn="l" marL="177800" indent="-177800">
+              <a:spcAft>
+                <a:spcPts val="800"/>
+              </a:spcAft>
+              <a:buSzPct val="100000"/>
+              <a:buChar char="•"/>
+            </a:pPr>
+            <a:r>
+              <a:rPr lang="en-US" sz="1250" dirty="0">
+                <a:solidFill>
+                  <a:srgbClr val="0E323B"/>
+                </a:solidFill>
+                <a:latin typeface="Calibri" pitchFamily="34" charset="0"/>
+                <a:ea typeface="Calibri" pitchFamily="34" charset="-122"/>
+                <a:cs typeface="Calibri" pitchFamily="34" charset="-120"/>
+              </a:rPr>
+              <a:t>Appointment &amp; Scheduling Trends</a:t>
+            </a:r>
+            <a:endParaRPr lang="en-US" sz="1250" dirty="0"/>
+          </a:p>
+          <a:p>
+            <a:pPr algn="l" marL="177800" indent="-177800">
+              <a:spcAft>
+                <a:spcPts val="800"/>
+              </a:spcAft>
+              <a:buSzPct val="100000"/>
+              <a:buChar char="•"/>
+            </a:pPr>
+            <a:r>
+              <a:rPr lang="en-US" sz="1250" dirty="0">
+                <a:solidFill>
+                  <a:srgbClr val="0E323B"/>
+                </a:solidFill>
+                <a:latin typeface="Calibri" pitchFamily="34" charset="0"/>
+                <a:ea typeface="Calibri" pitchFamily="34" charset="-122"/>
+                <a:cs typeface="Calibri" pitchFamily="34" charset="-120"/>
+              </a:rPr>
+              <a:t>Procedure Mix Analysis</a:t>
+            </a:r>
+            <a:endParaRPr lang="en-US" sz="1250" dirty="0"/>
+          </a:p>
+          <a:p>
+            <a:pPr algn="l" marL="177800" indent="-177800">
+              <a:spcAft>
+                <a:spcPts val="800"/>
+              </a:spcAft>
+              <a:buSzPct val="100000"/>
+              <a:buChar char="•"/>
+            </a:pPr>
+            <a:r>
+              <a:rPr lang="en-US" sz="1250" dirty="0">
+                <a:solidFill>
+                  <a:srgbClr val="0E323B"/>
+                </a:solidFill>
+                <a:latin typeface="Calibri" pitchFamily="34" charset="0"/>
+                <a:ea typeface="Calibri" pitchFamily="34" charset="-122"/>
+                <a:cs typeface="Calibri" pitchFamily="34" charset="-120"/>
+              </a:rPr>
+              <a:t>Patient Visit Volume</a:t>
+            </a:r>
+            <a:endParaRPr lang="en-US" sz="1250" dirty="0"/>
+          </a:p>
+        </p:txBody>
+      </p:sp>
+      <p:sp>
+        <p:nvSpPr>
+          <p:cNvPr id="13" name="Shape 10"/>
+          <p:cNvSpPr/>
+          <p:nvPr/>
+        </p:nvSpPr>
+        <p:spPr>
+          <a:xfrm>
+            <a:off x="4389120" y="2103120"/>
+            <a:ext cx="3383280" cy="4114800"/>
+          </a:xfrm>
+          <a:prstGeom prst="roundRect">
+            <a:avLst>
+              <a:gd name="adj" fmla="val 2162"/>
+            </a:avLst>
+          </a:prstGeom>
+          <a:solidFill>
+            <a:srgbClr val="FFFFFF"/>
+          </a:solidFill>
+          <a:ln w="12700">
+            <a:solidFill>
+              <a:srgbClr val="DDEAEC"/>
+            </a:solidFill>
+            <a:prstDash val="solid"/>
+          </a:ln>
+          <a:effectLst>
+            <a:outerShdw sx="100000" sy="100000" kx="0" ky="0" algn="bl" rotWithShape="0" blurRad="101600" dist="38100" dir="8100000">
+              <a:srgbClr val="0A2A33">
+                <a:alpha val="16000"/>
+              </a:srgbClr>
+            </a:outerShdw>
+          </a:effectLst>
+        </p:spPr>
+      </p:sp>
+      <p:sp>
+        <p:nvSpPr>
+          <p:cNvPr id="14" name="Shape 11"/>
+          <p:cNvSpPr/>
+          <p:nvPr/>
+        </p:nvSpPr>
+        <p:spPr>
+          <a:xfrm>
+            <a:off x="4700016" y="2414016"/>
+            <a:ext cx="566928" cy="566928"/>
+          </a:xfrm>
+          <a:prstGeom prst="ellipse">
+            <a:avLst/>
+          </a:prstGeom>
+          <a:solidFill>
+            <a:srgbClr val="0F8A8F"/>
+          </a:solidFill>
+          <a:ln/>
+          <a:effectLst>
+            <a:outerShdw sx="100000" sy="100000" kx="0" ky="0" algn="bl" rotWithShape="0" blurRad="101600" dist="38100" dir="8100000">
+              <a:srgbClr val="0A2A33">
+                <a:alpha val="16000"/>
+              </a:srgbClr>
+            </a:outerShdw>
+          </a:effectLst>
+        </p:spPr>
+      </p:sp>
+      <p:pic>
+        <p:nvPicPr>
+          <p:cNvPr id="15" name="Image 1" descr="preencoded.png">    </p:cNvPr>
+          <p:cNvPicPr>
+            <a:picLocks noChangeAspect="1"/>
+          </p:cNvPicPr>
+          <p:nvPr/>
+        </p:nvPicPr>
+        <p:blipFill>
+          <a:blip r:embed="rId2"/>
+          <a:stretch>
+            <a:fillRect/>
+          </a:stretch>
+        </p:blipFill>
+        <p:spPr>
+          <a:xfrm>
+            <a:off x="4836079" y="2550079"/>
+            <a:ext cx="294803" cy="294803"/>
+          </a:xfrm>
+          <a:prstGeom prst="rect">
+            <a:avLst/>
+          </a:prstGeom>
+        </p:spPr>
+      </p:pic>
+      <p:sp>
+        <p:nvSpPr>
+          <p:cNvPr id="16" name="Text 12"/>
+          <p:cNvSpPr/>
+          <p:nvPr/>
+        </p:nvSpPr>
+        <p:spPr>
+          <a:xfrm>
+            <a:off x="5394960" y="2432304"/>
+            <a:ext cx="2194560" cy="347472"/>
+          </a:xfrm>
+          <a:prstGeom prst="rect">
+            <a:avLst/>
+          </a:prstGeom>
+          <a:noFill/>
+          <a:ln/>
+        </p:spPr>
+        <p:txBody>
+          <a:bodyPr wrap="square" lIns="0" tIns="0" rIns="0" bIns="0" rtlCol="0" anchor="ctr"/>
+          <a:lstStyle/>
+          <a:p>
+            <a:pPr algn="l" indent="0" marL="0">
+              <a:buNone/>
+            </a:pPr>
+            <a:r>
+              <a:rPr lang="en-US" sz="1700" b="1" dirty="0">
+                <a:solidFill>
+                  <a:srgbClr val="0E323B"/>
+                </a:solidFill>
+                <a:latin typeface="Calibri" pitchFamily="34" charset="0"/>
+                <a:ea typeface="Calibri" pitchFamily="34" charset="-122"/>
+                <a:cs typeface="Calibri" pitchFamily="34" charset="-120"/>
+              </a:rPr>
+              <a:t>Paylocity</a:t>
+            </a:r>
+            <a:endParaRPr lang="en-US" sz="1700" dirty="0"/>
+          </a:p>
+        </p:txBody>
+      </p:sp>
+      <p:sp>
+        <p:nvSpPr>
+          <p:cNvPr id="17" name="Text 13"/>
+          <p:cNvSpPr/>
+          <p:nvPr/>
+        </p:nvSpPr>
+        <p:spPr>
+          <a:xfrm>
+            <a:off x="5394960" y="2798064"/>
+            <a:ext cx="2194560" cy="274320"/>
+          </a:xfrm>
+          <a:prstGeom prst="rect">
+            <a:avLst/>
+          </a:prstGeom>
+          <a:noFill/>
+          <a:ln/>
+        </p:spPr>
+        <p:txBody>
+          <a:bodyPr wrap="square" lIns="0" tIns="0" rIns="0" bIns="0" rtlCol="0" anchor="ctr"/>
+          <a:lstStyle/>
+          <a:p>
+            <a:pPr algn="l" indent="0" marL="0">
+              <a:buNone/>
+            </a:pPr>
+            <a:r>
+              <a:rPr lang="en-US" sz="950" b="1" spc="100" kern="0" dirty="0">
+                <a:solidFill>
+                  <a:srgbClr val="0F8A8F"/>
+                </a:solidFill>
+                <a:latin typeface="Calibri" pitchFamily="34" charset="0"/>
+                <a:ea typeface="Calibri" pitchFamily="34" charset="-122"/>
+                <a:cs typeface="Calibri" pitchFamily="34" charset="-120"/>
+              </a:rPr>
+              <a:t>WORKFORCE &amp; LABOR</a:t>
+            </a:r>
+            <a:endParaRPr lang="en-US" sz="950" dirty="0"/>
+          </a:p>
+        </p:txBody>
+      </p:sp>
+      <p:sp>
+        <p:nvSpPr>
+          <p:cNvPr id="18" name="Shape 14"/>
+          <p:cNvSpPr/>
+          <p:nvPr/>
+        </p:nvSpPr>
+        <p:spPr>
+          <a:xfrm>
+            <a:off x="4700016" y="3200400"/>
+            <a:ext cx="2761488" cy="10973"/>
+          </a:xfrm>
+          <a:prstGeom prst="rect">
+            <a:avLst/>
+          </a:prstGeom>
+          <a:solidFill>
+            <a:srgbClr val="DDEAEC"/>
+          </a:solidFill>
+          <a:ln/>
+        </p:spPr>
+      </p:sp>
+      <p:sp>
+        <p:nvSpPr>
+          <p:cNvPr id="19" name="Text 15"/>
+          <p:cNvSpPr/>
+          <p:nvPr/>
+        </p:nvSpPr>
+        <p:spPr>
+          <a:xfrm>
+            <a:off x="4754880" y="3364992"/>
+            <a:ext cx="2706624" cy="2651760"/>
+          </a:xfrm>
+          <a:prstGeom prst="rect">
+            <a:avLst/>
+          </a:prstGeom>
+          <a:noFill/>
+          <a:ln/>
+        </p:spPr>
+        <p:txBody>
+          <a:bodyPr wrap="square" lIns="0" tIns="0" rIns="0" bIns="0" rtlCol="0" anchor="t"/>
+          <a:lstStyle/>
+          <a:p>
+            <a:pPr algn="l" marL="177800" indent="-177800">
+              <a:spcAft>
+                <a:spcPts val="800"/>
+              </a:spcAft>
+              <a:buSzPct val="100000"/>
+              <a:buChar char="•"/>
+            </a:pPr>
+            <a:r>
+              <a:rPr lang="en-US" sz="1250" dirty="0">
+                <a:solidFill>
+                  <a:srgbClr val="0E323B"/>
+                </a:solidFill>
+                <a:latin typeface="Calibri" pitchFamily="34" charset="0"/>
+                <a:ea typeface="Calibri" pitchFamily="34" charset="-122"/>
+                <a:cs typeface="Calibri" pitchFamily="34" charset="-120"/>
+              </a:rPr>
+              <a:t>Employee Hours Tracking</a:t>
+            </a:r>
+            <a:endParaRPr lang="en-US" sz="1250" dirty="0"/>
+          </a:p>
+          <a:p>
+            <a:pPr algn="l" marL="177800" indent="-177800">
+              <a:spcAft>
+                <a:spcPts val="800"/>
+              </a:spcAft>
+              <a:buSzPct val="100000"/>
+              <a:buChar char="•"/>
+            </a:pPr>
+            <a:r>
+              <a:rPr lang="en-US" sz="1250" dirty="0">
+                <a:solidFill>
+                  <a:srgbClr val="0E323B"/>
+                </a:solidFill>
+                <a:latin typeface="Calibri" pitchFamily="34" charset="0"/>
+                <a:ea typeface="Calibri" pitchFamily="34" charset="-122"/>
+                <a:cs typeface="Calibri" pitchFamily="34" charset="-120"/>
+              </a:rPr>
+              <a:t>Labor Cost Analysis</a:t>
+            </a:r>
+            <a:endParaRPr lang="en-US" sz="1250" dirty="0"/>
+          </a:p>
+          <a:p>
+            <a:pPr algn="l" marL="177800" indent="-177800">
+              <a:spcAft>
+                <a:spcPts val="800"/>
+              </a:spcAft>
+              <a:buSzPct val="100000"/>
+              <a:buChar char="•"/>
+            </a:pPr>
+            <a:r>
+              <a:rPr lang="en-US" sz="1250" dirty="0">
+                <a:solidFill>
+                  <a:srgbClr val="0E323B"/>
+                </a:solidFill>
+                <a:latin typeface="Calibri" pitchFamily="34" charset="0"/>
+                <a:ea typeface="Calibri" pitchFamily="34" charset="-122"/>
+                <a:cs typeface="Calibri" pitchFamily="34" charset="-120"/>
+              </a:rPr>
+              <a:t>Productivity vs. Hours Analysis</a:t>
+            </a:r>
+            <a:endParaRPr lang="en-US" sz="1250" dirty="0"/>
+          </a:p>
+          <a:p>
+            <a:pPr algn="l" marL="177800" indent="-177800">
+              <a:spcAft>
+                <a:spcPts val="800"/>
+              </a:spcAft>
+              <a:buSzPct val="100000"/>
+              <a:buChar char="•"/>
+            </a:pPr>
+            <a:r>
+              <a:rPr lang="en-US" sz="1250" dirty="0">
+                <a:solidFill>
+                  <a:srgbClr val="0E323B"/>
+                </a:solidFill>
+                <a:latin typeface="Calibri" pitchFamily="34" charset="0"/>
+                <a:ea typeface="Calibri" pitchFamily="34" charset="-122"/>
+                <a:cs typeface="Calibri" pitchFamily="34" charset="-120"/>
+              </a:rPr>
+              <a:t>Attendance Trends</a:t>
+            </a:r>
+            <a:endParaRPr lang="en-US" sz="1250" dirty="0"/>
+          </a:p>
+        </p:txBody>
+      </p:sp>
+      <p:sp>
+        <p:nvSpPr>
+          <p:cNvPr id="20" name="Shape 16"/>
+          <p:cNvSpPr/>
+          <p:nvPr/>
+        </p:nvSpPr>
+        <p:spPr>
+          <a:xfrm>
+            <a:off x="8138160" y="2103120"/>
+            <a:ext cx="3383280" cy="4114800"/>
+          </a:xfrm>
+          <a:prstGeom prst="roundRect">
+            <a:avLst>
+              <a:gd name="adj" fmla="val 2162"/>
+            </a:avLst>
+          </a:prstGeom>
+          <a:solidFill>
+            <a:srgbClr val="FFFFFF"/>
+          </a:solidFill>
+          <a:ln w="12700">
+            <a:solidFill>
+              <a:srgbClr val="DDEAEC"/>
+            </a:solidFill>
+            <a:prstDash val="solid"/>
+          </a:ln>
+          <a:effectLst>
+            <a:outerShdw sx="100000" sy="100000" kx="0" ky="0" algn="bl" rotWithShape="0" blurRad="101600" dist="38100" dir="8100000">
+              <a:srgbClr val="0A2A33">
+                <a:alpha val="16000"/>
+              </a:srgbClr>
+            </a:outerShdw>
+          </a:effectLst>
+        </p:spPr>
+      </p:sp>
+      <p:sp>
+        <p:nvSpPr>
+          <p:cNvPr id="21" name="Shape 17"/>
+          <p:cNvSpPr/>
+          <p:nvPr/>
+        </p:nvSpPr>
+        <p:spPr>
+          <a:xfrm>
+            <a:off x="8449056" y="2414016"/>
+            <a:ext cx="566928" cy="566928"/>
+          </a:xfrm>
+          <a:prstGeom prst="ellipse">
+            <a:avLst/>
+          </a:prstGeom>
+          <a:solidFill>
+            <a:srgbClr val="0F8A8F"/>
+          </a:solidFill>
+          <a:ln/>
+          <a:effectLst>
+            <a:outerShdw sx="100000" sy="100000" kx="0" ky="0" algn="bl" rotWithShape="0" blurRad="101600" dist="38100" dir="8100000">
+              <a:srgbClr val="0A2A33">
+                <a:alpha val="16000"/>
+              </a:srgbClr>
+            </a:outerShdw>
+          </a:effectLst>
+        </p:spPr>
+      </p:sp>
+      <p:pic>
+        <p:nvPicPr>
+          <p:cNvPr id="22" name="Image 2" descr="preencoded.png">    </p:cNvPr>
+          <p:cNvPicPr>
+            <a:picLocks noChangeAspect="1"/>
+          </p:cNvPicPr>
+          <p:nvPr/>
+        </p:nvPicPr>
+        <p:blipFill>
+          <a:blip r:embed="rId3"/>
+          <a:stretch>
+            <a:fillRect/>
+          </a:stretch>
+        </p:blipFill>
+        <p:spPr>
+          <a:xfrm>
+            <a:off x="8585119" y="2550079"/>
+            <a:ext cx="294803" cy="294803"/>
+          </a:xfrm>
+          <a:prstGeom prst="rect">
+            <a:avLst/>
+          </a:prstGeom>
+        </p:spPr>
+      </p:pic>
+      <p:sp>
+        <p:nvSpPr>
+          <p:cNvPr id="23" name="Text 18"/>
+          <p:cNvSpPr/>
+          <p:nvPr/>
+        </p:nvSpPr>
+        <p:spPr>
+          <a:xfrm>
+            <a:off x="9144000" y="2432304"/>
+            <a:ext cx="2194560" cy="347472"/>
+          </a:xfrm>
+          <a:prstGeom prst="rect">
+            <a:avLst/>
+          </a:prstGeom>
+          <a:noFill/>
+          <a:ln/>
+        </p:spPr>
+        <p:txBody>
+          <a:bodyPr wrap="square" lIns="0" tIns="0" rIns="0" bIns="0" rtlCol="0" anchor="ctr"/>
+          <a:lstStyle/>
+          <a:p>
+            <a:pPr algn="l" indent="0" marL="0">
+              <a:buNone/>
+            </a:pPr>
+            <a:r>
+              <a:rPr lang="en-US" sz="1700" b="1" dirty="0">
+                <a:solidFill>
+                  <a:srgbClr val="0E323B"/>
+                </a:solidFill>
+                <a:latin typeface="Calibri" pitchFamily="34" charset="0"/>
+                <a:ea typeface="Calibri" pitchFamily="34" charset="-122"/>
+                <a:cs typeface="Calibri" pitchFamily="34" charset="-120"/>
+              </a:rPr>
+              <a:t>Sage Intacct</a:t>
+            </a:r>
+            <a:endParaRPr lang="en-US" sz="1700" dirty="0"/>
+          </a:p>
+        </p:txBody>
+      </p:sp>
+      <p:sp>
+        <p:nvSpPr>
+          <p:cNvPr id="24" name="Text 19"/>
+          <p:cNvSpPr/>
+          <p:nvPr/>
+        </p:nvSpPr>
+        <p:spPr>
+          <a:xfrm>
+            <a:off x="9144000" y="2798064"/>
+            <a:ext cx="2194560" cy="274320"/>
+          </a:xfrm>
+          <a:prstGeom prst="rect">
+            <a:avLst/>
+          </a:prstGeom>
+          <a:noFill/>
+          <a:ln/>
+        </p:spPr>
+        <p:txBody>
+          <a:bodyPr wrap="square" lIns="0" tIns="0" rIns="0" bIns="0" rtlCol="0" anchor="ctr"/>
+          <a:lstStyle/>
+          <a:p>
+            <a:pPr algn="l" indent="0" marL="0">
+              <a:buNone/>
+            </a:pPr>
+            <a:r>
+              <a:rPr lang="en-US" sz="950" b="1" spc="100" kern="0" dirty="0">
+                <a:solidFill>
+                  <a:srgbClr val="0F8A8F"/>
+                </a:solidFill>
+                <a:latin typeface="Calibri" pitchFamily="34" charset="0"/>
+                <a:ea typeface="Calibri" pitchFamily="34" charset="-122"/>
+                <a:cs typeface="Calibri" pitchFamily="34" charset="-120"/>
+              </a:rPr>
+              <a:t>FINANCIAL &amp; ACCOUNTING</a:t>
+            </a:r>
+            <a:endParaRPr lang="en-US" sz="950" dirty="0"/>
+          </a:p>
+        </p:txBody>
+      </p:sp>
+      <p:sp>
+        <p:nvSpPr>
+          <p:cNvPr id="25" name="Shape 20"/>
+          <p:cNvSpPr/>
+          <p:nvPr/>
+        </p:nvSpPr>
+        <p:spPr>
+          <a:xfrm>
+            <a:off x="8449056" y="3200400"/>
+            <a:ext cx="2761488" cy="10973"/>
+          </a:xfrm>
+          <a:prstGeom prst="rect">
+            <a:avLst/>
+          </a:prstGeom>
+          <a:solidFill>
+            <a:srgbClr val="DDEAEC"/>
+          </a:solidFill>
+          <a:ln/>
+        </p:spPr>
+      </p:sp>
+      <p:sp>
+        <p:nvSpPr>
+          <p:cNvPr id="26" name="Text 21"/>
+          <p:cNvSpPr/>
+          <p:nvPr/>
+        </p:nvSpPr>
+        <p:spPr>
+          <a:xfrm>
+            <a:off x="8503920" y="3364992"/>
+            <a:ext cx="2706624" cy="2651760"/>
+          </a:xfrm>
+          <a:prstGeom prst="rect">
+            <a:avLst/>
+          </a:prstGeom>
+          <a:noFill/>
+          <a:ln/>
+        </p:spPr>
+        <p:txBody>
+          <a:bodyPr wrap="square" lIns="0" tIns="0" rIns="0" bIns="0" rtlCol="0" anchor="t"/>
+          <a:lstStyle/>
+          <a:p>
+            <a:pPr algn="l" marL="177800" indent="-177800">
+              <a:spcAft>
+                <a:spcPts val="800"/>
+              </a:spcAft>
+              <a:buSzPct val="100000"/>
+              <a:buChar char="•"/>
+            </a:pPr>
+            <a:r>
+              <a:rPr lang="en-US" sz="1250" dirty="0">
+                <a:solidFill>
+                  <a:srgbClr val="0E323B"/>
+                </a:solidFill>
+                <a:latin typeface="Calibri" pitchFamily="34" charset="0"/>
+                <a:ea typeface="Calibri" pitchFamily="34" charset="-122"/>
+                <a:cs typeface="Calibri" pitchFamily="34" charset="-120"/>
+              </a:rPr>
+              <a:t>Non-Doctor Labor %</a:t>
+            </a:r>
+            <a:endParaRPr lang="en-US" sz="1250" dirty="0"/>
+          </a:p>
+          <a:p>
+            <a:pPr algn="l" marL="177800" indent="-177800">
+              <a:spcAft>
+                <a:spcPts val="800"/>
+              </a:spcAft>
+              <a:buSzPct val="100000"/>
+              <a:buChar char="•"/>
+            </a:pPr>
+            <a:r>
+              <a:rPr lang="en-US" sz="1250" dirty="0">
+                <a:solidFill>
+                  <a:srgbClr val="0E323B"/>
+                </a:solidFill>
+                <a:latin typeface="Calibri" pitchFamily="34" charset="0"/>
+                <a:ea typeface="Calibri" pitchFamily="34" charset="-122"/>
+                <a:cs typeface="Calibri" pitchFamily="34" charset="-120"/>
+              </a:rPr>
+              <a:t>Lab %</a:t>
+            </a:r>
+            <a:endParaRPr lang="en-US" sz="1250" dirty="0"/>
+          </a:p>
+          <a:p>
+            <a:pPr algn="l" marL="177800" indent="-177800">
+              <a:spcAft>
+                <a:spcPts val="800"/>
+              </a:spcAft>
+              <a:buSzPct val="100000"/>
+              <a:buChar char="•"/>
+            </a:pPr>
+            <a:r>
+              <a:rPr lang="en-US" sz="1250" dirty="0">
+                <a:solidFill>
+                  <a:srgbClr val="0E323B"/>
+                </a:solidFill>
+                <a:latin typeface="Calibri" pitchFamily="34" charset="0"/>
+                <a:ea typeface="Calibri" pitchFamily="34" charset="-122"/>
+                <a:cs typeface="Calibri" pitchFamily="34" charset="-120"/>
+              </a:rPr>
+              <a:t>Supplies %</a:t>
+            </a:r>
+            <a:endParaRPr lang="en-US" sz="1250" dirty="0"/>
+          </a:p>
+          <a:p>
+            <a:pPr algn="l" marL="177800" indent="-177800">
+              <a:spcAft>
+                <a:spcPts val="800"/>
+              </a:spcAft>
+              <a:buSzPct val="100000"/>
+              <a:buChar char="•"/>
+            </a:pPr>
+            <a:r>
+              <a:rPr lang="en-US" sz="1250" dirty="0">
+                <a:solidFill>
+                  <a:srgbClr val="0E323B"/>
+                </a:solidFill>
+                <a:latin typeface="Calibri" pitchFamily="34" charset="0"/>
+                <a:ea typeface="Calibri" pitchFamily="34" charset="-122"/>
+                <a:cs typeface="Calibri" pitchFamily="34" charset="-120"/>
+              </a:rPr>
+              <a:t>EBITDA</a:t>
+            </a:r>
+            <a:endParaRPr lang="en-US" sz="1250" dirty="0"/>
+          </a:p>
+          <a:p>
+            <a:pPr algn="l" marL="177800" indent="-177800">
+              <a:spcAft>
+                <a:spcPts val="800"/>
+              </a:spcAft>
+              <a:buSzPct val="100000"/>
+              <a:buChar char="•"/>
+            </a:pPr>
+            <a:r>
+              <a:rPr lang="en-US" sz="1250" dirty="0">
+                <a:solidFill>
+                  <a:srgbClr val="0E323B"/>
+                </a:solidFill>
+                <a:latin typeface="Calibri" pitchFamily="34" charset="0"/>
+                <a:ea typeface="Calibri" pitchFamily="34" charset="-122"/>
+                <a:cs typeface="Calibri" pitchFamily="34" charset="-120"/>
+              </a:rPr>
+              <a:t>EBITDA %</a:t>
+            </a:r>
+            <a:endParaRPr lang="en-US" sz="1250" dirty="0"/>
+          </a:p>
+          <a:p>
+            <a:pPr algn="l" marL="177800" indent="-177800">
+              <a:spcAft>
+                <a:spcPts val="800"/>
+              </a:spcAft>
+              <a:buSzPct val="100000"/>
+              <a:buChar char="•"/>
+            </a:pPr>
+            <a:r>
+              <a:rPr lang="en-US" sz="1250" dirty="0">
+                <a:solidFill>
+                  <a:srgbClr val="0E323B"/>
+                </a:solidFill>
+                <a:latin typeface="Calibri" pitchFamily="34" charset="0"/>
+                <a:ea typeface="Calibri" pitchFamily="34" charset="-122"/>
+                <a:cs typeface="Calibri" pitchFamily="34" charset="-120"/>
+              </a:rPr>
+              <a:t>Revenue &amp; Financial Trend Analysis</a:t>
+            </a:r>
+            <a:endParaRPr lang="en-US" sz="1250" dirty="0"/>
+          </a:p>
+        </p:txBody>
+      </p:sp>
+    </p:spTree>
+  </p:cSld>
+  <p:clrMapOvr>
+    <a:masterClrMapping/>
+  </p:clrMapOvr>
+</p:sld>
+</file>
+
+<file path=ppt/slides/slide5.xml><?xml version="1.0" encoding="utf-8"?>
+<p:sld xmlns:a="http://schemas.openxmlformats.org/drawingml/2006/main" xmlns:r="http://schemas.openxmlformats.org/officeDocument/2006/relationships" xmlns:p="http://schemas.openxmlformats.org/presentationml/2006/main">
+  <p:cSld name="Slide 5">
     <p:bg>
       <p:bgPr>
         <a:solidFill>

</xml_diff>

<commit_message>
Add Lumenore platform architecture slide (full data flow) as slide 4
Co-authored-by: Aankitgupta <Aankitgupta@users.noreply.github.com>
</commit_message>
<xml_diff>
--- a/presentations/dental-intelligence-pitch.pptx
+++ b/presentations/dental-intelligence-pitch.pptx
@@ -10,9 +10,10 @@
     <p:sldId id="258" r:id="rId4"/>
     <p:sldId id="259" r:id="rId5"/>
     <p:sldId id="260" r:id="rId6"/>
+    <p:sldId id="261" r:id="rId7"/>
   </p:sldIdLst>
   <p:notesMasterIdLst>
-    <p:notesMasterId r:id="rId7"/>
+    <p:notesMasterId r:id="rId8"/>
   </p:notesMasterIdLst>
   <p:sldSz cx="12192000" cy="6858000"/>
   <p:notesSz cx="6858000" cy="12192000"/>
@@ -900,6 +901,94 @@
 </p:notes>
 </file>
 
+<file path=ppt/notesSlides/notesSlide6.xml><?xml version="1.0" encoding="utf-8"?>
+<p:notes xmlns:a="http://schemas.openxmlformats.org/drawingml/2006/main" xmlns:r="http://schemas.openxmlformats.org/officeDocument/2006/relationships" xmlns:p="http://schemas.openxmlformats.org/presentationml/2006/main">
+  <p:cSld>
+    <p:spTree>
+      <p:nvGrpSpPr>
+        <p:cNvPr id="1" name=""/>
+        <p:cNvGrpSpPr/>
+        <p:nvPr/>
+      </p:nvGrpSpPr>
+      <p:grpSpPr>
+        <a:xfrm>
+          <a:off x="0" y="0"/>
+          <a:ext cx="0" cy="0"/>
+          <a:chOff x="0" y="0"/>
+          <a:chExt cx="0" cy="0"/>
+        </a:xfrm>
+      </p:grpSpPr>
+      <p:sp>
+        <p:nvSpPr>
+          <p:cNvPr id="2" name="Slide Image Placeholder 1"/>
+          <p:cNvSpPr>
+            <a:spLocks noGrp="1" noRot="1" noChangeAspect="1"/>
+          </p:cNvSpPr>
+          <p:nvPr>
+            <p:ph type="sldImg"/>
+          </p:nvPr>
+        </p:nvSpPr>
+        <p:spPr/>
+      </p:sp>
+      <p:sp>
+        <p:nvSpPr>
+          <p:cNvPr id="3" name="Notes Placeholder 2"/>
+          <p:cNvSpPr>
+            <a:spLocks noGrp="1"/>
+          </p:cNvSpPr>
+          <p:nvPr>
+            <p:ph type="body" idx="1"/>
+          </p:nvPr>
+        </p:nvSpPr>
+        <p:spPr/>
+        <p:txBody>
+          <a:bodyPr/>
+          <a:lstStyle/>
+          <a:p>
+            <a:r>
+              <a:rPr lang="en-US" dirty="0"/>
+              <a:t/>
+            </a:r>
+            <a:endParaRPr lang="en-US" dirty="0"/>
+          </a:p>
+        </p:txBody>
+      </p:sp>
+      <p:sp>
+        <p:nvSpPr>
+          <p:cNvPr id="4" name="Slide Number Placeholder 3"/>
+          <p:cNvSpPr>
+            <a:spLocks noGrp="1"/>
+          </p:cNvSpPr>
+          <p:nvPr>
+            <p:ph type="sldNum" sz="quarter" idx="10"/>
+          </p:nvPr>
+        </p:nvSpPr>
+        <p:spPr/>
+        <p:txBody>
+          <a:bodyPr/>
+          <a:lstStyle/>
+          <a:p>
+            <a:fld id="{F7021451-1387-4CA6-816F-3879F97B5CBC}" type="slidenum">
+              <a:rPr lang="en-US"/>
+              <a:t>6</a:t>
+            </a:fld>
+            <a:endParaRPr lang="en-US"/>
+          </a:p>
+        </p:txBody>
+      </p:sp>
+    </p:spTree>
+    <p:extLst>
+      <p:ext uri="{BB962C8B-B14F-4D97-AF65-F5344CB8AC3E}">
+        <p14:creationId xmlns:p14="http://schemas.microsoft.com/office/powerpoint/2010/main" val="1024086991"/>
+      </p:ext>
+    </p:extLst>
+  </p:cSld>
+  <p:clrMapOvr>
+    <a:masterClrMapping/>
+  </p:clrMapOvr>
+</p:notes>
+</file>
+
 <file path=ppt/slideLayouts/slideLayout1.xml><?xml version="1.0" encoding="utf-8"?>
 <p:sldLayout xmlns:a="http://schemas.openxmlformats.org/drawingml/2006/main" xmlns:r="http://schemas.openxmlformats.org/officeDocument/2006/relationships" xmlns:p="http://schemas.openxmlformats.org/presentationml/2006/main" preserve="1">
   <p:cSld name="DEFAULT">
@@ -5386,6 +5475,3345 @@
       </p:grpSpPr>
       <p:sp>
         <p:nvSpPr>
+          <p:cNvPr id="2" name="Shape 0"/>
+          <p:cNvSpPr/>
+          <p:nvPr/>
+        </p:nvSpPr>
+        <p:spPr>
+          <a:xfrm>
+            <a:off x="1371600" y="109728"/>
+            <a:ext cx="9326880" cy="6638544"/>
+          </a:xfrm>
+          <a:prstGeom prst="roundRect">
+            <a:avLst>
+              <a:gd name="adj" fmla="val 826"/>
+            </a:avLst>
+          </a:prstGeom>
+          <a:solidFill>
+            <a:srgbClr val="FFFFFF"/>
+          </a:solidFill>
+          <a:ln w="15875">
+            <a:solidFill>
+              <a:srgbClr val="C5CBD4"/>
+            </a:solidFill>
+            <a:prstDash val="solid"/>
+          </a:ln>
+        </p:spPr>
+      </p:sp>
+      <p:sp>
+        <p:nvSpPr>
+          <p:cNvPr id="3" name="Text 1"/>
+          <p:cNvSpPr/>
+          <p:nvPr/>
+        </p:nvSpPr>
+        <p:spPr>
+          <a:xfrm>
+            <a:off x="4160520" y="182880"/>
+            <a:ext cx="3840480" cy="365760"/>
+          </a:xfrm>
+          <a:prstGeom prst="rect">
+            <a:avLst/>
+          </a:prstGeom>
+          <a:noFill/>
+          <a:ln/>
+        </p:spPr>
+        <p:txBody>
+          <a:bodyPr wrap="square" lIns="0" tIns="0" rIns="0" bIns="0" rtlCol="0" anchor="ctr"/>
+          <a:lstStyle/>
+          <a:p>
+            <a:pPr algn="ctr" indent="0" marL="0">
+              <a:buNone/>
+            </a:pPr>
+            <a:r>
+              <a:rPr lang="en-US" sz="2100" b="1" spc="200" kern="0" dirty="0">
+                <a:solidFill>
+                  <a:srgbClr val="6B7B8B"/>
+                </a:solidFill>
+                <a:latin typeface="Calibri" pitchFamily="34" charset="0"/>
+                <a:ea typeface="Calibri" pitchFamily="34" charset="-122"/>
+                <a:cs typeface="Calibri" pitchFamily="34" charset="-120"/>
+              </a:rPr>
+              <a:t>LUMENORE</a:t>
+            </a:r>
+            <a:endParaRPr lang="en-US" sz="2100" dirty="0"/>
+          </a:p>
+        </p:txBody>
+      </p:sp>
+      <p:sp>
+        <p:nvSpPr>
+          <p:cNvPr id="4" name="Text 2"/>
+          <p:cNvSpPr/>
+          <p:nvPr/>
+        </p:nvSpPr>
+        <p:spPr>
+          <a:xfrm>
+            <a:off x="4160520" y="530352"/>
+            <a:ext cx="3840480" cy="164592"/>
+          </a:xfrm>
+          <a:prstGeom prst="rect">
+            <a:avLst/>
+          </a:prstGeom>
+          <a:noFill/>
+          <a:ln/>
+        </p:spPr>
+        <p:txBody>
+          <a:bodyPr wrap="square" lIns="0" tIns="0" rIns="0" bIns="0" rtlCol="0" anchor="ctr"/>
+          <a:lstStyle/>
+          <a:p>
+            <a:pPr algn="ctr" indent="0" marL="0">
+              <a:buNone/>
+            </a:pPr>
+            <a:r>
+              <a:rPr lang="en-US" sz="700" dirty="0">
+                <a:solidFill>
+                  <a:srgbClr val="6B7B8B"/>
+                </a:solidFill>
+                <a:latin typeface="Calibri" pitchFamily="34" charset="0"/>
+                <a:ea typeface="Calibri" pitchFamily="34" charset="-122"/>
+                <a:cs typeface="Calibri" pitchFamily="34" charset="-120"/>
+              </a:rPr>
+              <a:t>Netlink’s Flagship AI Product</a:t>
+            </a:r>
+            <a:endParaRPr lang="en-US" sz="700" dirty="0"/>
+          </a:p>
+        </p:txBody>
+      </p:sp>
+      <p:sp>
+        <p:nvSpPr>
+          <p:cNvPr id="5" name="Shape 3"/>
+          <p:cNvSpPr/>
+          <p:nvPr/>
+        </p:nvSpPr>
+        <p:spPr>
+          <a:xfrm>
+            <a:off x="1572768" y="749808"/>
+            <a:ext cx="8924544" cy="292608"/>
+          </a:xfrm>
+          <a:prstGeom prst="rect">
+            <a:avLst/>
+          </a:prstGeom>
+          <a:solidFill>
+            <a:srgbClr val="5B9BD5"/>
+          </a:solidFill>
+          <a:ln/>
+        </p:spPr>
+      </p:sp>
+      <p:sp>
+        <p:nvSpPr>
+          <p:cNvPr id="6" name="Text 4"/>
+          <p:cNvSpPr/>
+          <p:nvPr/>
+        </p:nvSpPr>
+        <p:spPr>
+          <a:xfrm>
+            <a:off x="1572768" y="749808"/>
+            <a:ext cx="8924544" cy="292608"/>
+          </a:xfrm>
+          <a:prstGeom prst="rect">
+            <a:avLst/>
+          </a:prstGeom>
+          <a:noFill/>
+          <a:ln/>
+        </p:spPr>
+        <p:txBody>
+          <a:bodyPr wrap="square" lIns="0" tIns="0" rIns="0" bIns="0" rtlCol="0" anchor="ctr"/>
+          <a:lstStyle/>
+          <a:p>
+            <a:pPr algn="ctr" indent="0" marL="0">
+              <a:buNone/>
+            </a:pPr>
+            <a:r>
+              <a:rPr lang="en-US" sz="1200" b="1" dirty="0">
+                <a:solidFill>
+                  <a:srgbClr val="FFFFFF"/>
+                </a:solidFill>
+                <a:latin typeface="Calibri" pitchFamily="34" charset="0"/>
+                <a:ea typeface="Calibri" pitchFamily="34" charset="-122"/>
+                <a:cs typeface="Calibri" pitchFamily="34" charset="-120"/>
+              </a:rPr>
+              <a:t>Authentication and Authorization</a:t>
+            </a:r>
+            <a:endParaRPr lang="en-US" sz="1200" dirty="0"/>
+          </a:p>
+        </p:txBody>
+      </p:sp>
+      <p:sp>
+        <p:nvSpPr>
+          <p:cNvPr id="7" name="Shape 5"/>
+          <p:cNvSpPr/>
+          <p:nvPr/>
+        </p:nvSpPr>
+        <p:spPr>
+          <a:xfrm>
+            <a:off x="1572768" y="1097280"/>
+            <a:ext cx="8924544" cy="292608"/>
+          </a:xfrm>
+          <a:prstGeom prst="rect">
+            <a:avLst/>
+          </a:prstGeom>
+          <a:solidFill>
+            <a:srgbClr val="5B9BD5"/>
+          </a:solidFill>
+          <a:ln/>
+        </p:spPr>
+      </p:sp>
+      <p:sp>
+        <p:nvSpPr>
+          <p:cNvPr id="8" name="Text 6"/>
+          <p:cNvSpPr/>
+          <p:nvPr/>
+        </p:nvSpPr>
+        <p:spPr>
+          <a:xfrm>
+            <a:off x="1572768" y="1097280"/>
+            <a:ext cx="8924544" cy="292608"/>
+          </a:xfrm>
+          <a:prstGeom prst="rect">
+            <a:avLst/>
+          </a:prstGeom>
+          <a:noFill/>
+          <a:ln/>
+        </p:spPr>
+        <p:txBody>
+          <a:bodyPr wrap="square" lIns="0" tIns="0" rIns="0" bIns="0" rtlCol="0" anchor="ctr"/>
+          <a:lstStyle/>
+          <a:p>
+            <a:pPr algn="ctr" indent="0" marL="0">
+              <a:buNone/>
+            </a:pPr>
+            <a:r>
+              <a:rPr lang="en-US" sz="1200" b="1" dirty="0">
+                <a:solidFill>
+                  <a:srgbClr val="FFFFFF"/>
+                </a:solidFill>
+                <a:latin typeface="Calibri" pitchFamily="34" charset="0"/>
+                <a:ea typeface="Calibri" pitchFamily="34" charset="-122"/>
+                <a:cs typeface="Calibri" pitchFamily="34" charset="-120"/>
+              </a:rPr>
+              <a:t>Data Security (RBAC, Row Level, Column Level, Encryption)</a:t>
+            </a:r>
+            <a:endParaRPr lang="en-US" sz="1200" dirty="0"/>
+          </a:p>
+        </p:txBody>
+      </p:sp>
+      <p:sp>
+        <p:nvSpPr>
+          <p:cNvPr id="9" name="Shape 7"/>
+          <p:cNvSpPr/>
+          <p:nvPr/>
+        </p:nvSpPr>
+        <p:spPr>
+          <a:xfrm>
+            <a:off x="1572768" y="5961888"/>
+            <a:ext cx="8924544" cy="292608"/>
+          </a:xfrm>
+          <a:prstGeom prst="rect">
+            <a:avLst/>
+          </a:prstGeom>
+          <a:solidFill>
+            <a:srgbClr val="5B9BD5"/>
+          </a:solidFill>
+          <a:ln/>
+        </p:spPr>
+      </p:sp>
+      <p:sp>
+        <p:nvSpPr>
+          <p:cNvPr id="10" name="Text 8"/>
+          <p:cNvSpPr/>
+          <p:nvPr/>
+        </p:nvSpPr>
+        <p:spPr>
+          <a:xfrm>
+            <a:off x="1572768" y="5961888"/>
+            <a:ext cx="8924544" cy="292608"/>
+          </a:xfrm>
+          <a:prstGeom prst="rect">
+            <a:avLst/>
+          </a:prstGeom>
+          <a:noFill/>
+          <a:ln/>
+        </p:spPr>
+        <p:txBody>
+          <a:bodyPr wrap="square" lIns="0" tIns="0" rIns="0" bIns="0" rtlCol="0" anchor="ctr"/>
+          <a:lstStyle/>
+          <a:p>
+            <a:pPr algn="ctr" indent="0" marL="0">
+              <a:buNone/>
+            </a:pPr>
+            <a:r>
+              <a:rPr lang="en-US" sz="1200" b="1" dirty="0">
+                <a:solidFill>
+                  <a:srgbClr val="FFFFFF"/>
+                </a:solidFill>
+                <a:latin typeface="Calibri" pitchFamily="34" charset="0"/>
+                <a:ea typeface="Calibri" pitchFamily="34" charset="-122"/>
+                <a:cs typeface="Calibri" pitchFamily="34" charset="-120"/>
+              </a:rPr>
+              <a:t>Metadata Management</a:t>
+            </a:r>
+            <a:endParaRPr lang="en-US" sz="1200" dirty="0"/>
+          </a:p>
+        </p:txBody>
+      </p:sp>
+      <p:sp>
+        <p:nvSpPr>
+          <p:cNvPr id="11" name="Shape 9"/>
+          <p:cNvSpPr/>
+          <p:nvPr/>
+        </p:nvSpPr>
+        <p:spPr>
+          <a:xfrm>
+            <a:off x="1572768" y="6309360"/>
+            <a:ext cx="8924544" cy="292608"/>
+          </a:xfrm>
+          <a:prstGeom prst="rect">
+            <a:avLst/>
+          </a:prstGeom>
+          <a:solidFill>
+            <a:srgbClr val="5B9BD5"/>
+          </a:solidFill>
+          <a:ln/>
+        </p:spPr>
+      </p:sp>
+      <p:sp>
+        <p:nvSpPr>
+          <p:cNvPr id="12" name="Text 10"/>
+          <p:cNvSpPr/>
+          <p:nvPr/>
+        </p:nvSpPr>
+        <p:spPr>
+          <a:xfrm>
+            <a:off x="1572768" y="6309360"/>
+            <a:ext cx="8924544" cy="292608"/>
+          </a:xfrm>
+          <a:prstGeom prst="rect">
+            <a:avLst/>
+          </a:prstGeom>
+          <a:noFill/>
+          <a:ln/>
+        </p:spPr>
+        <p:txBody>
+          <a:bodyPr wrap="square" lIns="0" tIns="0" rIns="0" bIns="0" rtlCol="0" anchor="ctr"/>
+          <a:lstStyle/>
+          <a:p>
+            <a:pPr algn="ctr" indent="0" marL="0">
+              <a:buNone/>
+            </a:pPr>
+            <a:r>
+              <a:rPr lang="en-US" sz="1200" b="1" dirty="0">
+                <a:solidFill>
+                  <a:srgbClr val="FFFFFF"/>
+                </a:solidFill>
+                <a:latin typeface="Calibri" pitchFamily="34" charset="0"/>
+                <a:ea typeface="Calibri" pitchFamily="34" charset="-122"/>
+                <a:cs typeface="Calibri" pitchFamily="34" charset="-120"/>
+              </a:rPr>
+              <a:t>Audit and Monitoring</a:t>
+            </a:r>
+            <a:endParaRPr lang="en-US" sz="1200" dirty="0"/>
+          </a:p>
+        </p:txBody>
+      </p:sp>
+      <p:sp>
+        <p:nvSpPr>
+          <p:cNvPr id="13" name="Shape 11"/>
+          <p:cNvSpPr/>
+          <p:nvPr/>
+        </p:nvSpPr>
+        <p:spPr>
+          <a:xfrm>
+            <a:off x="1737360" y="1554480"/>
+            <a:ext cx="5394960" cy="4297680"/>
+          </a:xfrm>
+          <a:prstGeom prst="rect">
+            <a:avLst/>
+          </a:prstGeom>
+          <a:solidFill>
+            <a:srgbClr val="F2F3F5"/>
+          </a:solidFill>
+          <a:ln w="12700">
+            <a:solidFill>
+              <a:srgbClr val="C5CBD4"/>
+            </a:solidFill>
+            <a:prstDash val="dash"/>
+          </a:ln>
+        </p:spPr>
+      </p:sp>
+      <p:sp>
+        <p:nvSpPr>
+          <p:cNvPr id="14" name="Text 12"/>
+          <p:cNvSpPr/>
+          <p:nvPr/>
+        </p:nvSpPr>
+        <p:spPr>
+          <a:xfrm>
+            <a:off x="1737360" y="1627632"/>
+            <a:ext cx="5394960" cy="310896"/>
+          </a:xfrm>
+          <a:prstGeom prst="rect">
+            <a:avLst/>
+          </a:prstGeom>
+          <a:noFill/>
+          <a:ln/>
+        </p:spPr>
+        <p:txBody>
+          <a:bodyPr wrap="square" lIns="0" tIns="0" rIns="0" bIns="0" rtlCol="0" anchor="ctr"/>
+          <a:lstStyle/>
+          <a:p>
+            <a:pPr algn="ctr" indent="0" marL="0">
+              <a:buNone/>
+            </a:pPr>
+            <a:r>
+              <a:rPr lang="en-US" sz="1400" dirty="0">
+                <a:solidFill>
+                  <a:srgbClr val="1AA8A0"/>
+                </a:solidFill>
+                <a:latin typeface="Calibri" pitchFamily="34" charset="0"/>
+                <a:ea typeface="Calibri" pitchFamily="34" charset="-122"/>
+                <a:cs typeface="Calibri" pitchFamily="34" charset="-120"/>
+              </a:rPr>
+              <a:t>Data Architecture</a:t>
+            </a:r>
+            <a:endParaRPr lang="en-US" sz="1400" dirty="0"/>
+          </a:p>
+        </p:txBody>
+      </p:sp>
+      <p:sp>
+        <p:nvSpPr>
+          <p:cNvPr id="15" name="Shape 13"/>
+          <p:cNvSpPr/>
+          <p:nvPr/>
+        </p:nvSpPr>
+        <p:spPr>
+          <a:xfrm>
+            <a:off x="1828800" y="2148840"/>
+            <a:ext cx="292608" cy="3246120"/>
+          </a:xfrm>
+          <a:prstGeom prst="rect">
+            <a:avLst/>
+          </a:prstGeom>
+          <a:solidFill>
+            <a:srgbClr val="EC8C7A"/>
+          </a:solidFill>
+          <a:ln/>
+        </p:spPr>
+      </p:sp>
+      <p:sp>
+        <p:nvSpPr>
+          <p:cNvPr id="16" name="Text 14"/>
+          <p:cNvSpPr/>
+          <p:nvPr/>
+        </p:nvSpPr>
+        <p:spPr>
+          <a:xfrm rot="16200000">
+            <a:off x="352044" y="3625596"/>
+            <a:ext cx="3246120" cy="292608"/>
+          </a:xfrm>
+          <a:prstGeom prst="rect">
+            <a:avLst/>
+          </a:prstGeom>
+          <a:noFill/>
+          <a:ln/>
+        </p:spPr>
+        <p:txBody>
+          <a:bodyPr wrap="square" lIns="0" tIns="0" rIns="0" bIns="0" rtlCol="0" anchor="ctr"/>
+          <a:lstStyle/>
+          <a:p>
+            <a:pPr algn="ctr" indent="0" marL="0">
+              <a:buNone/>
+            </a:pPr>
+            <a:r>
+              <a:rPr lang="en-US" sz="900" b="1" dirty="0">
+                <a:solidFill>
+                  <a:srgbClr val="FFFFFF"/>
+                </a:solidFill>
+                <a:latin typeface="Calibri" pitchFamily="34" charset="0"/>
+                <a:ea typeface="Calibri" pitchFamily="34" charset="-122"/>
+                <a:cs typeface="Calibri" pitchFamily="34" charset="-120"/>
+              </a:rPr>
+              <a:t>Connectors Gateway</a:t>
+            </a:r>
+            <a:endParaRPr lang="en-US" sz="900" dirty="0"/>
+          </a:p>
+        </p:txBody>
+      </p:sp>
+      <p:sp>
+        <p:nvSpPr>
+          <p:cNvPr id="17" name="Shape 15"/>
+          <p:cNvSpPr/>
+          <p:nvPr/>
+        </p:nvSpPr>
+        <p:spPr>
+          <a:xfrm>
+            <a:off x="2286000" y="2103120"/>
+            <a:ext cx="1280160" cy="3246120"/>
+          </a:xfrm>
+          <a:prstGeom prst="rect">
+            <a:avLst/>
+          </a:prstGeom>
+          <a:solidFill>
+            <a:srgbClr val="FFFFFF"/>
+          </a:solidFill>
+          <a:ln w="15875">
+            <a:solidFill>
+              <a:srgbClr val="E8915B"/>
+            </a:solidFill>
+            <a:prstDash val="solid"/>
+          </a:ln>
+        </p:spPr>
+      </p:sp>
+      <p:sp>
+        <p:nvSpPr>
+          <p:cNvPr id="18" name="Text 16"/>
+          <p:cNvSpPr/>
+          <p:nvPr/>
+        </p:nvSpPr>
+        <p:spPr>
+          <a:xfrm>
+            <a:off x="2286000" y="2194560"/>
+            <a:ext cx="1280160" cy="237744"/>
+          </a:xfrm>
+          <a:prstGeom prst="rect">
+            <a:avLst/>
+          </a:prstGeom>
+          <a:noFill/>
+          <a:ln/>
+        </p:spPr>
+        <p:txBody>
+          <a:bodyPr wrap="square" lIns="0" tIns="0" rIns="0" bIns="0" rtlCol="0" anchor="ctr"/>
+          <a:lstStyle/>
+          <a:p>
+            <a:pPr algn="ctr" indent="0" marL="0">
+              <a:buNone/>
+            </a:pPr>
+            <a:r>
+              <a:rPr lang="en-US" sz="1050" b="1" dirty="0">
+                <a:solidFill>
+                  <a:srgbClr val="E8915B"/>
+                </a:solidFill>
+                <a:latin typeface="Calibri" pitchFamily="34" charset="0"/>
+                <a:ea typeface="Calibri" pitchFamily="34" charset="-122"/>
+                <a:cs typeface="Calibri" pitchFamily="34" charset="-120"/>
+              </a:rPr>
+              <a:t>Data Access</a:t>
+            </a:r>
+            <a:endParaRPr lang="en-US" sz="1050" dirty="0"/>
+          </a:p>
+        </p:txBody>
+      </p:sp>
+      <p:sp>
+        <p:nvSpPr>
+          <p:cNvPr id="19" name="Shape 17"/>
+          <p:cNvSpPr/>
+          <p:nvPr/>
+        </p:nvSpPr>
+        <p:spPr>
+          <a:xfrm>
+            <a:off x="2697480" y="2542032"/>
+            <a:ext cx="457200" cy="457200"/>
+          </a:xfrm>
+          <a:prstGeom prst="ellipse">
+            <a:avLst/>
+          </a:prstGeom>
+          <a:solidFill>
+            <a:srgbClr val="1AA8A0"/>
+          </a:solidFill>
+          <a:ln/>
+        </p:spPr>
+      </p:sp>
+      <p:pic>
+        <p:nvPicPr>
+          <p:cNvPr id="20" name="Image 0" descr="preencoded.png">    </p:cNvPr>
+          <p:cNvPicPr>
+            <a:picLocks noChangeAspect="1"/>
+          </p:cNvPicPr>
+          <p:nvPr/>
+        </p:nvPicPr>
+        <p:blipFill>
+          <a:blip r:embed="rId1"/>
+          <a:stretch>
+            <a:fillRect/>
+          </a:stretch>
+        </p:blipFill>
+        <p:spPr>
+          <a:xfrm>
+            <a:off x="2811780" y="2656332"/>
+            <a:ext cx="228600" cy="228600"/>
+          </a:xfrm>
+          <a:prstGeom prst="rect">
+            <a:avLst/>
+          </a:prstGeom>
+        </p:spPr>
+      </p:pic>
+      <p:sp>
+        <p:nvSpPr>
+          <p:cNvPr id="21" name="Text 18"/>
+          <p:cNvSpPr/>
+          <p:nvPr/>
+        </p:nvSpPr>
+        <p:spPr>
+          <a:xfrm>
+            <a:off x="2377440" y="3026664"/>
+            <a:ext cx="1097280" cy="329184"/>
+          </a:xfrm>
+          <a:prstGeom prst="rect">
+            <a:avLst/>
+          </a:prstGeom>
+          <a:noFill/>
+          <a:ln/>
+        </p:spPr>
+        <p:txBody>
+          <a:bodyPr wrap="square" lIns="0" tIns="0" rIns="0" bIns="0" rtlCol="0" anchor="t"/>
+          <a:lstStyle/>
+          <a:p>
+            <a:pPr algn="ctr" indent="0" marL="0">
+              <a:lnSpc>
+                <a:spcPct val="90000"/>
+              </a:lnSpc>
+              <a:buNone/>
+            </a:pPr>
+            <a:r>
+              <a:rPr lang="en-US" sz="900" b="1" dirty="0">
+                <a:solidFill>
+                  <a:srgbClr val="3A4A5A"/>
+                </a:solidFill>
+                <a:latin typeface="Calibri" pitchFamily="34" charset="0"/>
+                <a:ea typeface="Calibri" pitchFamily="34" charset="-122"/>
+                <a:cs typeface="Calibri" pitchFamily="34" charset="-120"/>
+              </a:rPr>
+              <a:t>JDBC</a:t>
+            </a:r>
+            <a:endParaRPr lang="en-US" sz="900" dirty="0"/>
+          </a:p>
+        </p:txBody>
+      </p:sp>
+      <p:sp>
+        <p:nvSpPr>
+          <p:cNvPr id="22" name="Shape 19"/>
+          <p:cNvSpPr/>
+          <p:nvPr/>
+        </p:nvSpPr>
+        <p:spPr>
+          <a:xfrm>
+            <a:off x="2697480" y="3401568"/>
+            <a:ext cx="457200" cy="457200"/>
+          </a:xfrm>
+          <a:prstGeom prst="ellipse">
+            <a:avLst/>
+          </a:prstGeom>
+          <a:solidFill>
+            <a:srgbClr val="1AA8A0"/>
+          </a:solidFill>
+          <a:ln/>
+        </p:spPr>
+      </p:sp>
+      <p:pic>
+        <p:nvPicPr>
+          <p:cNvPr id="23" name="Image 1" descr="preencoded.png">    </p:cNvPr>
+          <p:cNvPicPr>
+            <a:picLocks noChangeAspect="1"/>
+          </p:cNvPicPr>
+          <p:nvPr/>
+        </p:nvPicPr>
+        <p:blipFill>
+          <a:blip r:embed="rId2"/>
+          <a:stretch>
+            <a:fillRect/>
+          </a:stretch>
+        </p:blipFill>
+        <p:spPr>
+          <a:xfrm>
+            <a:off x="2811780" y="3515868"/>
+            <a:ext cx="228600" cy="228600"/>
+          </a:xfrm>
+          <a:prstGeom prst="rect">
+            <a:avLst/>
+          </a:prstGeom>
+        </p:spPr>
+      </p:pic>
+      <p:sp>
+        <p:nvSpPr>
+          <p:cNvPr id="24" name="Text 20"/>
+          <p:cNvSpPr/>
+          <p:nvPr/>
+        </p:nvSpPr>
+        <p:spPr>
+          <a:xfrm>
+            <a:off x="2377440" y="3886200"/>
+            <a:ext cx="1097280" cy="329184"/>
+          </a:xfrm>
+          <a:prstGeom prst="rect">
+            <a:avLst/>
+          </a:prstGeom>
+          <a:noFill/>
+          <a:ln/>
+        </p:spPr>
+        <p:txBody>
+          <a:bodyPr wrap="square" lIns="0" tIns="0" rIns="0" bIns="0" rtlCol="0" anchor="t"/>
+          <a:lstStyle/>
+          <a:p>
+            <a:pPr algn="ctr" indent="0" marL="0">
+              <a:lnSpc>
+                <a:spcPct val="90000"/>
+              </a:lnSpc>
+              <a:buNone/>
+            </a:pPr>
+            <a:r>
+              <a:rPr lang="en-US" sz="900" b="1" dirty="0">
+                <a:solidFill>
+                  <a:srgbClr val="3A4A5A"/>
+                </a:solidFill>
+                <a:latin typeface="Calibri" pitchFamily="34" charset="0"/>
+                <a:ea typeface="Calibri" pitchFamily="34" charset="-122"/>
+                <a:cs typeface="Calibri" pitchFamily="34" charset="-120"/>
+              </a:rPr>
+              <a:t>Files</a:t>
+            </a:r>
+            <a:endParaRPr lang="en-US" sz="900" dirty="0"/>
+          </a:p>
+        </p:txBody>
+      </p:sp>
+      <p:sp>
+        <p:nvSpPr>
+          <p:cNvPr id="25" name="Shape 21"/>
+          <p:cNvSpPr/>
+          <p:nvPr/>
+        </p:nvSpPr>
+        <p:spPr>
+          <a:xfrm>
+            <a:off x="2697480" y="4261104"/>
+            <a:ext cx="457200" cy="457200"/>
+          </a:xfrm>
+          <a:prstGeom prst="ellipse">
+            <a:avLst/>
+          </a:prstGeom>
+          <a:solidFill>
+            <a:srgbClr val="1AA8A0"/>
+          </a:solidFill>
+          <a:ln/>
+        </p:spPr>
+      </p:sp>
+      <p:pic>
+        <p:nvPicPr>
+          <p:cNvPr id="26" name="Image 2" descr="preencoded.png">    </p:cNvPr>
+          <p:cNvPicPr>
+            <a:picLocks noChangeAspect="1"/>
+          </p:cNvPicPr>
+          <p:nvPr/>
+        </p:nvPicPr>
+        <p:blipFill>
+          <a:blip r:embed="rId3"/>
+          <a:stretch>
+            <a:fillRect/>
+          </a:stretch>
+        </p:blipFill>
+        <p:spPr>
+          <a:xfrm>
+            <a:off x="2811780" y="4375404"/>
+            <a:ext cx="228600" cy="228600"/>
+          </a:xfrm>
+          <a:prstGeom prst="rect">
+            <a:avLst/>
+          </a:prstGeom>
+        </p:spPr>
+      </p:pic>
+      <p:sp>
+        <p:nvSpPr>
+          <p:cNvPr id="27" name="Text 22"/>
+          <p:cNvSpPr/>
+          <p:nvPr/>
+        </p:nvSpPr>
+        <p:spPr>
+          <a:xfrm>
+            <a:off x="2331720" y="4745736"/>
+            <a:ext cx="1188720" cy="329184"/>
+          </a:xfrm>
+          <a:prstGeom prst="rect">
+            <a:avLst/>
+          </a:prstGeom>
+          <a:noFill/>
+          <a:ln/>
+        </p:spPr>
+        <p:txBody>
+          <a:bodyPr wrap="square" lIns="0" tIns="0" rIns="0" bIns="0" rtlCol="0" anchor="t"/>
+          <a:lstStyle/>
+          <a:p>
+            <a:pPr algn="ctr" indent="0" marL="0">
+              <a:lnSpc>
+                <a:spcPct val="90000"/>
+              </a:lnSpc>
+              <a:buNone/>
+            </a:pPr>
+            <a:r>
+              <a:rPr lang="en-US" sz="900" b="1" dirty="0">
+                <a:solidFill>
+                  <a:srgbClr val="3A4A5A"/>
+                </a:solidFill>
+                <a:latin typeface="Calibri" pitchFamily="34" charset="0"/>
+                <a:ea typeface="Calibri" pitchFamily="34" charset="-122"/>
+                <a:cs typeface="Calibri" pitchFamily="34" charset="-120"/>
+              </a:rPr>
+              <a:t>Web Services</a:t>
+            </a:r>
+            <a:endParaRPr lang="en-US" sz="900" dirty="0"/>
+          </a:p>
+        </p:txBody>
+      </p:sp>
+      <p:sp>
+        <p:nvSpPr>
+          <p:cNvPr id="28" name="Shape 23"/>
+          <p:cNvSpPr/>
+          <p:nvPr/>
+        </p:nvSpPr>
+        <p:spPr>
+          <a:xfrm>
+            <a:off x="3703320" y="2103120"/>
+            <a:ext cx="1874520" cy="3246120"/>
+          </a:xfrm>
+          <a:prstGeom prst="rect">
+            <a:avLst/>
+          </a:prstGeom>
+          <a:solidFill>
+            <a:srgbClr val="FFFFFF"/>
+          </a:solidFill>
+          <a:ln w="15875">
+            <a:solidFill>
+              <a:srgbClr val="1AA8A0"/>
+            </a:solidFill>
+            <a:prstDash val="solid"/>
+          </a:ln>
+        </p:spPr>
+      </p:sp>
+      <p:sp>
+        <p:nvSpPr>
+          <p:cNvPr id="29" name="Text 24"/>
+          <p:cNvSpPr/>
+          <p:nvPr/>
+        </p:nvSpPr>
+        <p:spPr>
+          <a:xfrm>
+            <a:off x="3749040" y="2194560"/>
+            <a:ext cx="1783080" cy="457200"/>
+          </a:xfrm>
+          <a:prstGeom prst="rect">
+            <a:avLst/>
+          </a:prstGeom>
+          <a:noFill/>
+          <a:ln/>
+        </p:spPr>
+        <p:txBody>
+          <a:bodyPr wrap="square" lIns="0" tIns="0" rIns="0" bIns="0" rtlCol="0" anchor="t"/>
+          <a:lstStyle/>
+          <a:p>
+            <a:pPr algn="l" indent="0" marL="0">
+              <a:lnSpc>
+                <a:spcPct val="95000"/>
+              </a:lnSpc>
+              <a:buNone/>
+            </a:pPr>
+            <a:r>
+              <a:rPr lang="en-US" sz="1000" b="1" dirty="0">
+                <a:solidFill>
+                  <a:srgbClr val="1AA8A0"/>
+                </a:solidFill>
+                <a:latin typeface="Calibri" pitchFamily="34" charset="0"/>
+                <a:ea typeface="Calibri" pitchFamily="34" charset="-122"/>
+                <a:cs typeface="Calibri" pitchFamily="34" charset="-120"/>
+              </a:rPr>
+              <a:t>Data Pipeline &amp; Orchestration</a:t>
+            </a:r>
+            <a:endParaRPr lang="en-US" sz="1000" dirty="0"/>
+          </a:p>
+        </p:txBody>
+      </p:sp>
+      <p:sp>
+        <p:nvSpPr>
+          <p:cNvPr id="30" name="Shape 25"/>
+          <p:cNvSpPr/>
+          <p:nvPr/>
+        </p:nvSpPr>
+        <p:spPr>
+          <a:xfrm>
+            <a:off x="3822192" y="2724912"/>
+            <a:ext cx="384048" cy="384048"/>
+          </a:xfrm>
+          <a:prstGeom prst="ellipse">
+            <a:avLst/>
+          </a:prstGeom>
+          <a:solidFill>
+            <a:srgbClr val="2FB57F"/>
+          </a:solidFill>
+          <a:ln/>
+        </p:spPr>
+      </p:sp>
+      <p:pic>
+        <p:nvPicPr>
+          <p:cNvPr id="31" name="Image 3" descr="preencoded.png">    </p:cNvPr>
+          <p:cNvPicPr>
+            <a:picLocks noChangeAspect="1"/>
+          </p:cNvPicPr>
+          <p:nvPr/>
+        </p:nvPicPr>
+        <p:blipFill>
+          <a:blip r:embed="rId4"/>
+          <a:stretch>
+            <a:fillRect/>
+          </a:stretch>
+        </p:blipFill>
+        <p:spPr>
+          <a:xfrm>
+            <a:off x="3913632" y="2816352"/>
+            <a:ext cx="201168" cy="201168"/>
+          </a:xfrm>
+          <a:prstGeom prst="rect">
+            <a:avLst/>
+          </a:prstGeom>
+        </p:spPr>
+      </p:pic>
+      <p:sp>
+        <p:nvSpPr>
+          <p:cNvPr id="32" name="Text 26"/>
+          <p:cNvSpPr/>
+          <p:nvPr/>
+        </p:nvSpPr>
+        <p:spPr>
+          <a:xfrm>
+            <a:off x="4297680" y="2706624"/>
+            <a:ext cx="1234440" cy="420624"/>
+          </a:xfrm>
+          <a:prstGeom prst="rect">
+            <a:avLst/>
+          </a:prstGeom>
+          <a:noFill/>
+          <a:ln/>
+        </p:spPr>
+        <p:txBody>
+          <a:bodyPr wrap="square" lIns="0" tIns="0" rIns="0" bIns="0" rtlCol="0" anchor="ctr"/>
+          <a:lstStyle/>
+          <a:p>
+            <a:pPr algn="l" indent="0" marL="0">
+              <a:lnSpc>
+                <a:spcPct val="90000"/>
+              </a:lnSpc>
+              <a:buNone/>
+            </a:pPr>
+            <a:r>
+              <a:rPr lang="en-US" sz="950" b="1" dirty="0">
+                <a:solidFill>
+                  <a:srgbClr val="3A4A5A"/>
+                </a:solidFill>
+                <a:latin typeface="Calibri" pitchFamily="34" charset="0"/>
+                <a:ea typeface="Calibri" pitchFamily="34" charset="-122"/>
+                <a:cs typeface="Calibri" pitchFamily="34" charset="-120"/>
+              </a:rPr>
+              <a:t>Batch data</a:t>
+            </a:r>
+            <a:endParaRPr lang="en-US" sz="950" dirty="0"/>
+          </a:p>
+          <a:p>
+            <a:pPr algn="l" indent="0" marL="0">
+              <a:lnSpc>
+                <a:spcPct val="90000"/>
+              </a:lnSpc>
+              <a:buNone/>
+            </a:pPr>
+            <a:r>
+              <a:rPr lang="en-US" sz="950" b="1" dirty="0">
+                <a:solidFill>
+                  <a:srgbClr val="3A4A5A"/>
+                </a:solidFill>
+                <a:latin typeface="Calibri" pitchFamily="34" charset="0"/>
+                <a:ea typeface="Calibri" pitchFamily="34" charset="-122"/>
+                <a:cs typeface="Calibri" pitchFamily="34" charset="-120"/>
+              </a:rPr>
+              <a:t>processing</a:t>
+            </a:r>
+            <a:endParaRPr lang="en-US" sz="950" dirty="0"/>
+          </a:p>
+        </p:txBody>
+      </p:sp>
+      <p:sp>
+        <p:nvSpPr>
+          <p:cNvPr id="33" name="Shape 27"/>
+          <p:cNvSpPr/>
+          <p:nvPr/>
+        </p:nvSpPr>
+        <p:spPr>
+          <a:xfrm>
+            <a:off x="3822192" y="3200400"/>
+            <a:ext cx="384048" cy="384048"/>
+          </a:xfrm>
+          <a:prstGeom prst="ellipse">
+            <a:avLst/>
+          </a:prstGeom>
+          <a:solidFill>
+            <a:srgbClr val="2FB57F"/>
+          </a:solidFill>
+          <a:ln/>
+        </p:spPr>
+      </p:sp>
+      <p:pic>
+        <p:nvPicPr>
+          <p:cNvPr id="34" name="Image 4" descr="preencoded.png">    </p:cNvPr>
+          <p:cNvPicPr>
+            <a:picLocks noChangeAspect="1"/>
+          </p:cNvPicPr>
+          <p:nvPr/>
+        </p:nvPicPr>
+        <p:blipFill>
+          <a:blip r:embed="rId5"/>
+          <a:stretch>
+            <a:fillRect/>
+          </a:stretch>
+        </p:blipFill>
+        <p:spPr>
+          <a:xfrm>
+            <a:off x="3913632" y="3291840"/>
+            <a:ext cx="201168" cy="201168"/>
+          </a:xfrm>
+          <a:prstGeom prst="rect">
+            <a:avLst/>
+          </a:prstGeom>
+        </p:spPr>
+      </p:pic>
+      <p:sp>
+        <p:nvSpPr>
+          <p:cNvPr id="35" name="Text 28"/>
+          <p:cNvSpPr/>
+          <p:nvPr/>
+        </p:nvSpPr>
+        <p:spPr>
+          <a:xfrm>
+            <a:off x="4297680" y="3182112"/>
+            <a:ext cx="1234440" cy="420624"/>
+          </a:xfrm>
+          <a:prstGeom prst="rect">
+            <a:avLst/>
+          </a:prstGeom>
+          <a:noFill/>
+          <a:ln/>
+        </p:spPr>
+        <p:txBody>
+          <a:bodyPr wrap="square" lIns="0" tIns="0" rIns="0" bIns="0" rtlCol="0" anchor="ctr"/>
+          <a:lstStyle/>
+          <a:p>
+            <a:pPr algn="l" indent="0" marL="0">
+              <a:lnSpc>
+                <a:spcPct val="90000"/>
+              </a:lnSpc>
+              <a:buNone/>
+            </a:pPr>
+            <a:r>
+              <a:rPr lang="en-US" sz="950" b="1" dirty="0">
+                <a:solidFill>
+                  <a:srgbClr val="3A4A5A"/>
+                </a:solidFill>
+                <a:latin typeface="Calibri" pitchFamily="34" charset="0"/>
+                <a:ea typeface="Calibri" pitchFamily="34" charset="-122"/>
+                <a:cs typeface="Calibri" pitchFamily="34" charset="-120"/>
+              </a:rPr>
+              <a:t>Real Time / Near</a:t>
+            </a:r>
+            <a:endParaRPr lang="en-US" sz="950" dirty="0"/>
+          </a:p>
+          <a:p>
+            <a:pPr algn="l" indent="0" marL="0">
+              <a:lnSpc>
+                <a:spcPct val="90000"/>
+              </a:lnSpc>
+              <a:buNone/>
+            </a:pPr>
+            <a:r>
+              <a:rPr lang="en-US" sz="950" b="1" dirty="0">
+                <a:solidFill>
+                  <a:srgbClr val="3A4A5A"/>
+                </a:solidFill>
+                <a:latin typeface="Calibri" pitchFamily="34" charset="0"/>
+                <a:ea typeface="Calibri" pitchFamily="34" charset="-122"/>
+                <a:cs typeface="Calibri" pitchFamily="34" charset="-120"/>
+              </a:rPr>
+              <a:t>Real Time</a:t>
+            </a:r>
+            <a:endParaRPr lang="en-US" sz="950" dirty="0"/>
+          </a:p>
+        </p:txBody>
+      </p:sp>
+      <p:sp>
+        <p:nvSpPr>
+          <p:cNvPr id="36" name="Text 29"/>
+          <p:cNvSpPr/>
+          <p:nvPr/>
+        </p:nvSpPr>
+        <p:spPr>
+          <a:xfrm>
+            <a:off x="3822192" y="3730752"/>
+            <a:ext cx="1280160" cy="237744"/>
+          </a:xfrm>
+          <a:prstGeom prst="rect">
+            <a:avLst/>
+          </a:prstGeom>
+          <a:noFill/>
+          <a:ln/>
+        </p:spPr>
+        <p:txBody>
+          <a:bodyPr wrap="square" lIns="0" tIns="0" rIns="0" bIns="0" rtlCol="0" anchor="ctr"/>
+          <a:lstStyle/>
+          <a:p>
+            <a:pPr algn="l" indent="0" marL="0">
+              <a:buNone/>
+            </a:pPr>
+            <a:r>
+              <a:rPr lang="en-US" sz="950" b="1" dirty="0">
+                <a:solidFill>
+                  <a:srgbClr val="3A4A5A"/>
+                </a:solidFill>
+                <a:latin typeface="Calibri" pitchFamily="34" charset="0"/>
+                <a:ea typeface="Calibri" pitchFamily="34" charset="-122"/>
+                <a:cs typeface="Calibri" pitchFamily="34" charset="-120"/>
+              </a:rPr>
+              <a:t>Processing Layer</a:t>
+            </a:r>
+            <a:endParaRPr lang="en-US" sz="950" dirty="0"/>
+          </a:p>
+        </p:txBody>
+      </p:sp>
+      <p:sp>
+        <p:nvSpPr>
+          <p:cNvPr id="37" name="Shape 30"/>
+          <p:cNvSpPr/>
+          <p:nvPr/>
+        </p:nvSpPr>
+        <p:spPr>
+          <a:xfrm>
+            <a:off x="5029200" y="3675888"/>
+            <a:ext cx="457200" cy="457200"/>
+          </a:xfrm>
+          <a:prstGeom prst="ellipse">
+            <a:avLst/>
+          </a:prstGeom>
+          <a:solidFill>
+            <a:srgbClr val="2FB57F"/>
+          </a:solidFill>
+          <a:ln/>
+        </p:spPr>
+      </p:sp>
+      <p:pic>
+        <p:nvPicPr>
+          <p:cNvPr id="38" name="Image 5" descr="preencoded.png">    </p:cNvPr>
+          <p:cNvPicPr>
+            <a:picLocks noChangeAspect="1"/>
+          </p:cNvPicPr>
+          <p:nvPr/>
+        </p:nvPicPr>
+        <p:blipFill>
+          <a:blip r:embed="rId6"/>
+          <a:stretch>
+            <a:fillRect/>
+          </a:stretch>
+        </p:blipFill>
+        <p:spPr>
+          <a:xfrm>
+            <a:off x="5129784" y="3776472"/>
+            <a:ext cx="256032" cy="256032"/>
+          </a:xfrm>
+          <a:prstGeom prst="rect">
+            <a:avLst/>
+          </a:prstGeom>
+        </p:spPr>
+      </p:pic>
+      <p:sp>
+        <p:nvSpPr>
+          <p:cNvPr id="39" name="Shape 31"/>
+          <p:cNvSpPr/>
+          <p:nvPr/>
+        </p:nvSpPr>
+        <p:spPr>
+          <a:xfrm>
+            <a:off x="3895344" y="4114800"/>
+            <a:ext cx="0" cy="914400"/>
+          </a:xfrm>
+          <a:prstGeom prst="line">
+            <a:avLst/>
+          </a:prstGeom>
+          <a:noFill/>
+          <a:ln w="12700">
+            <a:solidFill>
+              <a:srgbClr val="2FB57F"/>
+            </a:solidFill>
+            <a:prstDash val="solid"/>
+          </a:ln>
+        </p:spPr>
+      </p:sp>
+      <p:sp>
+        <p:nvSpPr>
+          <p:cNvPr id="40" name="Shape 32"/>
+          <p:cNvSpPr/>
+          <p:nvPr/>
+        </p:nvSpPr>
+        <p:spPr>
+          <a:xfrm>
+            <a:off x="3849624" y="4114800"/>
+            <a:ext cx="91440" cy="91440"/>
+          </a:xfrm>
+          <a:prstGeom prst="ellipse">
+            <a:avLst/>
+          </a:prstGeom>
+          <a:solidFill>
+            <a:srgbClr val="2FB57F"/>
+          </a:solidFill>
+          <a:ln/>
+        </p:spPr>
+      </p:sp>
+      <p:sp>
+        <p:nvSpPr>
+          <p:cNvPr id="41" name="Text 33"/>
+          <p:cNvSpPr/>
+          <p:nvPr/>
+        </p:nvSpPr>
+        <p:spPr>
+          <a:xfrm>
+            <a:off x="4023360" y="4059936"/>
+            <a:ext cx="1508760" cy="274320"/>
+          </a:xfrm>
+          <a:prstGeom prst="rect">
+            <a:avLst/>
+          </a:prstGeom>
+          <a:noFill/>
+          <a:ln/>
+        </p:spPr>
+        <p:txBody>
+          <a:bodyPr wrap="square" lIns="0" tIns="0" rIns="0" bIns="0" rtlCol="0" anchor="t"/>
+          <a:lstStyle/>
+          <a:p>
+            <a:pPr algn="l" indent="0" marL="0">
+              <a:lnSpc>
+                <a:spcPct val="85000"/>
+              </a:lnSpc>
+              <a:buNone/>
+            </a:pPr>
+            <a:r>
+              <a:rPr lang="en-US" sz="820" dirty="0">
+                <a:solidFill>
+                  <a:srgbClr val="6B7B8B"/>
+                </a:solidFill>
+                <a:latin typeface="Calibri" pitchFamily="34" charset="0"/>
+                <a:ea typeface="Calibri" pitchFamily="34" charset="-122"/>
+                <a:cs typeface="Calibri" pitchFamily="34" charset="-120"/>
+              </a:rPr>
+              <a:t>Data Quality Check</a:t>
+            </a:r>
+            <a:endParaRPr lang="en-US" sz="820" dirty="0"/>
+          </a:p>
+        </p:txBody>
+      </p:sp>
+      <p:sp>
+        <p:nvSpPr>
+          <p:cNvPr id="42" name="Shape 34"/>
+          <p:cNvSpPr/>
+          <p:nvPr/>
+        </p:nvSpPr>
+        <p:spPr>
+          <a:xfrm>
+            <a:off x="3849624" y="4425696"/>
+            <a:ext cx="91440" cy="91440"/>
+          </a:xfrm>
+          <a:prstGeom prst="ellipse">
+            <a:avLst/>
+          </a:prstGeom>
+          <a:solidFill>
+            <a:srgbClr val="2FB57F"/>
+          </a:solidFill>
+          <a:ln/>
+        </p:spPr>
+      </p:sp>
+      <p:sp>
+        <p:nvSpPr>
+          <p:cNvPr id="43" name="Text 35"/>
+          <p:cNvSpPr/>
+          <p:nvPr/>
+        </p:nvSpPr>
+        <p:spPr>
+          <a:xfrm>
+            <a:off x="4023360" y="4370832"/>
+            <a:ext cx="1508760" cy="274320"/>
+          </a:xfrm>
+          <a:prstGeom prst="rect">
+            <a:avLst/>
+          </a:prstGeom>
+          <a:noFill/>
+          <a:ln/>
+        </p:spPr>
+        <p:txBody>
+          <a:bodyPr wrap="square" lIns="0" tIns="0" rIns="0" bIns="0" rtlCol="0" anchor="t"/>
+          <a:lstStyle/>
+          <a:p>
+            <a:pPr algn="l" indent="0" marL="0">
+              <a:lnSpc>
+                <a:spcPct val="85000"/>
+              </a:lnSpc>
+              <a:buNone/>
+            </a:pPr>
+            <a:r>
+              <a:rPr lang="en-US" sz="820" dirty="0">
+                <a:solidFill>
+                  <a:srgbClr val="6B7B8B"/>
+                </a:solidFill>
+                <a:latin typeface="Calibri" pitchFamily="34" charset="0"/>
+                <a:ea typeface="Calibri" pitchFamily="34" charset="-122"/>
+                <a:cs typeface="Calibri" pitchFamily="34" charset="-120"/>
+              </a:rPr>
+              <a:t>Data Transformations</a:t>
+            </a:r>
+            <a:endParaRPr lang="en-US" sz="820" dirty="0"/>
+          </a:p>
+        </p:txBody>
+      </p:sp>
+      <p:sp>
+        <p:nvSpPr>
+          <p:cNvPr id="44" name="Shape 36"/>
+          <p:cNvSpPr/>
+          <p:nvPr/>
+        </p:nvSpPr>
+        <p:spPr>
+          <a:xfrm>
+            <a:off x="3849624" y="4736592"/>
+            <a:ext cx="91440" cy="91440"/>
+          </a:xfrm>
+          <a:prstGeom prst="ellipse">
+            <a:avLst/>
+          </a:prstGeom>
+          <a:solidFill>
+            <a:srgbClr val="2FB57F"/>
+          </a:solidFill>
+          <a:ln/>
+        </p:spPr>
+      </p:sp>
+      <p:sp>
+        <p:nvSpPr>
+          <p:cNvPr id="45" name="Text 37"/>
+          <p:cNvSpPr/>
+          <p:nvPr/>
+        </p:nvSpPr>
+        <p:spPr>
+          <a:xfrm>
+            <a:off x="4023360" y="4681728"/>
+            <a:ext cx="1508760" cy="274320"/>
+          </a:xfrm>
+          <a:prstGeom prst="rect">
+            <a:avLst/>
+          </a:prstGeom>
+          <a:noFill/>
+          <a:ln/>
+        </p:spPr>
+        <p:txBody>
+          <a:bodyPr wrap="square" lIns="0" tIns="0" rIns="0" bIns="0" rtlCol="0" anchor="t"/>
+          <a:lstStyle/>
+          <a:p>
+            <a:pPr algn="l" indent="0" marL="0">
+              <a:lnSpc>
+                <a:spcPct val="85000"/>
+              </a:lnSpc>
+              <a:buNone/>
+            </a:pPr>
+            <a:r>
+              <a:rPr lang="en-US" sz="820" dirty="0">
+                <a:solidFill>
+                  <a:srgbClr val="6B7B8B"/>
+                </a:solidFill>
+                <a:latin typeface="Calibri" pitchFamily="34" charset="0"/>
+                <a:ea typeface="Calibri" pitchFamily="34" charset="-122"/>
+                <a:cs typeface="Calibri" pitchFamily="34" charset="-120"/>
+              </a:rPr>
+              <a:t>Data Aggregations &amp;</a:t>
+            </a:r>
+            <a:endParaRPr lang="en-US" sz="820" dirty="0"/>
+          </a:p>
+          <a:p>
+            <a:pPr algn="l" indent="0" marL="0">
+              <a:lnSpc>
+                <a:spcPct val="85000"/>
+              </a:lnSpc>
+              <a:buNone/>
+            </a:pPr>
+            <a:r>
+              <a:rPr lang="en-US" sz="820" dirty="0">
+                <a:solidFill>
+                  <a:srgbClr val="6B7B8B"/>
+                </a:solidFill>
+                <a:latin typeface="Calibri" pitchFamily="34" charset="0"/>
+                <a:ea typeface="Calibri" pitchFamily="34" charset="-122"/>
+                <a:cs typeface="Calibri" pitchFamily="34" charset="-120"/>
+              </a:rPr>
+              <a:t>Normalizations</a:t>
+            </a:r>
+            <a:endParaRPr lang="en-US" sz="820" dirty="0"/>
+          </a:p>
+        </p:txBody>
+      </p:sp>
+      <p:sp>
+        <p:nvSpPr>
+          <p:cNvPr id="46" name="Shape 38"/>
+          <p:cNvSpPr/>
+          <p:nvPr/>
+        </p:nvSpPr>
+        <p:spPr>
+          <a:xfrm>
+            <a:off x="5779008" y="2212848"/>
+            <a:ext cx="1280160" cy="1280160"/>
+          </a:xfrm>
+          <a:prstGeom prst="ellipse">
+            <a:avLst/>
+          </a:prstGeom>
+          <a:ln w="12700">
+            <a:solidFill>
+              <a:srgbClr val="5B9BD5"/>
+            </a:solidFill>
+            <a:prstDash val="dash"/>
+          </a:ln>
+        </p:spPr>
+      </p:sp>
+      <p:sp>
+        <p:nvSpPr>
+          <p:cNvPr id="47" name="Shape 39"/>
+          <p:cNvSpPr/>
+          <p:nvPr/>
+        </p:nvSpPr>
+        <p:spPr>
+          <a:xfrm>
+            <a:off x="5870448" y="2304288"/>
+            <a:ext cx="1097280" cy="1097280"/>
+          </a:xfrm>
+          <a:prstGeom prst="ellipse">
+            <a:avLst/>
+          </a:prstGeom>
+          <a:solidFill>
+            <a:srgbClr val="EAF3FB"/>
+          </a:solidFill>
+          <a:ln w="22225">
+            <a:solidFill>
+              <a:srgbClr val="F2647A"/>
+            </a:solidFill>
+            <a:prstDash val="solid"/>
+          </a:ln>
+        </p:spPr>
+      </p:sp>
+      <p:sp>
+        <p:nvSpPr>
+          <p:cNvPr id="48" name="Shape 40"/>
+          <p:cNvSpPr/>
+          <p:nvPr/>
+        </p:nvSpPr>
+        <p:spPr>
+          <a:xfrm>
+            <a:off x="6254496" y="2505456"/>
+            <a:ext cx="329184" cy="329184"/>
+          </a:xfrm>
+          <a:prstGeom prst="ellipse">
+            <a:avLst/>
+          </a:prstGeom>
+          <a:solidFill>
+            <a:srgbClr val="1F3C88"/>
+          </a:solidFill>
+          <a:ln/>
+        </p:spPr>
+      </p:sp>
+      <p:pic>
+        <p:nvPicPr>
+          <p:cNvPr id="49" name="Image 6" descr="preencoded.png">    </p:cNvPr>
+          <p:cNvPicPr>
+            <a:picLocks noChangeAspect="1"/>
+          </p:cNvPicPr>
+          <p:nvPr/>
+        </p:nvPicPr>
+        <p:blipFill>
+          <a:blip r:embed="rId7"/>
+          <a:stretch>
+            <a:fillRect/>
+          </a:stretch>
+        </p:blipFill>
+        <p:spPr>
+          <a:xfrm>
+            <a:off x="6318504" y="2569464"/>
+            <a:ext cx="201168" cy="201168"/>
+          </a:xfrm>
+          <a:prstGeom prst="rect">
+            <a:avLst/>
+          </a:prstGeom>
+        </p:spPr>
+      </p:pic>
+      <p:sp>
+        <p:nvSpPr>
+          <p:cNvPr id="50" name="Shape 41"/>
+          <p:cNvSpPr/>
+          <p:nvPr/>
+        </p:nvSpPr>
+        <p:spPr>
+          <a:xfrm>
+            <a:off x="6053328" y="2926080"/>
+            <a:ext cx="731520" cy="0"/>
+          </a:xfrm>
+          <a:prstGeom prst="line">
+            <a:avLst/>
+          </a:prstGeom>
+          <a:noFill/>
+          <a:ln w="19050">
+            <a:solidFill>
+              <a:srgbClr val="5B9BD5"/>
+            </a:solidFill>
+            <a:prstDash val="solid"/>
+          </a:ln>
+        </p:spPr>
+      </p:sp>
+      <p:sp>
+        <p:nvSpPr>
+          <p:cNvPr id="51" name="Shape 42"/>
+          <p:cNvSpPr/>
+          <p:nvPr/>
+        </p:nvSpPr>
+        <p:spPr>
+          <a:xfrm>
+            <a:off x="6053328" y="3044952"/>
+            <a:ext cx="731520" cy="0"/>
+          </a:xfrm>
+          <a:prstGeom prst="line">
+            <a:avLst/>
+          </a:prstGeom>
+          <a:noFill/>
+          <a:ln w="19050">
+            <a:solidFill>
+              <a:srgbClr val="5B9BD5"/>
+            </a:solidFill>
+            <a:prstDash val="solid"/>
+          </a:ln>
+        </p:spPr>
+      </p:sp>
+      <p:sp>
+        <p:nvSpPr>
+          <p:cNvPr id="52" name="Shape 43"/>
+          <p:cNvSpPr/>
+          <p:nvPr/>
+        </p:nvSpPr>
+        <p:spPr>
+          <a:xfrm>
+            <a:off x="6053328" y="3163824"/>
+            <a:ext cx="731520" cy="0"/>
+          </a:xfrm>
+          <a:prstGeom prst="line">
+            <a:avLst/>
+          </a:prstGeom>
+          <a:noFill/>
+          <a:ln w="19050">
+            <a:solidFill>
+              <a:srgbClr val="5B9BD5"/>
+            </a:solidFill>
+            <a:prstDash val="solid"/>
+          </a:ln>
+        </p:spPr>
+      </p:sp>
+      <p:sp>
+        <p:nvSpPr>
+          <p:cNvPr id="53" name="Shape 44"/>
+          <p:cNvSpPr/>
+          <p:nvPr/>
+        </p:nvSpPr>
+        <p:spPr>
+          <a:xfrm>
+            <a:off x="5596128" y="3657600"/>
+            <a:ext cx="1645920" cy="457200"/>
+          </a:xfrm>
+          <a:prstGeom prst="rect">
+            <a:avLst/>
+          </a:prstGeom>
+          <a:solidFill>
+            <a:srgbClr val="DDE6F0"/>
+          </a:solidFill>
+          <a:ln w="9525">
+            <a:solidFill>
+              <a:srgbClr val="C5CBD4"/>
+            </a:solidFill>
+            <a:prstDash val="solid"/>
+          </a:ln>
+        </p:spPr>
+      </p:sp>
+      <p:sp>
+        <p:nvSpPr>
+          <p:cNvPr id="54" name="Text 45"/>
+          <p:cNvSpPr/>
+          <p:nvPr/>
+        </p:nvSpPr>
+        <p:spPr>
+          <a:xfrm>
+            <a:off x="5596128" y="3657600"/>
+            <a:ext cx="1645920" cy="457200"/>
+          </a:xfrm>
+          <a:prstGeom prst="rect">
+            <a:avLst/>
+          </a:prstGeom>
+          <a:noFill/>
+          <a:ln/>
+        </p:spPr>
+        <p:txBody>
+          <a:bodyPr wrap="square" lIns="0" tIns="0" rIns="0" bIns="0" rtlCol="0" anchor="ctr"/>
+          <a:lstStyle/>
+          <a:p>
+            <a:pPr algn="ctr" indent="0" marL="0">
+              <a:lnSpc>
+                <a:spcPct val="90000"/>
+              </a:lnSpc>
+              <a:buNone/>
+            </a:pPr>
+            <a:r>
+              <a:rPr lang="en-US" sz="950" b="1" dirty="0">
+                <a:solidFill>
+                  <a:srgbClr val="3A4A5A"/>
+                </a:solidFill>
+                <a:latin typeface="Calibri" pitchFamily="34" charset="0"/>
+                <a:ea typeface="Calibri" pitchFamily="34" charset="-122"/>
+                <a:cs typeface="Calibri" pitchFamily="34" charset="-120"/>
+              </a:rPr>
+              <a:t>Lumenore Data</a:t>
+            </a:r>
+            <a:endParaRPr lang="en-US" sz="950" dirty="0"/>
+          </a:p>
+          <a:p>
+            <a:pPr algn="ctr" indent="0" marL="0">
+              <a:lnSpc>
+                <a:spcPct val="90000"/>
+              </a:lnSpc>
+              <a:buNone/>
+            </a:pPr>
+            <a:r>
+              <a:rPr lang="en-US" sz="950" b="1" dirty="0">
+                <a:solidFill>
+                  <a:srgbClr val="3A4A5A"/>
+                </a:solidFill>
+                <a:latin typeface="Calibri" pitchFamily="34" charset="0"/>
+                <a:ea typeface="Calibri" pitchFamily="34" charset="-122"/>
+                <a:cs typeface="Calibri" pitchFamily="34" charset="-120"/>
+              </a:rPr>
+              <a:t>Lakehouse</a:t>
+            </a:r>
+            <a:endParaRPr lang="en-US" sz="950" dirty="0"/>
+          </a:p>
+        </p:txBody>
+      </p:sp>
+      <p:pic>
+        <p:nvPicPr>
+          <p:cNvPr id="55" name="Image 7" descr="preencoded.png">    </p:cNvPr>
+          <p:cNvPicPr>
+            <a:picLocks noChangeAspect="1"/>
+          </p:cNvPicPr>
+          <p:nvPr/>
+        </p:nvPicPr>
+        <p:blipFill>
+          <a:blip r:embed="rId8"/>
+          <a:stretch>
+            <a:fillRect/>
+          </a:stretch>
+        </p:blipFill>
+        <p:spPr>
+          <a:xfrm>
+            <a:off x="7187184" y="2331720"/>
+            <a:ext cx="292608" cy="292608"/>
+          </a:xfrm>
+          <a:prstGeom prst="rect">
+            <a:avLst/>
+          </a:prstGeom>
+        </p:spPr>
+      </p:pic>
+      <p:pic>
+        <p:nvPicPr>
+          <p:cNvPr id="56" name="Image 8" descr="preencoded.png">    </p:cNvPr>
+          <p:cNvPicPr>
+            <a:picLocks noChangeAspect="1"/>
+          </p:cNvPicPr>
+          <p:nvPr/>
+        </p:nvPicPr>
+        <p:blipFill>
+          <a:blip r:embed="rId9"/>
+          <a:stretch>
+            <a:fillRect/>
+          </a:stretch>
+        </p:blipFill>
+        <p:spPr>
+          <a:xfrm>
+            <a:off x="7187184" y="3200400"/>
+            <a:ext cx="292608" cy="292608"/>
+          </a:xfrm>
+          <a:prstGeom prst="rect">
+            <a:avLst/>
+          </a:prstGeom>
+        </p:spPr>
+      </p:pic>
+      <p:sp>
+        <p:nvSpPr>
+          <p:cNvPr id="57" name="Shape 46"/>
+          <p:cNvSpPr/>
+          <p:nvPr/>
+        </p:nvSpPr>
+        <p:spPr>
+          <a:xfrm>
+            <a:off x="7726680" y="1554480"/>
+            <a:ext cx="2697480" cy="4297680"/>
+          </a:xfrm>
+          <a:prstGeom prst="rect">
+            <a:avLst/>
+          </a:prstGeom>
+          <a:solidFill>
+            <a:srgbClr val="EAF3FB"/>
+          </a:solidFill>
+          <a:ln w="12700">
+            <a:solidFill>
+              <a:srgbClr val="5B9BD5"/>
+            </a:solidFill>
+            <a:prstDash val="solid"/>
+          </a:ln>
+        </p:spPr>
+      </p:sp>
+      <p:sp>
+        <p:nvSpPr>
+          <p:cNvPr id="58" name="Text 47"/>
+          <p:cNvSpPr/>
+          <p:nvPr/>
+        </p:nvSpPr>
+        <p:spPr>
+          <a:xfrm>
+            <a:off x="7726680" y="1627632"/>
+            <a:ext cx="2697480" cy="274320"/>
+          </a:xfrm>
+          <a:prstGeom prst="rect">
+            <a:avLst/>
+          </a:prstGeom>
+          <a:noFill/>
+          <a:ln/>
+        </p:spPr>
+        <p:txBody>
+          <a:bodyPr wrap="square" lIns="0" tIns="0" rIns="0" bIns="0" rtlCol="0" anchor="ctr"/>
+          <a:lstStyle/>
+          <a:p>
+            <a:pPr algn="ctr" indent="0" marL="0">
+              <a:buNone/>
+            </a:pPr>
+            <a:r>
+              <a:rPr lang="en-US" sz="1200" dirty="0">
+                <a:solidFill>
+                  <a:srgbClr val="5B9BD5"/>
+                </a:solidFill>
+                <a:latin typeface="Calibri" pitchFamily="34" charset="0"/>
+                <a:ea typeface="Calibri" pitchFamily="34" charset="-122"/>
+                <a:cs typeface="Calibri" pitchFamily="34" charset="-120"/>
+              </a:rPr>
+              <a:t>Visualization &amp; Designing</a:t>
+            </a:r>
+            <a:endParaRPr lang="en-US" sz="1200" dirty="0"/>
+          </a:p>
+        </p:txBody>
+      </p:sp>
+      <p:sp>
+        <p:nvSpPr>
+          <p:cNvPr id="59" name="Shape 48"/>
+          <p:cNvSpPr/>
+          <p:nvPr/>
+        </p:nvSpPr>
+        <p:spPr>
+          <a:xfrm>
+            <a:off x="7882128" y="2057400"/>
+            <a:ext cx="2395728" cy="1097280"/>
+          </a:xfrm>
+          <a:prstGeom prst="rect">
+            <a:avLst/>
+          </a:prstGeom>
+          <a:solidFill>
+            <a:srgbClr val="FFFFFF"/>
+          </a:solidFill>
+          <a:ln w="15875">
+            <a:solidFill>
+              <a:srgbClr val="9457D6"/>
+            </a:solidFill>
+            <a:prstDash val="solid"/>
+          </a:ln>
+        </p:spPr>
+      </p:sp>
+      <p:sp>
+        <p:nvSpPr>
+          <p:cNvPr id="60" name="Shape 49"/>
+          <p:cNvSpPr/>
+          <p:nvPr/>
+        </p:nvSpPr>
+        <p:spPr>
+          <a:xfrm>
+            <a:off x="8211312" y="2240280"/>
+            <a:ext cx="548640" cy="548640"/>
+          </a:xfrm>
+          <a:prstGeom prst="ellipse">
+            <a:avLst/>
+          </a:prstGeom>
+          <a:solidFill>
+            <a:srgbClr val="9457D6"/>
+          </a:solidFill>
+          <a:ln/>
+        </p:spPr>
+      </p:sp>
+      <p:pic>
+        <p:nvPicPr>
+          <p:cNvPr id="61" name="Image 9" descr="preencoded.png">    </p:cNvPr>
+          <p:cNvPicPr>
+            <a:picLocks noChangeAspect="1"/>
+          </p:cNvPicPr>
+          <p:nvPr/>
+        </p:nvPicPr>
+        <p:blipFill>
+          <a:blip r:embed="rId10"/>
+          <a:stretch>
+            <a:fillRect/>
+          </a:stretch>
+        </p:blipFill>
+        <p:spPr>
+          <a:xfrm>
+            <a:off x="8348472" y="2377440"/>
+            <a:ext cx="274320" cy="274320"/>
+          </a:xfrm>
+          <a:prstGeom prst="rect">
+            <a:avLst/>
+          </a:prstGeom>
+        </p:spPr>
+      </p:pic>
+      <p:sp>
+        <p:nvSpPr>
+          <p:cNvPr id="62" name="Text 50"/>
+          <p:cNvSpPr/>
+          <p:nvPr/>
+        </p:nvSpPr>
+        <p:spPr>
+          <a:xfrm>
+            <a:off x="7845552" y="2816352"/>
+            <a:ext cx="1280160" cy="329184"/>
+          </a:xfrm>
+          <a:prstGeom prst="rect">
+            <a:avLst/>
+          </a:prstGeom>
+          <a:noFill/>
+          <a:ln/>
+        </p:spPr>
+        <p:txBody>
+          <a:bodyPr wrap="square" lIns="0" tIns="0" rIns="0" bIns="0" rtlCol="0" anchor="t"/>
+          <a:lstStyle/>
+          <a:p>
+            <a:pPr algn="ctr" indent="0" marL="0">
+              <a:lnSpc>
+                <a:spcPct val="90000"/>
+              </a:lnSpc>
+              <a:buNone/>
+            </a:pPr>
+            <a:r>
+              <a:rPr lang="en-US" sz="850" b="1" dirty="0">
+                <a:solidFill>
+                  <a:srgbClr val="3A4A5A"/>
+                </a:solidFill>
+                <a:latin typeface="Calibri" pitchFamily="34" charset="0"/>
+                <a:ea typeface="Calibri" pitchFamily="34" charset="-122"/>
+                <a:cs typeface="Calibri" pitchFamily="34" charset="-120"/>
+              </a:rPr>
+              <a:t>Storytelling</a:t>
+            </a:r>
+            <a:endParaRPr lang="en-US" sz="850" dirty="0"/>
+          </a:p>
+        </p:txBody>
+      </p:sp>
+      <p:sp>
+        <p:nvSpPr>
+          <p:cNvPr id="63" name="Shape 51"/>
+          <p:cNvSpPr/>
+          <p:nvPr/>
+        </p:nvSpPr>
+        <p:spPr>
+          <a:xfrm>
+            <a:off x="9372600" y="2240280"/>
+            <a:ext cx="548640" cy="548640"/>
+          </a:xfrm>
+          <a:prstGeom prst="ellipse">
+            <a:avLst/>
+          </a:prstGeom>
+          <a:solidFill>
+            <a:srgbClr val="5B9BD5"/>
+          </a:solidFill>
+          <a:ln/>
+        </p:spPr>
+      </p:sp>
+      <p:pic>
+        <p:nvPicPr>
+          <p:cNvPr id="64" name="Image 10" descr="preencoded.png">    </p:cNvPr>
+          <p:cNvPicPr>
+            <a:picLocks noChangeAspect="1"/>
+          </p:cNvPicPr>
+          <p:nvPr/>
+        </p:nvPicPr>
+        <p:blipFill>
+          <a:blip r:embed="rId11"/>
+          <a:stretch>
+            <a:fillRect/>
+          </a:stretch>
+        </p:blipFill>
+        <p:spPr>
+          <a:xfrm>
+            <a:off x="9509760" y="2377440"/>
+            <a:ext cx="274320" cy="274320"/>
+          </a:xfrm>
+          <a:prstGeom prst="rect">
+            <a:avLst/>
+          </a:prstGeom>
+        </p:spPr>
+      </p:pic>
+      <p:sp>
+        <p:nvSpPr>
+          <p:cNvPr id="65" name="Text 52"/>
+          <p:cNvSpPr/>
+          <p:nvPr/>
+        </p:nvSpPr>
+        <p:spPr>
+          <a:xfrm>
+            <a:off x="9006840" y="2816352"/>
+            <a:ext cx="1280160" cy="329184"/>
+          </a:xfrm>
+          <a:prstGeom prst="rect">
+            <a:avLst/>
+          </a:prstGeom>
+          <a:noFill/>
+          <a:ln/>
+        </p:spPr>
+        <p:txBody>
+          <a:bodyPr wrap="square" lIns="0" tIns="0" rIns="0" bIns="0" rtlCol="0" anchor="t"/>
+          <a:lstStyle/>
+          <a:p>
+            <a:pPr algn="ctr" indent="0" marL="0">
+              <a:lnSpc>
+                <a:spcPct val="90000"/>
+              </a:lnSpc>
+              <a:buNone/>
+            </a:pPr>
+            <a:r>
+              <a:rPr lang="en-US" sz="850" b="1" dirty="0">
+                <a:solidFill>
+                  <a:srgbClr val="3A4A5A"/>
+                </a:solidFill>
+                <a:latin typeface="Calibri" pitchFamily="34" charset="0"/>
+                <a:ea typeface="Calibri" pitchFamily="34" charset="-122"/>
+                <a:cs typeface="Calibri" pitchFamily="34" charset="-120"/>
+              </a:rPr>
+              <a:t>Dashboards</a:t>
+            </a:r>
+            <a:endParaRPr lang="en-US" sz="850" dirty="0"/>
+          </a:p>
+        </p:txBody>
+      </p:sp>
+      <p:sp>
+        <p:nvSpPr>
+          <p:cNvPr id="66" name="Shape 53"/>
+          <p:cNvSpPr/>
+          <p:nvPr/>
+        </p:nvSpPr>
+        <p:spPr>
+          <a:xfrm>
+            <a:off x="7882128" y="3383280"/>
+            <a:ext cx="2395728" cy="2331720"/>
+          </a:xfrm>
+          <a:prstGeom prst="rect">
+            <a:avLst/>
+          </a:prstGeom>
+          <a:solidFill>
+            <a:srgbClr val="FFFFFF"/>
+          </a:solidFill>
+          <a:ln w="12700">
+            <a:solidFill>
+              <a:srgbClr val="C5CBD4"/>
+            </a:solidFill>
+            <a:prstDash val="solid"/>
+          </a:ln>
+        </p:spPr>
+      </p:sp>
+      <p:sp>
+        <p:nvSpPr>
+          <p:cNvPr id="67" name="Shape 54"/>
+          <p:cNvSpPr/>
+          <p:nvPr/>
+        </p:nvSpPr>
+        <p:spPr>
+          <a:xfrm>
+            <a:off x="8275320" y="3493008"/>
+            <a:ext cx="1600200" cy="274320"/>
+          </a:xfrm>
+          <a:prstGeom prst="roundRect">
+            <a:avLst>
+              <a:gd name="adj" fmla="val 50000"/>
+            </a:avLst>
+          </a:prstGeom>
+          <a:solidFill>
+            <a:srgbClr val="F4C20D"/>
+          </a:solidFill>
+          <a:ln/>
+        </p:spPr>
+      </p:sp>
+      <p:sp>
+        <p:nvSpPr>
+          <p:cNvPr id="68" name="Text 55"/>
+          <p:cNvSpPr/>
+          <p:nvPr/>
+        </p:nvSpPr>
+        <p:spPr>
+          <a:xfrm>
+            <a:off x="8275320" y="3493008"/>
+            <a:ext cx="1600200" cy="274320"/>
+          </a:xfrm>
+          <a:prstGeom prst="rect">
+            <a:avLst/>
+          </a:prstGeom>
+          <a:noFill/>
+          <a:ln/>
+        </p:spPr>
+        <p:txBody>
+          <a:bodyPr wrap="square" lIns="0" tIns="0" rIns="0" bIns="0" rtlCol="0" anchor="ctr"/>
+          <a:lstStyle/>
+          <a:p>
+            <a:pPr algn="ctr" indent="0" marL="0">
+              <a:buNone/>
+            </a:pPr>
+            <a:r>
+              <a:rPr lang="en-US" sz="950" b="1" dirty="0">
+                <a:solidFill>
+                  <a:srgbClr val="33414F"/>
+                </a:solidFill>
+                <a:latin typeface="Calibri" pitchFamily="34" charset="0"/>
+                <a:ea typeface="Calibri" pitchFamily="34" charset="-122"/>
+                <a:cs typeface="Calibri" pitchFamily="34" charset="-120"/>
+              </a:rPr>
+              <a:t>Advanced Analytics</a:t>
+            </a:r>
+            <a:endParaRPr lang="en-US" sz="950" dirty="0"/>
+          </a:p>
+        </p:txBody>
+      </p:sp>
+      <p:sp>
+        <p:nvSpPr>
+          <p:cNvPr id="69" name="Shape 56"/>
+          <p:cNvSpPr/>
+          <p:nvPr/>
+        </p:nvSpPr>
+        <p:spPr>
+          <a:xfrm>
+            <a:off x="8046720" y="3950208"/>
+            <a:ext cx="420624" cy="420624"/>
+          </a:xfrm>
+          <a:prstGeom prst="ellipse">
+            <a:avLst/>
+          </a:prstGeom>
+          <a:solidFill>
+            <a:srgbClr val="9457D6"/>
+          </a:solidFill>
+          <a:ln/>
+        </p:spPr>
+      </p:sp>
+      <p:pic>
+        <p:nvPicPr>
+          <p:cNvPr id="70" name="Image 11" descr="preencoded.png">    </p:cNvPr>
+          <p:cNvPicPr>
+            <a:picLocks noChangeAspect="1"/>
+          </p:cNvPicPr>
+          <p:nvPr/>
+        </p:nvPicPr>
+        <p:blipFill>
+          <a:blip r:embed="rId12"/>
+          <a:stretch>
+            <a:fillRect/>
+          </a:stretch>
+        </p:blipFill>
+        <p:spPr>
+          <a:xfrm>
+            <a:off x="8147304" y="4050792"/>
+            <a:ext cx="219456" cy="219456"/>
+          </a:xfrm>
+          <a:prstGeom prst="rect">
+            <a:avLst/>
+          </a:prstGeom>
+        </p:spPr>
+      </p:pic>
+      <p:sp>
+        <p:nvSpPr>
+          <p:cNvPr id="71" name="Text 57"/>
+          <p:cNvSpPr/>
+          <p:nvPr/>
+        </p:nvSpPr>
+        <p:spPr>
+          <a:xfrm>
+            <a:off x="8577072" y="3913632"/>
+            <a:ext cx="1691640" cy="493776"/>
+          </a:xfrm>
+          <a:prstGeom prst="rect">
+            <a:avLst/>
+          </a:prstGeom>
+          <a:noFill/>
+          <a:ln/>
+        </p:spPr>
+        <p:txBody>
+          <a:bodyPr wrap="square" lIns="0" tIns="0" rIns="0" bIns="0" rtlCol="0" anchor="ctr"/>
+          <a:lstStyle/>
+          <a:p>
+            <a:pPr algn="l" indent="0" marL="0">
+              <a:lnSpc>
+                <a:spcPct val="88000"/>
+              </a:lnSpc>
+              <a:buNone/>
+            </a:pPr>
+            <a:r>
+              <a:rPr lang="en-US" sz="850" b="1" dirty="0">
+                <a:solidFill>
+                  <a:srgbClr val="3A4A5A"/>
+                </a:solidFill>
+                <a:latin typeface="Calibri" pitchFamily="34" charset="0"/>
+                <a:ea typeface="Calibri" pitchFamily="34" charset="-122"/>
+                <a:cs typeface="Calibri" pitchFamily="34" charset="-120"/>
+              </a:rPr>
+              <a:t>AI Powered</a:t>
+            </a:r>
+            <a:endParaRPr lang="en-US" sz="850" dirty="0"/>
+          </a:p>
+          <a:p>
+            <a:pPr algn="l" indent="0" marL="0">
+              <a:lnSpc>
+                <a:spcPct val="88000"/>
+              </a:lnSpc>
+              <a:buNone/>
+            </a:pPr>
+            <a:r>
+              <a:rPr lang="en-US" sz="850" b="1" dirty="0">
+                <a:solidFill>
+                  <a:srgbClr val="3A4A5A"/>
+                </a:solidFill>
+                <a:latin typeface="Calibri" pitchFamily="34" charset="0"/>
+                <a:ea typeface="Calibri" pitchFamily="34" charset="-122"/>
+                <a:cs typeface="Calibri" pitchFamily="34" charset="-120"/>
+              </a:rPr>
+              <a:t>Narrative Insights</a:t>
+            </a:r>
+            <a:endParaRPr lang="en-US" sz="850" dirty="0"/>
+          </a:p>
+        </p:txBody>
+      </p:sp>
+      <p:sp>
+        <p:nvSpPr>
+          <p:cNvPr id="72" name="Shape 58"/>
+          <p:cNvSpPr/>
+          <p:nvPr/>
+        </p:nvSpPr>
+        <p:spPr>
+          <a:xfrm>
+            <a:off x="8046720" y="4517136"/>
+            <a:ext cx="420624" cy="420624"/>
+          </a:xfrm>
+          <a:prstGeom prst="ellipse">
+            <a:avLst/>
+          </a:prstGeom>
+          <a:solidFill>
+            <a:srgbClr val="F4C20D"/>
+          </a:solidFill>
+          <a:ln/>
+        </p:spPr>
+      </p:sp>
+      <p:pic>
+        <p:nvPicPr>
+          <p:cNvPr id="73" name="Image 12" descr="preencoded.png">    </p:cNvPr>
+          <p:cNvPicPr>
+            <a:picLocks noChangeAspect="1"/>
+          </p:cNvPicPr>
+          <p:nvPr/>
+        </p:nvPicPr>
+        <p:blipFill>
+          <a:blip r:embed="rId13"/>
+          <a:stretch>
+            <a:fillRect/>
+          </a:stretch>
+        </p:blipFill>
+        <p:spPr>
+          <a:xfrm>
+            <a:off x="8147304" y="4617720"/>
+            <a:ext cx="219456" cy="219456"/>
+          </a:xfrm>
+          <a:prstGeom prst="rect">
+            <a:avLst/>
+          </a:prstGeom>
+        </p:spPr>
+      </p:pic>
+      <p:sp>
+        <p:nvSpPr>
+          <p:cNvPr id="74" name="Text 59"/>
+          <p:cNvSpPr/>
+          <p:nvPr/>
+        </p:nvSpPr>
+        <p:spPr>
+          <a:xfrm>
+            <a:off x="8577072" y="4480560"/>
+            <a:ext cx="1691640" cy="493776"/>
+          </a:xfrm>
+          <a:prstGeom prst="rect">
+            <a:avLst/>
+          </a:prstGeom>
+          <a:noFill/>
+          <a:ln/>
+        </p:spPr>
+        <p:txBody>
+          <a:bodyPr wrap="square" lIns="0" tIns="0" rIns="0" bIns="0" rtlCol="0" anchor="ctr"/>
+          <a:lstStyle/>
+          <a:p>
+            <a:pPr algn="l" indent="0" marL="0">
+              <a:lnSpc>
+                <a:spcPct val="88000"/>
+              </a:lnSpc>
+              <a:buNone/>
+            </a:pPr>
+            <a:r>
+              <a:rPr lang="en-US" sz="850" b="1" dirty="0">
+                <a:solidFill>
+                  <a:srgbClr val="3A4A5A"/>
+                </a:solidFill>
+                <a:latin typeface="Calibri" pitchFamily="34" charset="0"/>
+                <a:ea typeface="Calibri" pitchFamily="34" charset="-122"/>
+                <a:cs typeface="Calibri" pitchFamily="34" charset="-120"/>
+              </a:rPr>
+              <a:t>AI based</a:t>
+            </a:r>
+            <a:endParaRPr lang="en-US" sz="850" dirty="0"/>
+          </a:p>
+          <a:p>
+            <a:pPr algn="l" indent="0" marL="0">
+              <a:lnSpc>
+                <a:spcPct val="88000"/>
+              </a:lnSpc>
+              <a:buNone/>
+            </a:pPr>
+            <a:r>
+              <a:rPr lang="en-US" sz="850" b="1" dirty="0">
+                <a:solidFill>
+                  <a:srgbClr val="3A4A5A"/>
+                </a:solidFill>
+                <a:latin typeface="Calibri" pitchFamily="34" charset="0"/>
+                <a:ea typeface="Calibri" pitchFamily="34" charset="-122"/>
+                <a:cs typeface="Calibri" pitchFamily="34" charset="-120"/>
+              </a:rPr>
+              <a:t>Conversational Analytics</a:t>
+            </a:r>
+            <a:endParaRPr lang="en-US" sz="850" dirty="0"/>
+          </a:p>
+        </p:txBody>
+      </p:sp>
+      <p:sp>
+        <p:nvSpPr>
+          <p:cNvPr id="75" name="Shape 60"/>
+          <p:cNvSpPr/>
+          <p:nvPr/>
+        </p:nvSpPr>
+        <p:spPr>
+          <a:xfrm>
+            <a:off x="8046720" y="5084064"/>
+            <a:ext cx="420624" cy="420624"/>
+          </a:xfrm>
+          <a:prstGeom prst="ellipse">
+            <a:avLst/>
+          </a:prstGeom>
+          <a:solidFill>
+            <a:srgbClr val="5B9BD5"/>
+          </a:solidFill>
+          <a:ln/>
+        </p:spPr>
+      </p:sp>
+      <p:pic>
+        <p:nvPicPr>
+          <p:cNvPr id="76" name="Image 13" descr="preencoded.png">    </p:cNvPr>
+          <p:cNvPicPr>
+            <a:picLocks noChangeAspect="1"/>
+          </p:cNvPicPr>
+          <p:nvPr/>
+        </p:nvPicPr>
+        <p:blipFill>
+          <a:blip r:embed="rId14"/>
+          <a:stretch>
+            <a:fillRect/>
+          </a:stretch>
+        </p:blipFill>
+        <p:spPr>
+          <a:xfrm>
+            <a:off x="8147304" y="5184648"/>
+            <a:ext cx="219456" cy="219456"/>
+          </a:xfrm>
+          <a:prstGeom prst="rect">
+            <a:avLst/>
+          </a:prstGeom>
+        </p:spPr>
+      </p:pic>
+      <p:sp>
+        <p:nvSpPr>
+          <p:cNvPr id="77" name="Text 61"/>
+          <p:cNvSpPr/>
+          <p:nvPr/>
+        </p:nvSpPr>
+        <p:spPr>
+          <a:xfrm>
+            <a:off x="8577072" y="5047488"/>
+            <a:ext cx="1691640" cy="493776"/>
+          </a:xfrm>
+          <a:prstGeom prst="rect">
+            <a:avLst/>
+          </a:prstGeom>
+          <a:noFill/>
+          <a:ln/>
+        </p:spPr>
+        <p:txBody>
+          <a:bodyPr wrap="square" lIns="0" tIns="0" rIns="0" bIns="0" rtlCol="0" anchor="ctr"/>
+          <a:lstStyle/>
+          <a:p>
+            <a:pPr algn="l" indent="0" marL="0">
+              <a:lnSpc>
+                <a:spcPct val="88000"/>
+              </a:lnSpc>
+              <a:buNone/>
+            </a:pPr>
+            <a:r>
+              <a:rPr lang="en-US" sz="850" b="1" dirty="0">
+                <a:solidFill>
+                  <a:srgbClr val="3A4A5A"/>
+                </a:solidFill>
+                <a:latin typeface="Calibri" pitchFamily="34" charset="0"/>
+                <a:ea typeface="Calibri" pitchFamily="34" charset="-122"/>
+                <a:cs typeface="Calibri" pitchFamily="34" charset="-120"/>
+              </a:rPr>
+              <a:t>Data Science Driven</a:t>
+            </a:r>
+            <a:endParaRPr lang="en-US" sz="850" dirty="0"/>
+          </a:p>
+          <a:p>
+            <a:pPr algn="l" indent="0" marL="0">
+              <a:lnSpc>
+                <a:spcPct val="88000"/>
+              </a:lnSpc>
+              <a:buNone/>
+            </a:pPr>
+            <a:r>
+              <a:rPr lang="en-US" sz="850" b="1" dirty="0">
+                <a:solidFill>
+                  <a:srgbClr val="3A4A5A"/>
+                </a:solidFill>
+                <a:latin typeface="Calibri" pitchFamily="34" charset="0"/>
+                <a:ea typeface="Calibri" pitchFamily="34" charset="-122"/>
+                <a:cs typeface="Calibri" pitchFamily="34" charset="-120"/>
+              </a:rPr>
+              <a:t>Advanced Analytics</a:t>
+            </a:r>
+            <a:endParaRPr lang="en-US" sz="850" dirty="0"/>
+          </a:p>
+        </p:txBody>
+      </p:sp>
+      <p:sp>
+        <p:nvSpPr>
+          <p:cNvPr id="78" name="Shape 62"/>
+          <p:cNvSpPr/>
+          <p:nvPr/>
+        </p:nvSpPr>
+        <p:spPr>
+          <a:xfrm>
+            <a:off x="10479024" y="1828800"/>
+            <a:ext cx="237744" cy="3657600"/>
+          </a:xfrm>
+          <a:prstGeom prst="rect">
+            <a:avLst/>
+          </a:prstGeom>
+          <a:solidFill>
+            <a:srgbClr val="F4C20D"/>
+          </a:solidFill>
+          <a:ln/>
+        </p:spPr>
+      </p:sp>
+      <p:sp>
+        <p:nvSpPr>
+          <p:cNvPr id="79" name="Text 63"/>
+          <p:cNvSpPr/>
+          <p:nvPr/>
+        </p:nvSpPr>
+        <p:spPr>
+          <a:xfrm rot="16200000">
+            <a:off x="8769096" y="3538728"/>
+            <a:ext cx="3657600" cy="237744"/>
+          </a:xfrm>
+          <a:prstGeom prst="rect">
+            <a:avLst/>
+          </a:prstGeom>
+          <a:noFill/>
+          <a:ln/>
+        </p:spPr>
+        <p:txBody>
+          <a:bodyPr wrap="square" lIns="0" tIns="0" rIns="0" bIns="0" rtlCol="0" anchor="ctr"/>
+          <a:lstStyle/>
+          <a:p>
+            <a:pPr algn="ctr" indent="0" marL="0">
+              <a:buNone/>
+            </a:pPr>
+            <a:r>
+              <a:rPr lang="en-US" sz="900" b="1" dirty="0">
+                <a:solidFill>
+                  <a:srgbClr val="33414F"/>
+                </a:solidFill>
+                <a:latin typeface="Calibri" pitchFamily="34" charset="0"/>
+                <a:ea typeface="Calibri" pitchFamily="34" charset="-122"/>
+                <a:cs typeface="Calibri" pitchFamily="34" charset="-120"/>
+              </a:rPr>
+              <a:t>Access Layer</a:t>
+            </a:r>
+            <a:endParaRPr lang="en-US" sz="900" dirty="0"/>
+          </a:p>
+        </p:txBody>
+      </p:sp>
+      <p:sp>
+        <p:nvSpPr>
+          <p:cNvPr id="80" name="Text 64"/>
+          <p:cNvSpPr/>
+          <p:nvPr/>
+        </p:nvSpPr>
+        <p:spPr>
+          <a:xfrm>
+            <a:off x="256032" y="1042416"/>
+            <a:ext cx="1097280" cy="237744"/>
+          </a:xfrm>
+          <a:prstGeom prst="rect">
+            <a:avLst/>
+          </a:prstGeom>
+          <a:noFill/>
+          <a:ln/>
+        </p:spPr>
+        <p:txBody>
+          <a:bodyPr wrap="square" lIns="0" tIns="0" rIns="0" bIns="0" rtlCol="0" anchor="ctr"/>
+          <a:lstStyle/>
+          <a:p>
+            <a:pPr algn="l" indent="0" marL="0">
+              <a:buNone/>
+            </a:pPr>
+            <a:r>
+              <a:rPr lang="en-US" sz="1100" b="1" dirty="0">
+                <a:solidFill>
+                  <a:srgbClr val="3A4A5A"/>
+                </a:solidFill>
+                <a:latin typeface="Calibri" pitchFamily="34" charset="0"/>
+                <a:ea typeface="Calibri" pitchFamily="34" charset="-122"/>
+                <a:cs typeface="Calibri" pitchFamily="34" charset="-120"/>
+              </a:rPr>
+              <a:t>Data Sources</a:t>
+            </a:r>
+            <a:endParaRPr lang="en-US" sz="1100" dirty="0"/>
+          </a:p>
+        </p:txBody>
+      </p:sp>
+      <p:sp>
+        <p:nvSpPr>
+          <p:cNvPr id="81" name="Shape 65"/>
+          <p:cNvSpPr/>
+          <p:nvPr/>
+        </p:nvSpPr>
+        <p:spPr>
+          <a:xfrm>
+            <a:off x="274320" y="1298448"/>
+            <a:ext cx="1024128" cy="3429000"/>
+          </a:xfrm>
+          <a:prstGeom prst="roundRect">
+            <a:avLst>
+              <a:gd name="adj" fmla="val 4464"/>
+            </a:avLst>
+          </a:prstGeom>
+          <a:solidFill>
+            <a:srgbClr val="FFFFFF"/>
+          </a:solidFill>
+          <a:ln w="15875">
+            <a:solidFill>
+              <a:srgbClr val="5B9BD5"/>
+            </a:solidFill>
+            <a:prstDash val="solid"/>
+          </a:ln>
+        </p:spPr>
+      </p:sp>
+      <p:sp>
+        <p:nvSpPr>
+          <p:cNvPr id="82" name="Shape 66"/>
+          <p:cNvSpPr/>
+          <p:nvPr/>
+        </p:nvSpPr>
+        <p:spPr>
+          <a:xfrm>
+            <a:off x="384048" y="1517904"/>
+            <a:ext cx="804672" cy="2377440"/>
+          </a:xfrm>
+          <a:prstGeom prst="roundRect">
+            <a:avLst>
+              <a:gd name="adj" fmla="val 5682"/>
+            </a:avLst>
+          </a:prstGeom>
+          <a:solidFill>
+            <a:srgbClr val="FFFFFF"/>
+          </a:solidFill>
+          <a:ln w="12700">
+            <a:solidFill>
+              <a:srgbClr val="5B9BD5"/>
+            </a:solidFill>
+            <a:prstDash val="solid"/>
+          </a:ln>
+        </p:spPr>
+      </p:sp>
+      <p:sp>
+        <p:nvSpPr>
+          <p:cNvPr id="83" name="Text 67"/>
+          <p:cNvSpPr/>
+          <p:nvPr/>
+        </p:nvSpPr>
+        <p:spPr>
+          <a:xfrm>
+            <a:off x="384048" y="1572768"/>
+            <a:ext cx="804672" cy="219456"/>
+          </a:xfrm>
+          <a:prstGeom prst="rect">
+            <a:avLst/>
+          </a:prstGeom>
+          <a:noFill/>
+          <a:ln/>
+        </p:spPr>
+        <p:txBody>
+          <a:bodyPr wrap="square" lIns="0" tIns="0" rIns="0" bIns="0" rtlCol="0" anchor="ctr"/>
+          <a:lstStyle/>
+          <a:p>
+            <a:pPr algn="ctr" indent="0" marL="0">
+              <a:buNone/>
+            </a:pPr>
+            <a:r>
+              <a:rPr lang="en-US" sz="900" b="1" dirty="0">
+                <a:solidFill>
+                  <a:srgbClr val="5B9BD5"/>
+                </a:solidFill>
+                <a:latin typeface="Calibri" pitchFamily="34" charset="0"/>
+                <a:ea typeface="Calibri" pitchFamily="34" charset="-122"/>
+                <a:cs typeface="Calibri" pitchFamily="34" charset="-120"/>
+              </a:rPr>
+              <a:t>SFTP</a:t>
+            </a:r>
+            <a:endParaRPr lang="en-US" sz="900" dirty="0"/>
+          </a:p>
+        </p:txBody>
+      </p:sp>
+      <p:sp>
+        <p:nvSpPr>
+          <p:cNvPr id="84" name="Shape 68"/>
+          <p:cNvSpPr/>
+          <p:nvPr/>
+        </p:nvSpPr>
+        <p:spPr>
+          <a:xfrm>
+            <a:off x="576072" y="1828800"/>
+            <a:ext cx="420624" cy="420624"/>
+          </a:xfrm>
+          <a:prstGeom prst="ellipse">
+            <a:avLst/>
+          </a:prstGeom>
+          <a:solidFill>
+            <a:srgbClr val="5B9BD5"/>
+          </a:solidFill>
+          <a:ln/>
+        </p:spPr>
+      </p:sp>
+      <p:pic>
+        <p:nvPicPr>
+          <p:cNvPr id="85" name="Image 14" descr="preencoded.png">    </p:cNvPr>
+          <p:cNvPicPr>
+            <a:picLocks noChangeAspect="1"/>
+          </p:cNvPicPr>
+          <p:nvPr/>
+        </p:nvPicPr>
+        <p:blipFill>
+          <a:blip r:embed="rId15"/>
+          <a:stretch>
+            <a:fillRect/>
+          </a:stretch>
+        </p:blipFill>
+        <p:spPr>
+          <a:xfrm>
+            <a:off x="681228" y="1933956"/>
+            <a:ext cx="210312" cy="210312"/>
+          </a:xfrm>
+          <a:prstGeom prst="rect">
+            <a:avLst/>
+          </a:prstGeom>
+        </p:spPr>
+      </p:pic>
+      <p:sp>
+        <p:nvSpPr>
+          <p:cNvPr id="86" name="Text 69"/>
+          <p:cNvSpPr/>
+          <p:nvPr/>
+        </p:nvSpPr>
+        <p:spPr>
+          <a:xfrm>
+            <a:off x="393192" y="2276856"/>
+            <a:ext cx="786384" cy="329184"/>
+          </a:xfrm>
+          <a:prstGeom prst="rect">
+            <a:avLst/>
+          </a:prstGeom>
+          <a:noFill/>
+          <a:ln/>
+        </p:spPr>
+        <p:txBody>
+          <a:bodyPr wrap="square" lIns="0" tIns="0" rIns="0" bIns="0" rtlCol="0" anchor="t"/>
+          <a:lstStyle/>
+          <a:p>
+            <a:pPr algn="ctr" indent="0" marL="0">
+              <a:lnSpc>
+                <a:spcPct val="90000"/>
+              </a:lnSpc>
+              <a:buNone/>
+            </a:pPr>
+            <a:r>
+              <a:rPr lang="en-US" sz="750" b="1" dirty="0">
+                <a:solidFill>
+                  <a:srgbClr val="3A4A5A"/>
+                </a:solidFill>
+                <a:latin typeface="Calibri" pitchFamily="34" charset="0"/>
+                <a:ea typeface="Calibri" pitchFamily="34" charset="-122"/>
+                <a:cs typeface="Calibri" pitchFamily="34" charset="-120"/>
+              </a:rPr>
+              <a:t>Excel</a:t>
+            </a:r>
+            <a:endParaRPr lang="en-US" sz="750" dirty="0"/>
+          </a:p>
+        </p:txBody>
+      </p:sp>
+      <p:sp>
+        <p:nvSpPr>
+          <p:cNvPr id="87" name="Shape 70"/>
+          <p:cNvSpPr/>
+          <p:nvPr/>
+        </p:nvSpPr>
+        <p:spPr>
+          <a:xfrm>
+            <a:off x="576072" y="2505456"/>
+            <a:ext cx="420624" cy="420624"/>
+          </a:xfrm>
+          <a:prstGeom prst="ellipse">
+            <a:avLst/>
+          </a:prstGeom>
+          <a:solidFill>
+            <a:srgbClr val="5B9BD5"/>
+          </a:solidFill>
+          <a:ln/>
+        </p:spPr>
+      </p:sp>
+      <p:pic>
+        <p:nvPicPr>
+          <p:cNvPr id="88" name="Image 15" descr="preencoded.png">    </p:cNvPr>
+          <p:cNvPicPr>
+            <a:picLocks noChangeAspect="1"/>
+          </p:cNvPicPr>
+          <p:nvPr/>
+        </p:nvPicPr>
+        <p:blipFill>
+          <a:blip r:embed="rId16"/>
+          <a:stretch>
+            <a:fillRect/>
+          </a:stretch>
+        </p:blipFill>
+        <p:spPr>
+          <a:xfrm>
+            <a:off x="681228" y="2610612"/>
+            <a:ext cx="210312" cy="210312"/>
+          </a:xfrm>
+          <a:prstGeom prst="rect">
+            <a:avLst/>
+          </a:prstGeom>
+        </p:spPr>
+      </p:pic>
+      <p:sp>
+        <p:nvSpPr>
+          <p:cNvPr id="89" name="Text 71"/>
+          <p:cNvSpPr/>
+          <p:nvPr/>
+        </p:nvSpPr>
+        <p:spPr>
+          <a:xfrm>
+            <a:off x="393192" y="2953512"/>
+            <a:ext cx="786384" cy="329184"/>
+          </a:xfrm>
+          <a:prstGeom prst="rect">
+            <a:avLst/>
+          </a:prstGeom>
+          <a:noFill/>
+          <a:ln/>
+        </p:spPr>
+        <p:txBody>
+          <a:bodyPr wrap="square" lIns="0" tIns="0" rIns="0" bIns="0" rtlCol="0" anchor="t"/>
+          <a:lstStyle/>
+          <a:p>
+            <a:pPr algn="ctr" indent="0" marL="0">
+              <a:lnSpc>
+                <a:spcPct val="90000"/>
+              </a:lnSpc>
+              <a:buNone/>
+            </a:pPr>
+            <a:r>
+              <a:rPr lang="en-US" sz="750" b="1" dirty="0">
+                <a:solidFill>
+                  <a:srgbClr val="3A4A5A"/>
+                </a:solidFill>
+                <a:latin typeface="Calibri" pitchFamily="34" charset="0"/>
+                <a:ea typeface="Calibri" pitchFamily="34" charset="-122"/>
+                <a:cs typeface="Calibri" pitchFamily="34" charset="-120"/>
+              </a:rPr>
+              <a:t>CSV</a:t>
+            </a:r>
+            <a:endParaRPr lang="en-US" sz="750" dirty="0"/>
+          </a:p>
+        </p:txBody>
+      </p:sp>
+      <p:sp>
+        <p:nvSpPr>
+          <p:cNvPr id="90" name="Shape 72"/>
+          <p:cNvSpPr/>
+          <p:nvPr/>
+        </p:nvSpPr>
+        <p:spPr>
+          <a:xfrm>
+            <a:off x="576072" y="3182112"/>
+            <a:ext cx="420624" cy="420624"/>
+          </a:xfrm>
+          <a:prstGeom prst="ellipse">
+            <a:avLst/>
+          </a:prstGeom>
+          <a:solidFill>
+            <a:srgbClr val="5B9BD5"/>
+          </a:solidFill>
+          <a:ln/>
+        </p:spPr>
+      </p:sp>
+      <p:pic>
+        <p:nvPicPr>
+          <p:cNvPr id="91" name="Image 16" descr="preencoded.png">    </p:cNvPr>
+          <p:cNvPicPr>
+            <a:picLocks noChangeAspect="1"/>
+          </p:cNvPicPr>
+          <p:nvPr/>
+        </p:nvPicPr>
+        <p:blipFill>
+          <a:blip r:embed="rId17"/>
+          <a:stretch>
+            <a:fillRect/>
+          </a:stretch>
+        </p:blipFill>
+        <p:spPr>
+          <a:xfrm>
+            <a:off x="681228" y="3287268"/>
+            <a:ext cx="210312" cy="210312"/>
+          </a:xfrm>
+          <a:prstGeom prst="rect">
+            <a:avLst/>
+          </a:prstGeom>
+        </p:spPr>
+      </p:pic>
+      <p:sp>
+        <p:nvSpPr>
+          <p:cNvPr id="92" name="Text 73"/>
+          <p:cNvSpPr/>
+          <p:nvPr/>
+        </p:nvSpPr>
+        <p:spPr>
+          <a:xfrm>
+            <a:off x="393192" y="3630168"/>
+            <a:ext cx="786384" cy="329184"/>
+          </a:xfrm>
+          <a:prstGeom prst="rect">
+            <a:avLst/>
+          </a:prstGeom>
+          <a:noFill/>
+          <a:ln/>
+        </p:spPr>
+        <p:txBody>
+          <a:bodyPr wrap="square" lIns="0" tIns="0" rIns="0" bIns="0" rtlCol="0" anchor="t"/>
+          <a:lstStyle/>
+          <a:p>
+            <a:pPr algn="ctr" indent="0" marL="0">
+              <a:lnSpc>
+                <a:spcPct val="90000"/>
+              </a:lnSpc>
+              <a:buNone/>
+            </a:pPr>
+            <a:r>
+              <a:rPr lang="en-US" sz="750" b="1" dirty="0">
+                <a:solidFill>
+                  <a:srgbClr val="3A4A5A"/>
+                </a:solidFill>
+                <a:latin typeface="Calibri" pitchFamily="34" charset="0"/>
+                <a:ea typeface="Calibri" pitchFamily="34" charset="-122"/>
+                <a:cs typeface="Calibri" pitchFamily="34" charset="-120"/>
+              </a:rPr>
+              <a:t>Text Files</a:t>
+            </a:r>
+            <a:endParaRPr lang="en-US" sz="750" dirty="0"/>
+          </a:p>
+        </p:txBody>
+      </p:sp>
+      <p:sp>
+        <p:nvSpPr>
+          <p:cNvPr id="93" name="Shape 74"/>
+          <p:cNvSpPr/>
+          <p:nvPr/>
+        </p:nvSpPr>
+        <p:spPr>
+          <a:xfrm>
+            <a:off x="557784" y="3986784"/>
+            <a:ext cx="457200" cy="457200"/>
+          </a:xfrm>
+          <a:prstGeom prst="ellipse">
+            <a:avLst/>
+          </a:prstGeom>
+          <a:solidFill>
+            <a:srgbClr val="5B9BD5"/>
+          </a:solidFill>
+          <a:ln/>
+        </p:spPr>
+      </p:sp>
+      <p:pic>
+        <p:nvPicPr>
+          <p:cNvPr id="94" name="Image 17" descr="preencoded.png">    </p:cNvPr>
+          <p:cNvPicPr>
+            <a:picLocks noChangeAspect="1"/>
+          </p:cNvPicPr>
+          <p:nvPr/>
+        </p:nvPicPr>
+        <p:blipFill>
+          <a:blip r:embed="rId18"/>
+          <a:stretch>
+            <a:fillRect/>
+          </a:stretch>
+        </p:blipFill>
+        <p:spPr>
+          <a:xfrm>
+            <a:off x="672084" y="4101084"/>
+            <a:ext cx="228600" cy="228600"/>
+          </a:xfrm>
+          <a:prstGeom prst="rect">
+            <a:avLst/>
+          </a:prstGeom>
+        </p:spPr>
+      </p:pic>
+      <p:sp>
+        <p:nvSpPr>
+          <p:cNvPr id="95" name="Text 75"/>
+          <p:cNvSpPr/>
+          <p:nvPr/>
+        </p:nvSpPr>
+        <p:spPr>
+          <a:xfrm>
+            <a:off x="329184" y="4471416"/>
+            <a:ext cx="914400" cy="329184"/>
+          </a:xfrm>
+          <a:prstGeom prst="rect">
+            <a:avLst/>
+          </a:prstGeom>
+          <a:noFill/>
+          <a:ln/>
+        </p:spPr>
+        <p:txBody>
+          <a:bodyPr wrap="square" lIns="0" tIns="0" rIns="0" bIns="0" rtlCol="0" anchor="t"/>
+          <a:lstStyle/>
+          <a:p>
+            <a:pPr algn="ctr" indent="0" marL="0">
+              <a:lnSpc>
+                <a:spcPct val="90000"/>
+              </a:lnSpc>
+              <a:buNone/>
+            </a:pPr>
+            <a:r>
+              <a:rPr lang="en-US" sz="850" b="1" dirty="0">
+                <a:solidFill>
+                  <a:srgbClr val="3A4A5A"/>
+                </a:solidFill>
+                <a:latin typeface="Calibri" pitchFamily="34" charset="0"/>
+                <a:ea typeface="Calibri" pitchFamily="34" charset="-122"/>
+                <a:cs typeface="Calibri" pitchFamily="34" charset="-120"/>
+              </a:rPr>
+              <a:t>Database</a:t>
+            </a:r>
+            <a:endParaRPr lang="en-US" sz="850" dirty="0"/>
+          </a:p>
+        </p:txBody>
+      </p:sp>
+      <p:sp>
+        <p:nvSpPr>
+          <p:cNvPr id="96" name="Text 76"/>
+          <p:cNvSpPr/>
+          <p:nvPr/>
+        </p:nvSpPr>
+        <p:spPr>
+          <a:xfrm>
+            <a:off x="10844784" y="1481328"/>
+            <a:ext cx="1042416" cy="365760"/>
+          </a:xfrm>
+          <a:prstGeom prst="rect">
+            <a:avLst/>
+          </a:prstGeom>
+          <a:noFill/>
+          <a:ln/>
+        </p:spPr>
+        <p:txBody>
+          <a:bodyPr wrap="square" lIns="0" tIns="0" rIns="0" bIns="0" rtlCol="0" anchor="t"/>
+          <a:lstStyle/>
+          <a:p>
+            <a:pPr algn="ctr" indent="0" marL="0">
+              <a:lnSpc>
+                <a:spcPct val="90000"/>
+              </a:lnSpc>
+              <a:buNone/>
+            </a:pPr>
+            <a:r>
+              <a:rPr lang="en-US" sz="850" b="1" dirty="0">
+                <a:solidFill>
+                  <a:srgbClr val="F2647A"/>
+                </a:solidFill>
+                <a:latin typeface="Calibri" pitchFamily="34" charset="0"/>
+                <a:ea typeface="Calibri" pitchFamily="34" charset="-122"/>
+                <a:cs typeface="Calibri" pitchFamily="34" charset="-120"/>
+              </a:rPr>
+              <a:t>Data Consumption</a:t>
+            </a:r>
+            <a:endParaRPr lang="en-US" sz="850" dirty="0"/>
+          </a:p>
+        </p:txBody>
+      </p:sp>
+      <p:sp>
+        <p:nvSpPr>
+          <p:cNvPr id="97" name="Shape 77"/>
+          <p:cNvSpPr/>
+          <p:nvPr/>
+        </p:nvSpPr>
+        <p:spPr>
+          <a:xfrm>
+            <a:off x="10844784" y="1371600"/>
+            <a:ext cx="1042416" cy="3383280"/>
+          </a:xfrm>
+          <a:prstGeom prst="roundRect">
+            <a:avLst>
+              <a:gd name="adj" fmla="val 4386"/>
+            </a:avLst>
+          </a:prstGeom>
+          <a:solidFill>
+            <a:srgbClr val="FFFFFF"/>
+          </a:solidFill>
+          <a:ln w="15875">
+            <a:solidFill>
+              <a:srgbClr val="F2647A"/>
+            </a:solidFill>
+            <a:prstDash val="solid"/>
+          </a:ln>
+        </p:spPr>
+      </p:sp>
+      <p:sp>
+        <p:nvSpPr>
+          <p:cNvPr id="98" name="Text 78"/>
+          <p:cNvSpPr/>
+          <p:nvPr/>
+        </p:nvSpPr>
+        <p:spPr>
+          <a:xfrm>
+            <a:off x="10881360" y="1499616"/>
+            <a:ext cx="969264" cy="365760"/>
+          </a:xfrm>
+          <a:prstGeom prst="rect">
+            <a:avLst/>
+          </a:prstGeom>
+          <a:noFill/>
+          <a:ln/>
+        </p:spPr>
+        <p:txBody>
+          <a:bodyPr wrap="square" lIns="0" tIns="0" rIns="0" bIns="0" rtlCol="0" anchor="t"/>
+          <a:lstStyle/>
+          <a:p>
+            <a:pPr algn="ctr" indent="0" marL="0">
+              <a:lnSpc>
+                <a:spcPct val="90000"/>
+              </a:lnSpc>
+              <a:buNone/>
+            </a:pPr>
+            <a:r>
+              <a:rPr lang="en-US" sz="850" b="1" dirty="0">
+                <a:solidFill>
+                  <a:srgbClr val="F2647A"/>
+                </a:solidFill>
+                <a:latin typeface="Calibri" pitchFamily="34" charset="0"/>
+                <a:ea typeface="Calibri" pitchFamily="34" charset="-122"/>
+                <a:cs typeface="Calibri" pitchFamily="34" charset="-120"/>
+              </a:rPr>
+              <a:t>Data Consumption</a:t>
+            </a:r>
+            <a:endParaRPr lang="en-US" sz="850" dirty="0"/>
+          </a:p>
+        </p:txBody>
+      </p:sp>
+      <p:sp>
+        <p:nvSpPr>
+          <p:cNvPr id="99" name="Shape 79"/>
+          <p:cNvSpPr/>
+          <p:nvPr/>
+        </p:nvSpPr>
+        <p:spPr>
+          <a:xfrm>
+            <a:off x="11137392" y="2011680"/>
+            <a:ext cx="457200" cy="457200"/>
+          </a:xfrm>
+          <a:prstGeom prst="ellipse">
+            <a:avLst/>
+          </a:prstGeom>
+          <a:solidFill>
+            <a:srgbClr val="F2647A"/>
+          </a:solidFill>
+          <a:ln/>
+        </p:spPr>
+      </p:sp>
+      <p:pic>
+        <p:nvPicPr>
+          <p:cNvPr id="100" name="Image 18" descr="preencoded.png">    </p:cNvPr>
+          <p:cNvPicPr>
+            <a:picLocks noChangeAspect="1"/>
+          </p:cNvPicPr>
+          <p:nvPr/>
+        </p:nvPicPr>
+        <p:blipFill>
+          <a:blip r:embed="rId19"/>
+          <a:stretch>
+            <a:fillRect/>
+          </a:stretch>
+        </p:blipFill>
+        <p:spPr>
+          <a:xfrm>
+            <a:off x="11251692" y="2125980"/>
+            <a:ext cx="228600" cy="228600"/>
+          </a:xfrm>
+          <a:prstGeom prst="rect">
+            <a:avLst/>
+          </a:prstGeom>
+        </p:spPr>
+      </p:pic>
+      <p:sp>
+        <p:nvSpPr>
+          <p:cNvPr id="101" name="Text 80"/>
+          <p:cNvSpPr/>
+          <p:nvPr/>
+        </p:nvSpPr>
+        <p:spPr>
+          <a:xfrm>
+            <a:off x="10908792" y="2496312"/>
+            <a:ext cx="914400" cy="329184"/>
+          </a:xfrm>
+          <a:prstGeom prst="rect">
+            <a:avLst/>
+          </a:prstGeom>
+          <a:noFill/>
+          <a:ln/>
+        </p:spPr>
+        <p:txBody>
+          <a:bodyPr wrap="square" lIns="0" tIns="0" rIns="0" bIns="0" rtlCol="0" anchor="t"/>
+          <a:lstStyle/>
+          <a:p>
+            <a:pPr algn="ctr" indent="0" marL="0">
+              <a:lnSpc>
+                <a:spcPct val="90000"/>
+              </a:lnSpc>
+              <a:buNone/>
+            </a:pPr>
+            <a:r>
+              <a:rPr lang="en-US" sz="800" b="1" dirty="0">
+                <a:solidFill>
+                  <a:srgbClr val="3A4A5A"/>
+                </a:solidFill>
+                <a:latin typeface="Calibri" pitchFamily="34" charset="0"/>
+                <a:ea typeface="Calibri" pitchFamily="34" charset="-122"/>
+                <a:cs typeface="Calibri" pitchFamily="34" charset="-120"/>
+              </a:rPr>
+              <a:t>PC</a:t>
+            </a:r>
+            <a:endParaRPr lang="en-US" sz="800" dirty="0"/>
+          </a:p>
+        </p:txBody>
+      </p:sp>
+      <p:sp>
+        <p:nvSpPr>
+          <p:cNvPr id="102" name="Shape 81"/>
+          <p:cNvSpPr/>
+          <p:nvPr/>
+        </p:nvSpPr>
+        <p:spPr>
+          <a:xfrm>
+            <a:off x="11137392" y="2779776"/>
+            <a:ext cx="457200" cy="457200"/>
+          </a:xfrm>
+          <a:prstGeom prst="ellipse">
+            <a:avLst/>
+          </a:prstGeom>
+          <a:solidFill>
+            <a:srgbClr val="F2647A"/>
+          </a:solidFill>
+          <a:ln/>
+        </p:spPr>
+      </p:sp>
+      <p:pic>
+        <p:nvPicPr>
+          <p:cNvPr id="103" name="Image 19" descr="preencoded.png">    </p:cNvPr>
+          <p:cNvPicPr>
+            <a:picLocks noChangeAspect="1"/>
+          </p:cNvPicPr>
+          <p:nvPr/>
+        </p:nvPicPr>
+        <p:blipFill>
+          <a:blip r:embed="rId20"/>
+          <a:stretch>
+            <a:fillRect/>
+          </a:stretch>
+        </p:blipFill>
+        <p:spPr>
+          <a:xfrm>
+            <a:off x="11251692" y="2894076"/>
+            <a:ext cx="228600" cy="228600"/>
+          </a:xfrm>
+          <a:prstGeom prst="rect">
+            <a:avLst/>
+          </a:prstGeom>
+        </p:spPr>
+      </p:pic>
+      <p:sp>
+        <p:nvSpPr>
+          <p:cNvPr id="104" name="Text 82"/>
+          <p:cNvSpPr/>
+          <p:nvPr/>
+        </p:nvSpPr>
+        <p:spPr>
+          <a:xfrm>
+            <a:off x="10885932" y="3264408"/>
+            <a:ext cx="960120" cy="329184"/>
+          </a:xfrm>
+          <a:prstGeom prst="rect">
+            <a:avLst/>
+          </a:prstGeom>
+          <a:noFill/>
+          <a:ln/>
+        </p:spPr>
+        <p:txBody>
+          <a:bodyPr wrap="square" lIns="0" tIns="0" rIns="0" bIns="0" rtlCol="0" anchor="t"/>
+          <a:lstStyle/>
+          <a:p>
+            <a:pPr algn="ctr" indent="0" marL="0">
+              <a:lnSpc>
+                <a:spcPct val="90000"/>
+              </a:lnSpc>
+              <a:buNone/>
+            </a:pPr>
+            <a:r>
+              <a:rPr lang="en-US" sz="800" b="1" dirty="0">
+                <a:solidFill>
+                  <a:srgbClr val="3A4A5A"/>
+                </a:solidFill>
+                <a:latin typeface="Calibri" pitchFamily="34" charset="0"/>
+                <a:ea typeface="Calibri" pitchFamily="34" charset="-122"/>
+                <a:cs typeface="Calibri" pitchFamily="34" charset="-120"/>
+              </a:rPr>
+              <a:t>Smart Phone</a:t>
+            </a:r>
+            <a:endParaRPr lang="en-US" sz="800" dirty="0"/>
+          </a:p>
+        </p:txBody>
+      </p:sp>
+      <p:sp>
+        <p:nvSpPr>
+          <p:cNvPr id="105" name="Shape 83"/>
+          <p:cNvSpPr/>
+          <p:nvPr/>
+        </p:nvSpPr>
+        <p:spPr>
+          <a:xfrm>
+            <a:off x="11137392" y="3584448"/>
+            <a:ext cx="457200" cy="457200"/>
+          </a:xfrm>
+          <a:prstGeom prst="ellipse">
+            <a:avLst/>
+          </a:prstGeom>
+          <a:solidFill>
+            <a:srgbClr val="F2647A"/>
+          </a:solidFill>
+          <a:ln/>
+        </p:spPr>
+      </p:sp>
+      <p:pic>
+        <p:nvPicPr>
+          <p:cNvPr id="106" name="Image 20" descr="preencoded.png">    </p:cNvPr>
+          <p:cNvPicPr>
+            <a:picLocks noChangeAspect="1"/>
+          </p:cNvPicPr>
+          <p:nvPr/>
+        </p:nvPicPr>
+        <p:blipFill>
+          <a:blip r:embed="rId21"/>
+          <a:stretch>
+            <a:fillRect/>
+          </a:stretch>
+        </p:blipFill>
+        <p:spPr>
+          <a:xfrm>
+            <a:off x="11251692" y="3698748"/>
+            <a:ext cx="228600" cy="228600"/>
+          </a:xfrm>
+          <a:prstGeom prst="rect">
+            <a:avLst/>
+          </a:prstGeom>
+        </p:spPr>
+      </p:pic>
+      <p:sp>
+        <p:nvSpPr>
+          <p:cNvPr id="107" name="Text 84"/>
+          <p:cNvSpPr/>
+          <p:nvPr/>
+        </p:nvSpPr>
+        <p:spPr>
+          <a:xfrm>
+            <a:off x="10863072" y="4069080"/>
+            <a:ext cx="1005840" cy="329184"/>
+          </a:xfrm>
+          <a:prstGeom prst="rect">
+            <a:avLst/>
+          </a:prstGeom>
+          <a:noFill/>
+          <a:ln/>
+        </p:spPr>
+        <p:txBody>
+          <a:bodyPr wrap="square" lIns="0" tIns="0" rIns="0" bIns="0" rtlCol="0" anchor="t"/>
+          <a:lstStyle/>
+          <a:p>
+            <a:pPr algn="ctr" indent="0" marL="0">
+              <a:lnSpc>
+                <a:spcPct val="90000"/>
+              </a:lnSpc>
+              <a:buNone/>
+            </a:pPr>
+            <a:r>
+              <a:rPr lang="en-US" sz="800" b="1" dirty="0">
+                <a:solidFill>
+                  <a:srgbClr val="3A4A5A"/>
+                </a:solidFill>
+                <a:latin typeface="Calibri" pitchFamily="34" charset="0"/>
+                <a:ea typeface="Calibri" pitchFamily="34" charset="-122"/>
+                <a:cs typeface="Calibri" pitchFamily="34" charset="-120"/>
+              </a:rPr>
+              <a:t>Downstream</a:t>
+            </a:r>
+            <a:endParaRPr lang="en-US" sz="800" dirty="0"/>
+          </a:p>
+          <a:p>
+            <a:pPr algn="ctr" indent="0" marL="0">
+              <a:lnSpc>
+                <a:spcPct val="90000"/>
+              </a:lnSpc>
+              <a:buNone/>
+            </a:pPr>
+            <a:r>
+              <a:rPr lang="en-US" sz="800" b="1" dirty="0">
+                <a:solidFill>
+                  <a:srgbClr val="3A4A5A"/>
+                </a:solidFill>
+                <a:latin typeface="Calibri" pitchFamily="34" charset="0"/>
+                <a:ea typeface="Calibri" pitchFamily="34" charset="-122"/>
+                <a:cs typeface="Calibri" pitchFamily="34" charset="-120"/>
+              </a:rPr>
+              <a:t>Data System</a:t>
+            </a:r>
+            <a:endParaRPr lang="en-US" sz="800" dirty="0"/>
+          </a:p>
+        </p:txBody>
+      </p:sp>
+      <p:sp>
+        <p:nvSpPr>
+          <p:cNvPr id="108" name="Shape 85"/>
+          <p:cNvSpPr/>
+          <p:nvPr/>
+        </p:nvSpPr>
+        <p:spPr>
+          <a:xfrm>
+            <a:off x="1298448" y="2971800"/>
+            <a:ext cx="530352" cy="0"/>
+          </a:xfrm>
+          <a:prstGeom prst="line">
+            <a:avLst/>
+          </a:prstGeom>
+          <a:noFill/>
+          <a:ln w="15875">
+            <a:solidFill>
+              <a:srgbClr val="5B9BD5"/>
+            </a:solidFill>
+            <a:prstDash val="dash"/>
+          </a:ln>
+        </p:spPr>
+      </p:sp>
+      <p:sp>
+        <p:nvSpPr>
+          <p:cNvPr id="109" name="Shape 86"/>
+          <p:cNvSpPr/>
+          <p:nvPr/>
+        </p:nvSpPr>
+        <p:spPr>
+          <a:xfrm>
+            <a:off x="10716768" y="2743200"/>
+            <a:ext cx="128016" cy="0"/>
+          </a:xfrm>
+          <a:prstGeom prst="line">
+            <a:avLst/>
+          </a:prstGeom>
+          <a:noFill/>
+          <a:ln w="15875">
+            <a:solidFill>
+              <a:srgbClr val="F2647A"/>
+            </a:solidFill>
+            <a:prstDash val="dash"/>
+          </a:ln>
+        </p:spPr>
+      </p:sp>
+    </p:spTree>
+  </p:cSld>
+  <p:clrMapOvr>
+    <a:masterClrMapping/>
+  </p:clrMapOvr>
+</p:sld>
+</file>
+
+<file path=ppt/slides/slide5.xml><?xml version="1.0" encoding="utf-8"?>
+<p:sld xmlns:a="http://schemas.openxmlformats.org/drawingml/2006/main" xmlns:r="http://schemas.openxmlformats.org/officeDocument/2006/relationships" xmlns:p="http://schemas.openxmlformats.org/presentationml/2006/main">
+  <p:cSld name="Slide 5">
+    <p:bg>
+      <p:bgPr>
+        <a:solidFill>
+          <a:srgbClr val="FFFFFF"/>
+        </a:solidFill>
+      </p:bgPr>
+    </p:bg>
+    <p:spTree>
+      <p:nvGrpSpPr>
+        <p:cNvPr id="1" name=""/>
+        <p:cNvGrpSpPr/>
+        <p:nvPr/>
+      </p:nvGrpSpPr>
+      <p:grpSpPr>
+        <a:xfrm>
+          <a:off x="0" y="0"/>
+          <a:ext cx="0" cy="0"/>
+          <a:chOff x="0" y="0"/>
+          <a:chExt cx="0" cy="0"/>
+        </a:xfrm>
+      </p:grpSpPr>
+      <p:sp>
+        <p:nvSpPr>
           <p:cNvPr id="2" name="Text 0"/>
           <p:cNvSpPr/>
           <p:nvPr/>
@@ -7086,9 +10514,9 @@
 </p:sld>
 </file>
 
-<file path=ppt/slides/slide5.xml><?xml version="1.0" encoding="utf-8"?>
+<file path=ppt/slides/slide6.xml><?xml version="1.0" encoding="utf-8"?>
 <p:sld xmlns:a="http://schemas.openxmlformats.org/drawingml/2006/main" xmlns:r="http://schemas.openxmlformats.org/officeDocument/2006/relationships" xmlns:p="http://schemas.openxmlformats.org/presentationml/2006/main">
-  <p:cSld name="Slide 5">
+  <p:cSld name="Slide 6">
     <p:bg>
       <p:bgPr>
         <a:solidFill>

</xml_diff>